<commit_message>
Put the baseline, the outrage split and the reversal count in the deck
Adds a slide showing TF-IDF at 0.9758 against the index at 0.6274, retitles
the effect-size slide to say outrage moves both networks, and states that
the reversal count matches the noise model. The builder now reads icons from
assets/icons, where they are, so the editable deck builds again.
</commit_message>
<xml_diff>
--- a/docs/defence/Monarch_Defence.pptx
+++ b/docs/defence/Monarch_Defence.pptx
@@ -33,6 +33,7 @@
     <p:sldId id="281" r:id="rId32"/>
     <p:sldId id="282" r:id="rId33"/>
     <p:sldId id="283" r:id="rId34"/>
+    <p:sldId id="284" r:id="rId35"/>
   </p:sldIdLst>
   <p:sldSz cx="12191695" cy="6858000" type="screen4x3"/>
   <p:notesSz cx="6858000" cy="9144000"/>
@@ -4740,7 +4741,7 @@
                 </a:solidFill>
                 <a:latin typeface="Calibri"/>
               </a:rPr>
-              <a:t>against a design powered to detect 0.0268; AUC against the pre-scan label is 0.6274</a:t>
+              <a:t>against a design powered to detect 0.0268</a:t>
             </a:r>
           </a:p>
         </p:txBody>
@@ -5043,7 +5044,7 @@
                 </a:solidFill>
                 <a:latin typeface="Calibri"/>
               </a:rPr>
-              <a:t>Fear-activating content carries the effect; outrage does not separate</a:t>
+              <a:t>Fear-activating content carries the effect; outrage moves both networks equally</a:t>
             </a:r>
           </a:p>
         </p:txBody>
@@ -5511,13 +5512,13 @@
               </a:spcAft>
             </a:pPr>
             <a:r>
-              <a:rPr sz="2000" b="1" i="0">
+              <a:rPr sz="1900" b="1" i="0">
                 <a:solidFill>
                   <a:srgbClr val="C0392B"/>
                 </a:solidFill>
                 <a:latin typeface="Calibri"/>
               </a:rPr>
-              <a:t>Outrage is the category the proposal expected to separate most, and it does not separate at all.</a:t>
+              <a:t>Outrage is the category the proposal expected to separate most. Taken apart, it raises both networks: affective d = +0.507, deliberative d = +0.491. Fear raises one only.</a:t>
             </a:r>
           </a:p>
         </p:txBody>
@@ -6560,7 +6561,7 @@
       <p:grpSpPr/>
       <p:pic>
         <p:nvPicPr>
-          <p:cNvPr id="2" name="Picture 1" descr="arrows-clockwise.png"/>
+          <p:cNvPr id="2" name="Picture 1" descr="warning.png"/>
           <p:cNvPicPr>
             <a:picLocks noChangeAspect="1"/>
           </p:cNvPicPr>
@@ -6616,7 +6617,7 @@
                 </a:solidFill>
                 <a:latin typeface="Calibri"/>
               </a:rPr>
-              <a:t>Group-level claims hold at this precision; per-item claims do not</a:t>
+              <a:t>A bag of words beats the index on the label, so the index is not a classifier</a:t>
             </a:r>
           </a:p>
         </p:txBody>
@@ -6651,11 +6652,11 @@
             <a:r>
               <a:rPr sz="5400" b="1" i="0">
                 <a:solidFill>
-                  <a:srgbClr val="1F4E79"/>
-                </a:solidFill>
-                <a:latin typeface="Calibri"/>
-              </a:rPr>
-              <a:t>0.8725</a:t>
+                  <a:srgbClr val="595959"/>
+                </a:solidFill>
+                <a:latin typeface="Calibri"/>
+              </a:rPr>
+              <a:t>0.6274</a:t>
             </a:r>
           </a:p>
         </p:txBody>
@@ -6694,7 +6695,7 @@
                 </a:solidFill>
                 <a:latin typeface="Calibri"/>
               </a:rPr>
-              <a:t>ICC between two GPU sessions</a:t>
+              <a:t>AUC, the index, nothing fitted</a:t>
             </a:r>
           </a:p>
         </p:txBody>
@@ -6702,45 +6703,6 @@
       <p:sp>
         <p:nvSpPr>
           <p:cNvPr id="6" name="TextBox 5"/>
-          <p:cNvSpPr txBox="1"/>
-          <p:nvPr/>
-        </p:nvSpPr>
-        <p:spPr>
-          <a:xfrm>
-            <a:off x="685800" y="3154680"/>
-            <a:ext cx="5120640" cy="1371600"/>
-          </a:xfrm>
-          <a:prstGeom prst="rect">
-            <a:avLst/>
-          </a:prstGeom>
-          <a:noFill/>
-        </p:spPr>
-        <p:txBody>
-          <a:bodyPr wrap="square" anchor="t">
-            <a:spAutoFit/>
-          </a:bodyPr>
-          <a:lstStyle/>
-          <a:p>
-            <a:pPr algn="l">
-              <a:spcAft>
-                <a:spcPts val="0"/>
-              </a:spcAft>
-            </a:pPr>
-            <a:r>
-              <a:rPr sz="1700" b="0" i="0">
-                <a:solidFill>
-                  <a:srgbClr val="1A1A1A"/>
-                </a:solidFill>
-                <a:latin typeface="Calibri"/>
-              </a:rPr>
-              <a:t>The separation replicates: 0.0888 on the second session against 0.1068 on the first. Both clear the detectable floor.</a:t>
-            </a:r>
-          </a:p>
-        </p:txBody>
-      </p:sp>
-      <p:sp>
-        <p:nvSpPr>
-          <p:cNvPr id="7" name="TextBox 6"/>
           <p:cNvSpPr txBox="1"/>
           <p:nvPr/>
         </p:nvSpPr>
@@ -6772,14 +6734,14 @@
                 </a:solidFill>
                 <a:latin typeface="Calibri"/>
               </a:rPr>
-              <a:t>12.8%</a:t>
-            </a:r>
-          </a:p>
-        </p:txBody>
-      </p:sp>
-      <p:sp>
-        <p:nvSpPr>
-          <p:cNvPr id="8" name="TextBox 7"/>
+              <a:t>0.9758</a:t>
+            </a:r>
+          </a:p>
+        </p:txBody>
+      </p:sp>
+      <p:sp>
+        <p:nvSpPr>
+          <p:cNvPr id="7" name="TextBox 6"/>
           <p:cNvSpPr txBox="1"/>
           <p:nvPr/>
         </p:nvSpPr>
@@ -6811,7 +6773,46 @@
                 </a:solidFill>
                 <a:latin typeface="Calibri"/>
               </a:rPr>
-              <a:t>of items reverse direction</a:t>
+              <a:t>AUC, TF-IDF + logistic, 5-fold</a:t>
+            </a:r>
+          </a:p>
+        </p:txBody>
+      </p:sp>
+      <p:sp>
+        <p:nvSpPr>
+          <p:cNvPr id="8" name="TextBox 7"/>
+          <p:cNvSpPr txBox="1"/>
+          <p:nvPr/>
+        </p:nvSpPr>
+        <p:spPr>
+          <a:xfrm>
+            <a:off x="685800" y="3246120"/>
+            <a:ext cx="10820095" cy="1463040"/>
+          </a:xfrm>
+          <a:prstGeom prst="rect">
+            <a:avLst/>
+          </a:prstGeom>
+          <a:noFill/>
+        </p:spPr>
+        <p:txBody>
+          <a:bodyPr wrap="square" anchor="t">
+            <a:spAutoFit/>
+          </a:bodyPr>
+          <a:lstStyle/>
+          <a:p>
+            <a:pPr algn="l">
+              <a:spcAft>
+                <a:spcPts val="0"/>
+              </a:spcAft>
+            </a:pPr>
+            <a:r>
+              <a:rPr sz="1700" b="0" i="0">
+                <a:solidFill>
+                  <a:srgbClr val="1A1A1A"/>
+                </a:solidFill>
+                <a:latin typeface="Calibri"/>
+              </a:rPr>
+              <a:t>Same 400 rows, same pre-scan label. Sentiment (VADER) does not clear chance, 0.5392. On the 150 ISOT items, the one source carrying both classes, TF-IDF still reaches 0.9724. A probe on the same words recovers the source dataset at 66.25% against 25% chance, so much of the lexical win is provenance.</a:t>
             </a:r>
           </a:p>
         </p:txBody>
@@ -6824,8 +6825,8 @@
         </p:nvSpPr>
         <p:spPr>
           <a:xfrm>
-            <a:off x="6492240" y="3154680"/>
-            <a:ext cx="5029200" cy="1371600"/>
+            <a:off x="685800" y="4846320"/>
+            <a:ext cx="10820095" cy="731520"/>
           </a:xfrm>
           <a:prstGeom prst="rect">
             <a:avLst/>
@@ -6844,13 +6845,13 @@
               </a:spcAft>
             </a:pPr>
             <a:r>
-              <a:rPr sz="1700" b="0" i="0">
-                <a:solidFill>
-                  <a:srgbClr val="1A1A1A"/>
-                </a:solidFill>
-                <a:latin typeface="Calibri"/>
-              </a:rPr>
-              <a:t>51 of 400 items flip sign between sessions, so no verdict on one article appears anywhere in the analysis, the figures or the public site.</a:t>
+              <a:rPr sz="1900" b="1" i="0">
+                <a:solidFill>
+                  <a:srgbClr val="C0392B"/>
+                </a:solidFill>
+                <a:latin typeface="Calibri"/>
+              </a:rPr>
+              <a:t>The index is carried forward as the field observable the physics needs, not as a detector.</a:t>
             </a:r>
           </a:p>
         </p:txBody>
@@ -6858,45 +6859,6 @@
       <p:sp>
         <p:nvSpPr>
           <p:cNvPr id="10" name="TextBox 9"/>
-          <p:cNvSpPr txBox="1"/>
-          <p:nvPr/>
-        </p:nvSpPr>
-        <p:spPr>
-          <a:xfrm>
-            <a:off x="685800" y="4892040"/>
-            <a:ext cx="10820095" cy="822960"/>
-          </a:xfrm>
-          <a:prstGeom prst="rect">
-            <a:avLst/>
-          </a:prstGeom>
-          <a:noFill/>
-        </p:spPr>
-        <p:txBody>
-          <a:bodyPr wrap="square" anchor="t">
-            <a:spAutoFit/>
-          </a:bodyPr>
-          <a:lstStyle/>
-          <a:p>
-            <a:pPr algn="l">
-              <a:spcAft>
-                <a:spcPts val="0"/>
-              </a:spcAft>
-            </a:pPr>
-            <a:r>
-              <a:rPr sz="1700" b="0" i="0">
-                <a:solidFill>
-                  <a:srgbClr val="595959"/>
-                </a:solidFill>
-                <a:latin typeface="Calibri"/>
-              </a:rPr>
-              <a:t>A second session scanned all 400 items with identical text, code and regions. Neither run is corrected toward the other, and they are not averaged.</a:t>
-            </a:r>
-          </a:p>
-        </p:txBody>
-      </p:sp>
-      <p:sp>
-        <p:nvSpPr>
-          <p:cNvPr id="11" name="TextBox 10"/>
           <p:cNvSpPr txBox="1"/>
           <p:nvPr/>
         </p:nvSpPr>
@@ -6935,7 +6897,7 @@
       </p:sp>
       <p:sp>
         <p:nvSpPr>
-          <p:cNvPr id="12" name="TextBox 11"/>
+          <p:cNvPr id="11" name="TextBox 10"/>
           <p:cNvSpPr txBox="1"/>
           <p:nvPr/>
         </p:nvSpPr>
@@ -6992,7 +6954,7 @@
       <p:grpSpPr/>
       <p:pic>
         <p:nvPicPr>
-          <p:cNvPr id="2" name="Picture 1" descr="brain.png"/>
+          <p:cNvPr id="2" name="Picture 1" descr="arrows-clockwise.png"/>
           <p:cNvPicPr>
             <a:picLocks noChangeAspect="1"/>
           </p:cNvPicPr>
@@ -7048,38 +7010,248 @@
                 </a:solidFill>
                 <a:latin typeface="Calibri"/>
               </a:rPr>
-              <a:t>The encoder returns a full cortical map, not a summary statistic</a:t>
-            </a:r>
-          </a:p>
-        </p:txBody>
-      </p:sp>
-      <p:pic>
-        <p:nvPicPr>
-          <p:cNvPr id="4" name="Picture 3" descr="B3_per_vertex_fear_activating-0000.png"/>
-          <p:cNvPicPr>
-            <a:picLocks noChangeAspect="1"/>
-          </p:cNvPicPr>
-          <p:nvPr/>
-        </p:nvPicPr>
-        <p:blipFill>
-          <a:blip r:embed="rId3"/>
-          <a:stretch>
-            <a:fillRect/>
-          </a:stretch>
-        </p:blipFill>
-        <p:spPr>
-          <a:xfrm>
-            <a:off x="2148840" y="1325880"/>
-            <a:ext cx="7863840" cy="3538728"/>
-          </a:xfrm>
-          <a:prstGeom prst="rect">
-            <a:avLst/>
-          </a:prstGeom>
-        </p:spPr>
-      </p:pic>
+              <a:t>Group-level claims hold at this precision; per-item claims do not</a:t>
+            </a:r>
+          </a:p>
+        </p:txBody>
+      </p:sp>
+      <p:sp>
+        <p:nvSpPr>
+          <p:cNvPr id="4" name="TextBox 3"/>
+          <p:cNvSpPr txBox="1"/>
+          <p:nvPr/>
+        </p:nvSpPr>
+        <p:spPr>
+          <a:xfrm>
+            <a:off x="685800" y="1554480"/>
+            <a:ext cx="5120640" cy="1005840"/>
+          </a:xfrm>
+          <a:prstGeom prst="rect">
+            <a:avLst/>
+          </a:prstGeom>
+          <a:noFill/>
+        </p:spPr>
+        <p:txBody>
+          <a:bodyPr wrap="square" anchor="t">
+            <a:spAutoFit/>
+          </a:bodyPr>
+          <a:lstStyle/>
+          <a:p>
+            <a:pPr algn="ctr">
+              <a:spcAft>
+                <a:spcPts val="0"/>
+              </a:spcAft>
+            </a:pPr>
+            <a:r>
+              <a:rPr sz="5400" b="1" i="0">
+                <a:solidFill>
+                  <a:srgbClr val="1F4E79"/>
+                </a:solidFill>
+                <a:latin typeface="Calibri"/>
+              </a:rPr>
+              <a:t>0.8725</a:t>
+            </a:r>
+          </a:p>
+        </p:txBody>
+      </p:sp>
       <p:sp>
         <p:nvSpPr>
           <p:cNvPr id="5" name="TextBox 4"/>
+          <p:cNvSpPr txBox="1"/>
+          <p:nvPr/>
+        </p:nvSpPr>
+        <p:spPr>
+          <a:xfrm>
+            <a:off x="685800" y="2606040"/>
+            <a:ext cx="5120640" cy="411480"/>
+          </a:xfrm>
+          <a:prstGeom prst="rect">
+            <a:avLst/>
+          </a:prstGeom>
+          <a:noFill/>
+        </p:spPr>
+        <p:txBody>
+          <a:bodyPr wrap="square" anchor="t">
+            <a:spAutoFit/>
+          </a:bodyPr>
+          <a:lstStyle/>
+          <a:p>
+            <a:pPr algn="ctr">
+              <a:spcAft>
+                <a:spcPts val="0"/>
+              </a:spcAft>
+            </a:pPr>
+            <a:r>
+              <a:rPr sz="1600" b="0" i="0">
+                <a:solidFill>
+                  <a:srgbClr val="595959"/>
+                </a:solidFill>
+                <a:latin typeface="Calibri"/>
+              </a:rPr>
+              <a:t>ICC between two GPU sessions</a:t>
+            </a:r>
+          </a:p>
+        </p:txBody>
+      </p:sp>
+      <p:sp>
+        <p:nvSpPr>
+          <p:cNvPr id="6" name="TextBox 5"/>
+          <p:cNvSpPr txBox="1"/>
+          <p:nvPr/>
+        </p:nvSpPr>
+        <p:spPr>
+          <a:xfrm>
+            <a:off x="685800" y="3154680"/>
+            <a:ext cx="5120640" cy="1371600"/>
+          </a:xfrm>
+          <a:prstGeom prst="rect">
+            <a:avLst/>
+          </a:prstGeom>
+          <a:noFill/>
+        </p:spPr>
+        <p:txBody>
+          <a:bodyPr wrap="square" anchor="t">
+            <a:spAutoFit/>
+          </a:bodyPr>
+          <a:lstStyle/>
+          <a:p>
+            <a:pPr algn="l">
+              <a:spcAft>
+                <a:spcPts val="0"/>
+              </a:spcAft>
+            </a:pPr>
+            <a:r>
+              <a:rPr sz="1700" b="0" i="0">
+                <a:solidFill>
+                  <a:srgbClr val="1A1A1A"/>
+                </a:solidFill>
+                <a:latin typeface="Calibri"/>
+              </a:rPr>
+              <a:t>The separation replicates: 0.0888 on the second session against 0.1068 on the first. Both clear the detectable floor.</a:t>
+            </a:r>
+          </a:p>
+        </p:txBody>
+      </p:sp>
+      <p:sp>
+        <p:nvSpPr>
+          <p:cNvPr id="7" name="TextBox 6"/>
+          <p:cNvSpPr txBox="1"/>
+          <p:nvPr/>
+        </p:nvSpPr>
+        <p:spPr>
+          <a:xfrm>
+            <a:off x="6492240" y="1554480"/>
+            <a:ext cx="5029200" cy="1005840"/>
+          </a:xfrm>
+          <a:prstGeom prst="rect">
+            <a:avLst/>
+          </a:prstGeom>
+          <a:noFill/>
+        </p:spPr>
+        <p:txBody>
+          <a:bodyPr wrap="square" anchor="t">
+            <a:spAutoFit/>
+          </a:bodyPr>
+          <a:lstStyle/>
+          <a:p>
+            <a:pPr algn="ctr">
+              <a:spcAft>
+                <a:spcPts val="0"/>
+              </a:spcAft>
+            </a:pPr>
+            <a:r>
+              <a:rPr sz="5400" b="1" i="0">
+                <a:solidFill>
+                  <a:srgbClr val="C0392B"/>
+                </a:solidFill>
+                <a:latin typeface="Calibri"/>
+              </a:rPr>
+              <a:t>12.8%</a:t>
+            </a:r>
+          </a:p>
+        </p:txBody>
+      </p:sp>
+      <p:sp>
+        <p:nvSpPr>
+          <p:cNvPr id="8" name="TextBox 7"/>
+          <p:cNvSpPr txBox="1"/>
+          <p:nvPr/>
+        </p:nvSpPr>
+        <p:spPr>
+          <a:xfrm>
+            <a:off x="6492240" y="2606040"/>
+            <a:ext cx="5029200" cy="411480"/>
+          </a:xfrm>
+          <a:prstGeom prst="rect">
+            <a:avLst/>
+          </a:prstGeom>
+          <a:noFill/>
+        </p:spPr>
+        <p:txBody>
+          <a:bodyPr wrap="square" anchor="t">
+            <a:spAutoFit/>
+          </a:bodyPr>
+          <a:lstStyle/>
+          <a:p>
+            <a:pPr algn="ctr">
+              <a:spcAft>
+                <a:spcPts val="0"/>
+              </a:spcAft>
+            </a:pPr>
+            <a:r>
+              <a:rPr sz="1600" b="0" i="0">
+                <a:solidFill>
+                  <a:srgbClr val="595959"/>
+                </a:solidFill>
+                <a:latin typeface="Calibri"/>
+              </a:rPr>
+              <a:t>of items reverse direction</a:t>
+            </a:r>
+          </a:p>
+        </p:txBody>
+      </p:sp>
+      <p:sp>
+        <p:nvSpPr>
+          <p:cNvPr id="9" name="TextBox 8"/>
+          <p:cNvSpPr txBox="1"/>
+          <p:nvPr/>
+        </p:nvSpPr>
+        <p:spPr>
+          <a:xfrm>
+            <a:off x="6492240" y="3154680"/>
+            <a:ext cx="5029200" cy="1371600"/>
+          </a:xfrm>
+          <a:prstGeom prst="rect">
+            <a:avLst/>
+          </a:prstGeom>
+          <a:noFill/>
+        </p:spPr>
+        <p:txBody>
+          <a:bodyPr wrap="square" anchor="t">
+            <a:spAutoFit/>
+          </a:bodyPr>
+          <a:lstStyle/>
+          <a:p>
+            <a:pPr algn="l">
+              <a:spcAft>
+                <a:spcPts val="0"/>
+              </a:spcAft>
+            </a:pPr>
+            <a:r>
+              <a:rPr sz="1700" b="0" i="0">
+                <a:solidFill>
+                  <a:srgbClr val="1A1A1A"/>
+                </a:solidFill>
+                <a:latin typeface="Calibri"/>
+              </a:rPr>
+              <a:t>51 of 400 items flip sign between sessions, so no verdict on one article appears anywhere in the analysis, the figures or the public site.</a:t>
+            </a:r>
+          </a:p>
+        </p:txBody>
+      </p:sp>
+      <p:sp>
+        <p:nvSpPr>
+          <p:cNvPr id="10" name="TextBox 9"/>
           <p:cNvSpPr txBox="1"/>
           <p:nvPr/>
         </p:nvSpPr>
@@ -7099,26 +7271,26 @@
           </a:bodyPr>
           <a:lstStyle/>
           <a:p>
-            <a:pPr algn="ctr">
-              <a:spcAft>
-                <a:spcPts val="0"/>
-              </a:spcAft>
-            </a:pPr>
-            <a:r>
-              <a:rPr sz="1600" b="0" i="0">
+            <a:pPr algn="l">
+              <a:spcAft>
+                <a:spcPts val="0"/>
+              </a:spcAft>
+            </a:pPr>
+            <a:r>
+              <a:rPr sz="1700" b="0" i="0">
                 <a:solidFill>
                   <a:srgbClr val="595959"/>
                 </a:solidFill>
                 <a:latin typeface="Calibri"/>
               </a:rPr>
-              <a:t>One fear-activating item at all 20,484 vertices, painted above the map's 70th percentile. Nothing is smoothed, interpolated or simulated.</a:t>
-            </a:r>
-          </a:p>
-        </p:txBody>
-      </p:sp>
-      <p:sp>
-        <p:nvSpPr>
-          <p:cNvPr id="6" name="TextBox 5"/>
+              <a:t>Additive noise at the measured session error predicts 55.3 reversals, 95% [44, 67]; 51 are observed. Reversing items sit near zero and spread evenly across categories.</a:t>
+            </a:r>
+          </a:p>
+        </p:txBody>
+      </p:sp>
+      <p:sp>
+        <p:nvSpPr>
+          <p:cNvPr id="11" name="TextBox 10"/>
           <p:cNvSpPr txBox="1"/>
           <p:nvPr/>
         </p:nvSpPr>
@@ -7157,7 +7329,7 @@
       </p:sp>
       <p:sp>
         <p:nvSpPr>
-          <p:cNvPr id="7" name="TextBox 6"/>
+          <p:cNvPr id="12" name="TextBox 11"/>
           <p:cNvSpPr txBox="1"/>
           <p:nvPr/>
         </p:nvSpPr>
@@ -7214,7 +7386,7 @@
       <p:grpSpPr/>
       <p:pic>
         <p:nvPicPr>
-          <p:cNvPr id="2" name="Picture 1" descr="atom.png"/>
+          <p:cNvPr id="2" name="Picture 1" descr="brain.png"/>
           <p:cNvPicPr>
             <a:picLocks noChangeAspect="1"/>
           </p:cNvPicPr>
@@ -7228,8 +7400,8 @@
         </p:blipFill>
         <p:spPr>
           <a:xfrm>
-            <a:off x="1188720" y="2148840"/>
-            <a:ext cx="658368" cy="658368"/>
+            <a:off x="685800" y="365759"/>
+            <a:ext cx="420624" cy="420624"/>
           </a:xfrm>
           <a:prstGeom prst="rect">
             <a:avLst/>
@@ -7244,8 +7416,8 @@
         </p:nvSpPr>
         <p:spPr>
           <a:xfrm>
-            <a:off x="1188720" y="2971800"/>
-            <a:ext cx="8229600" cy="1828800"/>
+            <a:off x="1289304" y="310896"/>
+            <a:ext cx="10216591" cy="822960"/>
           </a:xfrm>
           <a:prstGeom prst="rect">
             <a:avLst/>
@@ -7260,49 +7432,158 @@
           <a:p>
             <a:pPr algn="l">
               <a:spcAft>
-                <a:spcPts val="200"/>
-              </a:spcAft>
-            </a:pPr>
-            <a:r>
-              <a:rPr sz="4000" b="1" i="0">
-                <a:solidFill>
-                  <a:srgbClr val="2E75B6"/>
-                </a:solidFill>
-                <a:latin typeface="Calibri"/>
-              </a:rPr>
-              <a:t>04</a:t>
-            </a:r>
-          </a:p>
-          <a:p>
-            <a:pPr>
-              <a:spcAft>
-                <a:spcPts val="800"/>
-              </a:spcAft>
-            </a:pPr>
-            <a:r>
-              <a:rPr sz="3000" b="1" i="0">
+                <a:spcPts val="0"/>
+              </a:spcAft>
+            </a:pPr>
+            <a:r>
+              <a:rPr sz="2600" b="1" i="0">
                 <a:solidFill>
                   <a:srgbClr val="1F4E79"/>
                 </a:solidFill>
                 <a:latin typeface="Calibri"/>
               </a:rPr>
-              <a:t>The physics</a:t>
-            </a:r>
-          </a:p>
-          <a:p>
-            <a:pPr>
-              <a:spcAft>
-                <a:spcPts val="800"/>
-              </a:spcAft>
-            </a:pPr>
-            <a:r>
-              <a:rPr sz="1700" b="0" i="0">
+              <a:t>The encoder returns a full cortical map, not a summary statistic</a:t>
+            </a:r>
+          </a:p>
+        </p:txBody>
+      </p:sp>
+      <p:pic>
+        <p:nvPicPr>
+          <p:cNvPr id="4" name="Picture 3" descr="B3_per_vertex_fear_activating-0000.png"/>
+          <p:cNvPicPr>
+            <a:picLocks noChangeAspect="1"/>
+          </p:cNvPicPr>
+          <p:nvPr/>
+        </p:nvPicPr>
+        <p:blipFill>
+          <a:blip r:embed="rId3"/>
+          <a:stretch>
+            <a:fillRect/>
+          </a:stretch>
+        </p:blipFill>
+        <p:spPr>
+          <a:xfrm>
+            <a:off x="2148840" y="1325880"/>
+            <a:ext cx="7863840" cy="3538728"/>
+          </a:xfrm>
+          <a:prstGeom prst="rect">
+            <a:avLst/>
+          </a:prstGeom>
+        </p:spPr>
+      </p:pic>
+      <p:sp>
+        <p:nvSpPr>
+          <p:cNvPr id="5" name="TextBox 4"/>
+          <p:cNvSpPr txBox="1"/>
+          <p:nvPr/>
+        </p:nvSpPr>
+        <p:spPr>
+          <a:xfrm>
+            <a:off x="685800" y="4892040"/>
+            <a:ext cx="10820095" cy="822960"/>
+          </a:xfrm>
+          <a:prstGeom prst="rect">
+            <a:avLst/>
+          </a:prstGeom>
+          <a:noFill/>
+        </p:spPr>
+        <p:txBody>
+          <a:bodyPr wrap="square" anchor="t">
+            <a:spAutoFit/>
+          </a:bodyPr>
+          <a:lstStyle/>
+          <a:p>
+            <a:pPr algn="ctr">
+              <a:spcAft>
+                <a:spcPts val="0"/>
+              </a:spcAft>
+            </a:pPr>
+            <a:r>
+              <a:rPr sz="1600" b="0" i="0">
                 <a:solidFill>
                   <a:srgbClr val="595959"/>
                 </a:solidFill>
                 <a:latin typeface="Calibri"/>
               </a:rPr>
-              <a:t>What a measured field is worth.</a:t>
+              <a:t>One fear-activating item at all 20,484 vertices, painted above the map's 70th percentile. Nothing is smoothed, interpolated or simulated.</a:t>
+            </a:r>
+          </a:p>
+        </p:txBody>
+      </p:sp>
+      <p:sp>
+        <p:nvSpPr>
+          <p:cNvPr id="6" name="TextBox 5"/>
+          <p:cNvSpPr txBox="1"/>
+          <p:nvPr/>
+        </p:nvSpPr>
+        <p:spPr>
+          <a:xfrm>
+            <a:off x="685800" y="6291072"/>
+            <a:ext cx="4572000" cy="320040"/>
+          </a:xfrm>
+          <a:prstGeom prst="rect">
+            <a:avLst/>
+          </a:prstGeom>
+          <a:noFill/>
+        </p:spPr>
+        <p:txBody>
+          <a:bodyPr wrap="square" anchor="t">
+            <a:spAutoFit/>
+          </a:bodyPr>
+          <a:lstStyle/>
+          <a:p>
+            <a:pPr algn="l">
+              <a:spcAft>
+                <a:spcPts val="0"/>
+              </a:spcAft>
+            </a:pPr>
+            <a:r>
+              <a:rPr sz="1100" b="0" i="0">
+                <a:solidFill>
+                  <a:srgbClr val="595959"/>
+                </a:solidFill>
+                <a:latin typeface="Calibri"/>
+              </a:rPr>
+              <a:t>The measurement</a:t>
+            </a:r>
+          </a:p>
+        </p:txBody>
+      </p:sp>
+      <p:sp>
+        <p:nvSpPr>
+          <p:cNvPr id="7" name="TextBox 6"/>
+          <p:cNvSpPr txBox="1"/>
+          <p:nvPr/>
+        </p:nvSpPr>
+        <p:spPr>
+          <a:xfrm>
+            <a:off x="10591495" y="6291072"/>
+            <a:ext cx="914400" cy="320040"/>
+          </a:xfrm>
+          <a:prstGeom prst="rect">
+            <a:avLst/>
+          </a:prstGeom>
+          <a:noFill/>
+        </p:spPr>
+        <p:txBody>
+          <a:bodyPr wrap="square" anchor="t">
+            <a:spAutoFit/>
+          </a:bodyPr>
+          <a:lstStyle/>
+          <a:p>
+            <a:pPr algn="r">
+              <a:spcAft>
+                <a:spcPts val="0"/>
+              </a:spcAft>
+            </a:pPr>
+            <a:r>
+              <a:rPr sz="1100" b="0" i="0">
+                <a:solidFill>
+                  <a:srgbClr val="595959"/>
+                </a:solidFill>
+                <a:latin typeface="Calibri"/>
+              </a:rPr>
+              <a:t>19</a:t>
             </a:r>
           </a:p>
         </p:txBody>
@@ -7521,8 +7802,8 @@
         </p:blipFill>
         <p:spPr>
           <a:xfrm>
-            <a:off x="685800" y="365759"/>
-            <a:ext cx="420624" cy="420624"/>
+            <a:off x="1188720" y="2148840"/>
+            <a:ext cx="658368" cy="658368"/>
           </a:xfrm>
           <a:prstGeom prst="rect">
             <a:avLst/>
@@ -7537,8 +7818,8 @@
         </p:nvSpPr>
         <p:spPr>
           <a:xfrm>
-            <a:off x="1289304" y="310896"/>
-            <a:ext cx="10216591" cy="822960"/>
+            <a:off x="1188720" y="2971800"/>
+            <a:ext cx="8229600" cy="1828800"/>
           </a:xfrm>
           <a:prstGeom prst="rect">
             <a:avLst/>
@@ -7553,299 +7834,49 @@
           <a:p>
             <a:pPr algn="l">
               <a:spcAft>
-                <a:spcPts val="0"/>
-              </a:spcAft>
-            </a:pPr>
-            <a:r>
-              <a:rPr sz="2600" b="1" i="0">
+                <a:spcPts val="200"/>
+              </a:spcAft>
+            </a:pPr>
+            <a:r>
+              <a:rPr sz="4000" b="1" i="0">
+                <a:solidFill>
+                  <a:srgbClr val="2E75B6"/>
+                </a:solidFill>
+                <a:latin typeface="Calibri"/>
+              </a:rPr>
+              <a:t>04</a:t>
+            </a:r>
+          </a:p>
+          <a:p>
+            <a:pPr>
+              <a:spcAft>
+                <a:spcPts val="800"/>
+              </a:spcAft>
+            </a:pPr>
+            <a:r>
+              <a:rPr sz="3000" b="1" i="0">
                 <a:solidFill>
                   <a:srgbClr val="1F4E79"/>
                 </a:solidFill>
                 <a:latin typeface="Calibri"/>
               </a:rPr>
-              <a:t>Media enters the mean-field model as a field on the measured observable</a:t>
-            </a:r>
-          </a:p>
-        </p:txBody>
-      </p:sp>
-      <p:sp>
-        <p:nvSpPr>
-          <p:cNvPr id="4" name="TextBox 3"/>
-          <p:cNvSpPr txBox="1"/>
-          <p:nvPr/>
-        </p:nvSpPr>
-        <p:spPr>
-          <a:xfrm>
-            <a:off x="685800" y="1463040"/>
-            <a:ext cx="10820095" cy="914400"/>
-          </a:xfrm>
-          <a:prstGeom prst="rect">
-            <a:avLst/>
-          </a:prstGeom>
-          <a:noFill/>
-        </p:spPr>
-        <p:txBody>
-          <a:bodyPr wrap="square" anchor="t">
-            <a:spAutoFit/>
-          </a:bodyPr>
-          <a:lstStyle/>
-          <a:p>
-            <a:pPr algn="l">
-              <a:spcAft>
-                <a:spcPts val="0"/>
-              </a:spcAft>
-            </a:pPr>
-            <a:r>
-              <a:rPr sz="1900" b="0" i="0">
-                <a:solidFill>
-                  <a:srgbClr val="1A1A1A"/>
-                </a:solidFill>
-                <a:latin typeface="Calibri"/>
-              </a:rPr>
-              <a:t>Each person holds an opinion ±1, is pulled toward their neighbours with strength J, and is pushed by media with field h:</a:t>
-            </a:r>
-          </a:p>
-        </p:txBody>
-      </p:sp>
-      <p:sp>
-        <p:nvSpPr>
-          <p:cNvPr id="5" name="TextBox 4"/>
-          <p:cNvSpPr txBox="1"/>
-          <p:nvPr/>
-        </p:nvSpPr>
-        <p:spPr>
-          <a:xfrm>
-            <a:off x="685800" y="2240280"/>
-            <a:ext cx="10820095" cy="640080"/>
-          </a:xfrm>
-          <a:prstGeom prst="rect">
-            <a:avLst/>
-          </a:prstGeom>
-          <a:noFill/>
-        </p:spPr>
-        <p:txBody>
-          <a:bodyPr wrap="square" anchor="t">
-            <a:spAutoFit/>
-          </a:bodyPr>
-          <a:lstStyle/>
-          <a:p>
-            <a:pPr algn="ctr">
-              <a:spcAft>
-                <a:spcPts val="0"/>
-              </a:spcAft>
-            </a:pPr>
-            <a:r>
-              <a:rPr sz="2600" b="1" i="0">
-                <a:solidFill>
-                  <a:srgbClr val="1F4E79"/>
-                </a:solidFill>
-                <a:latin typeface="Calibri"/>
-              </a:rPr>
-              <a:t>m  =  tanh( βJ m + h ),        h  =  α X</a:t>
-            </a:r>
-          </a:p>
-        </p:txBody>
-      </p:sp>
-      <p:sp>
-        <p:nvSpPr>
-          <p:cNvPr id="6" name="TextBox 5"/>
-          <p:cNvSpPr txBox="1"/>
-          <p:nvPr/>
-        </p:nvSpPr>
-        <p:spPr>
-          <a:xfrm>
-            <a:off x="685800" y="2971800"/>
-            <a:ext cx="10820095" cy="731520"/>
-          </a:xfrm>
-          <a:prstGeom prst="rect">
-            <a:avLst/>
-          </a:prstGeom>
-          <a:noFill/>
-        </p:spPr>
-        <p:txBody>
-          <a:bodyPr wrap="square" anchor="t">
-            <a:spAutoFit/>
-          </a:bodyPr>
-          <a:lstStyle/>
-          <a:p>
-            <a:pPr algn="l">
-              <a:spcAft>
-                <a:spcPts val="0"/>
-              </a:spcAft>
-            </a:pPr>
-            <a:r>
-              <a:rPr sz="1900" b="0" i="0">
-                <a:solidFill>
-                  <a:srgbClr val="1A1A1A"/>
-                </a:solidFill>
-                <a:latin typeface="Calibri"/>
-              </a:rPr>
-              <a:t>where X is the measured observable and α the unknown coupling. Expanding artanh(m) ≈ m + m³/3:</a:t>
-            </a:r>
-          </a:p>
-        </p:txBody>
-      </p:sp>
-      <p:sp>
-        <p:nvSpPr>
-          <p:cNvPr id="7" name="TextBox 6"/>
-          <p:cNvSpPr txBox="1"/>
-          <p:nvPr/>
-        </p:nvSpPr>
-        <p:spPr>
-          <a:xfrm>
-            <a:off x="685800" y="3657600"/>
-            <a:ext cx="10820095" cy="640080"/>
-          </a:xfrm>
-          <a:prstGeom prst="rect">
-            <a:avLst/>
-          </a:prstGeom>
-          <a:noFill/>
-        </p:spPr>
-        <p:txBody>
-          <a:bodyPr wrap="square" anchor="t">
-            <a:spAutoFit/>
-          </a:bodyPr>
-          <a:lstStyle/>
-          <a:p>
-            <a:pPr algn="ctr">
-              <a:spcAft>
-                <a:spcPts val="0"/>
-              </a:spcAft>
-            </a:pPr>
-            <a:r>
-              <a:rPr sz="2400" b="1" i="0">
-                <a:solidFill>
-                  <a:srgbClr val="1F4E79"/>
-                </a:solidFill>
-                <a:latin typeface="Calibri"/>
-              </a:rPr>
-              <a:t>F(m) = a m² + b m⁴ − h m,        a = (1 − βJ)/2,        b = 1/12</a:t>
-            </a:r>
-          </a:p>
-        </p:txBody>
-      </p:sp>
-      <p:sp>
-        <p:nvSpPr>
-          <p:cNvPr id="8" name="TextBox 7"/>
-          <p:cNvSpPr txBox="1"/>
-          <p:nvPr/>
-        </p:nvSpPr>
-        <p:spPr>
-          <a:xfrm>
-            <a:off x="685800" y="4434840"/>
-            <a:ext cx="10820095" cy="1097280"/>
-          </a:xfrm>
-          <a:prstGeom prst="rect">
-            <a:avLst/>
-          </a:prstGeom>
-          <a:noFill/>
-        </p:spPr>
-        <p:txBody>
-          <a:bodyPr wrap="square" anchor="t">
-            <a:spAutoFit/>
-          </a:bodyPr>
-          <a:lstStyle/>
-          <a:p>
-            <a:pPr algn="l">
-              <a:spcAft>
-                <a:spcPts val="0"/>
-              </a:spcAft>
-            </a:pPr>
-            <a:r>
-              <a:rPr sz="1700" b="1">
+              <a:t>The physics</a:t>
+            </a:r>
+          </a:p>
+          <a:p>
+            <a:pPr>
+              <a:spcAft>
+                <a:spcPts val="800"/>
+              </a:spcAft>
+            </a:pPr>
+            <a:r>
+              <a:rPr sz="1700" b="0" i="0">
                 <a:solidFill>
                   <a:srgbClr val="595959"/>
                 </a:solidFill>
                 <a:latin typeface="Calibri"/>
               </a:rPr>
-              <a:t>Coefficients derived from the self-consistency condition. </a:t>
-            </a:r>
-            <a:r>
-              <a:rPr sz="1700" b="0">
-                <a:solidFill>
-                  <a:srgbClr val="595959"/>
-                </a:solidFill>
-                <a:latin typeface="Calibri"/>
-              </a:rPr>
-              <a:t>The proposal carried a = 1 − βJ, b = (βJ)³/3, which do not follow from it. The solver reproduces the exact exponents 1/2, 1 and 3.</a:t>
-            </a:r>
-          </a:p>
-        </p:txBody>
-      </p:sp>
-      <p:sp>
-        <p:nvSpPr>
-          <p:cNvPr id="9" name="TextBox 8"/>
-          <p:cNvSpPr txBox="1"/>
-          <p:nvPr/>
-        </p:nvSpPr>
-        <p:spPr>
-          <a:xfrm>
-            <a:off x="685800" y="6291072"/>
-            <a:ext cx="4572000" cy="320040"/>
-          </a:xfrm>
-          <a:prstGeom prst="rect">
-            <a:avLst/>
-          </a:prstGeom>
-          <a:noFill/>
-        </p:spPr>
-        <p:txBody>
-          <a:bodyPr wrap="square" anchor="t">
-            <a:spAutoFit/>
-          </a:bodyPr>
-          <a:lstStyle/>
-          <a:p>
-            <a:pPr algn="l">
-              <a:spcAft>
-                <a:spcPts val="0"/>
-              </a:spcAft>
-            </a:pPr>
-            <a:r>
-              <a:rPr sz="1100" b="0" i="0">
-                <a:solidFill>
-                  <a:srgbClr val="595959"/>
-                </a:solidFill>
-                <a:latin typeface="Calibri"/>
-              </a:rPr>
-              <a:t>The physics</a:t>
-            </a:r>
-          </a:p>
-        </p:txBody>
-      </p:sp>
-      <p:sp>
-        <p:nvSpPr>
-          <p:cNvPr id="10" name="TextBox 9"/>
-          <p:cNvSpPr txBox="1"/>
-          <p:nvPr/>
-        </p:nvSpPr>
-        <p:spPr>
-          <a:xfrm>
-            <a:off x="10591495" y="6291072"/>
-            <a:ext cx="914400" cy="320040"/>
-          </a:xfrm>
-          <a:prstGeom prst="rect">
-            <a:avLst/>
-          </a:prstGeom>
-          <a:noFill/>
-        </p:spPr>
-        <p:txBody>
-          <a:bodyPr wrap="square" anchor="t">
-            <a:spAutoFit/>
-          </a:bodyPr>
-          <a:lstStyle/>
-          <a:p>
-            <a:pPr algn="r">
-              <a:spcAft>
-                <a:spcPts val="0"/>
-              </a:spcAft>
-            </a:pPr>
-            <a:r>
-              <a:rPr sz="1100" b="0" i="0">
-                <a:solidFill>
-                  <a:srgbClr val="595959"/>
-                </a:solidFill>
-                <a:latin typeface="Calibri"/>
-              </a:rPr>
-              <a:t>20</a:t>
+              <a:t>What a measured field is worth.</a:t>
             </a:r>
           </a:p>
         </p:txBody>
@@ -7870,7 +7901,7 @@
       <p:grpSpPr/>
       <p:pic>
         <p:nvPicPr>
-          <p:cNvPr id="2" name="Picture 1" descr="x-circle.png"/>
+          <p:cNvPr id="2" name="Picture 1" descr="atom.png"/>
           <p:cNvPicPr>
             <a:picLocks noChangeAspect="1"/>
           </p:cNvPicPr>
@@ -7926,7 +7957,7 @@
                 </a:solidFill>
                 <a:latin typeface="Calibri"/>
               </a:rPr>
-              <a:t>The corpus does not identify the coupling, so no value is quoted</a:t>
+              <a:t>Media enters the mean-field model as a field on the measured observable</a:t>
             </a:r>
           </a:p>
         </p:txBody>
@@ -7939,8 +7970,8 @@
         </p:nvSpPr>
         <p:spPr>
           <a:xfrm>
-            <a:off x="685800" y="1600200"/>
-            <a:ext cx="6035040" cy="3291840"/>
+            <a:off x="685800" y="1463040"/>
+            <a:ext cx="10820095" cy="914400"/>
           </a:xfrm>
           <a:prstGeom prst="rect">
             <a:avLst/>
@@ -7955,81 +7986,148 @@
           <a:p>
             <a:pPr algn="l">
               <a:spcAft>
-                <a:spcPts val="1400"/>
-              </a:spcAft>
-            </a:pPr>
-            <a:r>
-              <a:rPr sz="2000" b="1">
+                <a:spcPts val="0"/>
+              </a:spcAft>
+            </a:pPr>
+            <a:r>
+              <a:rPr sz="1900" b="0" i="0">
                 <a:solidFill>
                   <a:srgbClr val="1A1A1A"/>
                 </a:solidFill>
                 <a:latin typeface="Calibri"/>
               </a:rPr>
-              <a:t>What was tried. </a:t>
-            </a:r>
-            <a:r>
-              <a:rPr sz="2000" b="0">
+              <a:t>Each person holds an opinion ±1, is pulled toward their neighbours with strength J, and is pushed by media with field h:</a:t>
+            </a:r>
+          </a:p>
+        </p:txBody>
+      </p:sp>
+      <p:sp>
+        <p:nvSpPr>
+          <p:cNvPr id="5" name="TextBox 4"/>
+          <p:cNvSpPr txBox="1"/>
+          <p:nvPr/>
+        </p:nvSpPr>
+        <p:spPr>
+          <a:xfrm>
+            <a:off x="685800" y="2240280"/>
+            <a:ext cx="10820095" cy="640080"/>
+          </a:xfrm>
+          <a:prstGeom prst="rect">
+            <a:avLst/>
+          </a:prstGeom>
+          <a:noFill/>
+        </p:spPr>
+        <p:txBody>
+          <a:bodyPr wrap="square" anchor="t">
+            <a:spAutoFit/>
+          </a:bodyPr>
+          <a:lstStyle/>
+          <a:p>
+            <a:pPr algn="ctr">
+              <a:spcAft>
+                <a:spcPts val="0"/>
+              </a:spcAft>
+            </a:pPr>
+            <a:r>
+              <a:rPr sz="2600" b="1" i="0">
+                <a:solidFill>
+                  <a:srgbClr val="1F4E79"/>
+                </a:solidFill>
+                <a:latin typeface="Calibri"/>
+              </a:rPr>
+              <a:t>m  =  tanh( βJ m + h ),        h  =  α X</a:t>
+            </a:r>
+          </a:p>
+        </p:txBody>
+      </p:sp>
+      <p:sp>
+        <p:nvSpPr>
+          <p:cNvPr id="6" name="TextBox 5"/>
+          <p:cNvSpPr txBox="1"/>
+          <p:nvPr/>
+        </p:nvSpPr>
+        <p:spPr>
+          <a:xfrm>
+            <a:off x="685800" y="2971800"/>
+            <a:ext cx="10820095" cy="731520"/>
+          </a:xfrm>
+          <a:prstGeom prst="rect">
+            <a:avLst/>
+          </a:prstGeom>
+          <a:noFill/>
+        </p:spPr>
+        <p:txBody>
+          <a:bodyPr wrap="square" anchor="t">
+            <a:spAutoFit/>
+          </a:bodyPr>
+          <a:lstStyle/>
+          <a:p>
+            <a:pPr algn="l">
+              <a:spcAft>
+                <a:spcPts val="0"/>
+              </a:spcAft>
+            </a:pPr>
+            <a:r>
+              <a:rPr sz="1900" b="0" i="0">
                 <a:solidFill>
                   <a:srgbClr val="1A1A1A"/>
                 </a:solidFill>
                 <a:latin typeface="Calibri"/>
               </a:rPr>
-              <a:t>Regress the outcome on the measured index and read off α.</a:t>
-            </a:r>
-          </a:p>
-          <a:p>
-            <a:pPr>
-              <a:spcAft>
-                <a:spcPts val="1400"/>
-              </a:spcAft>
-            </a:pPr>
-            <a:r>
-              <a:rPr sz="2000" b="1">
-                <a:solidFill>
-                  <a:srgbClr val="1A1A1A"/>
-                </a:solidFill>
-                <a:latin typeface="Calibri"/>
-              </a:rPr>
-              <a:t>What happened. </a:t>
-            </a:r>
-            <a:r>
-              <a:rPr sz="2000" b="0">
-                <a:solidFill>
-                  <a:srgbClr val="1A1A1A"/>
-                </a:solidFill>
-                <a:latin typeface="Calibri"/>
-              </a:rPr>
-              <a:t>The fit performs worse than the sample mean out of sample, and the estimate scales inversely with a coupling βJ that no measurement here fixes.</a:t>
-            </a:r>
-          </a:p>
-          <a:p>
-            <a:pPr>
-              <a:spcAft>
-                <a:spcPts val="0"/>
-              </a:spcAft>
-            </a:pPr>
-            <a:r>
-              <a:rPr sz="2000" b="1" i="0">
-                <a:solidFill>
-                  <a:srgbClr val="C0392B"/>
-                </a:solidFill>
-                <a:latin typeface="Calibri"/>
-              </a:rPr>
-              <a:t>So no value of α-hat appears anywhere — not in a table, a caption, or “for illustration”.</a:t>
-            </a:r>
-          </a:p>
-        </p:txBody>
-      </p:sp>
-      <p:sp>
-        <p:nvSpPr>
-          <p:cNvPr id="5" name="TextBox 4"/>
-          <p:cNvSpPr txBox="1"/>
-          <p:nvPr/>
-        </p:nvSpPr>
-        <p:spPr>
-          <a:xfrm>
-            <a:off x="7360920" y="1691640"/>
-            <a:ext cx="4160520" cy="2743200"/>
+              <a:t>where X is the measured observable and α the unknown coupling. Expanding artanh(m) ≈ m + m³/3:</a:t>
+            </a:r>
+          </a:p>
+        </p:txBody>
+      </p:sp>
+      <p:sp>
+        <p:nvSpPr>
+          <p:cNvPr id="7" name="TextBox 6"/>
+          <p:cNvSpPr txBox="1"/>
+          <p:nvPr/>
+        </p:nvSpPr>
+        <p:spPr>
+          <a:xfrm>
+            <a:off x="685800" y="3657600"/>
+            <a:ext cx="10820095" cy="640080"/>
+          </a:xfrm>
+          <a:prstGeom prst="rect">
+            <a:avLst/>
+          </a:prstGeom>
+          <a:noFill/>
+        </p:spPr>
+        <p:txBody>
+          <a:bodyPr wrap="square" anchor="t">
+            <a:spAutoFit/>
+          </a:bodyPr>
+          <a:lstStyle/>
+          <a:p>
+            <a:pPr algn="ctr">
+              <a:spcAft>
+                <a:spcPts val="0"/>
+              </a:spcAft>
+            </a:pPr>
+            <a:r>
+              <a:rPr sz="2400" b="1" i="0">
+                <a:solidFill>
+                  <a:srgbClr val="1F4E79"/>
+                </a:solidFill>
+                <a:latin typeface="Calibri"/>
+              </a:rPr>
+              <a:t>F(m) = a m² + b m⁴ − h m,        a = (1 − βJ)/2,        b = 1/12</a:t>
+            </a:r>
+          </a:p>
+        </p:txBody>
+      </p:sp>
+      <p:sp>
+        <p:nvSpPr>
+          <p:cNvPr id="8" name="TextBox 7"/>
+          <p:cNvSpPr txBox="1"/>
+          <p:nvPr/>
+        </p:nvSpPr>
+        <p:spPr>
+          <a:xfrm>
+            <a:off x="685800" y="4434840"/>
+            <a:ext cx="10820095" cy="1097280"/>
           </a:xfrm>
           <a:prstGeom prst="rect">
             <a:avLst/>
@@ -8044,40 +8142,33 @@
           <a:p>
             <a:pPr algn="l">
               <a:spcAft>
-                <a:spcPts val="1400"/>
-              </a:spcAft>
-            </a:pPr>
-            <a:r>
-              <a:rPr sz="1700" b="0" i="0">
+                <a:spcPts val="0"/>
+              </a:spcAft>
+            </a:pPr>
+            <a:r>
+              <a:rPr sz="1700" b="1">
                 <a:solidFill>
                   <a:srgbClr val="595959"/>
                 </a:solidFill>
                 <a:latin typeface="Calibri"/>
               </a:rPr>
-              <a:t>Reporting an unidentified coupling as though it were measured would be the failure here. Declining to quote it is not.</a:t>
-            </a:r>
-          </a:p>
-          <a:p>
-            <a:pPr>
-              <a:spcAft>
-                <a:spcPts val="0"/>
-              </a:spcAft>
-            </a:pPr>
-            <a:r>
-              <a:rPr sz="1700" b="0" i="0">
+              <a:t>Coefficients derived from the self-consistency condition. </a:t>
+            </a:r>
+            <a:r>
+              <a:rPr sz="1700" b="0">
                 <a:solidFill>
                   <a:srgbClr val="595959"/>
                 </a:solidFill>
                 <a:latin typeface="Calibri"/>
               </a:rPr>
-              <a:t>What replaces it is a statement that does not need the fit at all.</a:t>
-            </a:r>
-          </a:p>
-        </p:txBody>
-      </p:sp>
-      <p:sp>
-        <p:nvSpPr>
-          <p:cNvPr id="6" name="TextBox 5"/>
+              <a:t>The proposal carried a = 1 − βJ, b = (βJ)³/3, which do not follow from it. The solver reproduces the exact exponents 1/2, 1 and 3.</a:t>
+            </a:r>
+          </a:p>
+        </p:txBody>
+      </p:sp>
+      <p:sp>
+        <p:nvSpPr>
+          <p:cNvPr id="9" name="TextBox 8"/>
           <p:cNvSpPr txBox="1"/>
           <p:nvPr/>
         </p:nvSpPr>
@@ -8116,7 +8207,7 @@
       </p:sp>
       <p:sp>
         <p:nvSpPr>
-          <p:cNvPr id="7" name="TextBox 6"/>
+          <p:cNvPr id="10" name="TextBox 9"/>
           <p:cNvSpPr txBox="1"/>
           <p:nvPr/>
         </p:nvSpPr>
@@ -8173,7 +8264,7 @@
       <p:grpSpPr/>
       <p:pic>
         <p:nvPicPr>
-          <p:cNvPr id="2" name="Picture 1" descr="ruler.png"/>
+          <p:cNvPr id="2" name="Picture 1" descr="x-circle.png"/>
           <p:cNvPicPr>
             <a:picLocks noChangeAspect="1"/>
           </p:cNvPicPr>
@@ -8229,35 +8320,100 @@
                 </a:solidFill>
                 <a:latin typeface="Calibri"/>
               </a:rPr>
-              <a:t>Any content observable must clear a bound to drive a transition</a:t>
-            </a:r>
-          </a:p>
-        </p:txBody>
-      </p:sp>
-      <p:pic>
-        <p:nvPicPr>
-          <p:cNvPr id="4" name="Picture 3" descr="F6_alpha_required.png"/>
-          <p:cNvPicPr>
-            <a:picLocks noChangeAspect="1"/>
-          </p:cNvPicPr>
-          <p:nvPr/>
-        </p:nvPicPr>
-        <p:blipFill>
-          <a:blip r:embed="rId3"/>
-          <a:stretch>
-            <a:fillRect/>
-          </a:stretch>
-        </p:blipFill>
-        <p:spPr>
-          <a:xfrm>
-            <a:off x="685800" y="1463040"/>
-            <a:ext cx="4618191" cy="3154680"/>
-          </a:xfrm>
-          <a:prstGeom prst="rect">
-            <a:avLst/>
-          </a:prstGeom>
-        </p:spPr>
-      </p:pic>
+              <a:t>The corpus does not identify the coupling, so no value is quoted</a:t>
+            </a:r>
+          </a:p>
+        </p:txBody>
+      </p:sp>
+      <p:sp>
+        <p:nvSpPr>
+          <p:cNvPr id="4" name="TextBox 3"/>
+          <p:cNvSpPr txBox="1"/>
+          <p:nvPr/>
+        </p:nvSpPr>
+        <p:spPr>
+          <a:xfrm>
+            <a:off x="685800" y="1600200"/>
+            <a:ext cx="6035040" cy="3291840"/>
+          </a:xfrm>
+          <a:prstGeom prst="rect">
+            <a:avLst/>
+          </a:prstGeom>
+          <a:noFill/>
+        </p:spPr>
+        <p:txBody>
+          <a:bodyPr wrap="square" anchor="t">
+            <a:spAutoFit/>
+          </a:bodyPr>
+          <a:lstStyle/>
+          <a:p>
+            <a:pPr algn="l">
+              <a:spcAft>
+                <a:spcPts val="1400"/>
+              </a:spcAft>
+            </a:pPr>
+            <a:r>
+              <a:rPr sz="2000" b="1">
+                <a:solidFill>
+                  <a:srgbClr val="1A1A1A"/>
+                </a:solidFill>
+                <a:latin typeface="Calibri"/>
+              </a:rPr>
+              <a:t>What was tried. </a:t>
+            </a:r>
+            <a:r>
+              <a:rPr sz="2000" b="0">
+                <a:solidFill>
+                  <a:srgbClr val="1A1A1A"/>
+                </a:solidFill>
+                <a:latin typeface="Calibri"/>
+              </a:rPr>
+              <a:t>Regress the outcome on the measured index and read off α.</a:t>
+            </a:r>
+          </a:p>
+          <a:p>
+            <a:pPr>
+              <a:spcAft>
+                <a:spcPts val="1400"/>
+              </a:spcAft>
+            </a:pPr>
+            <a:r>
+              <a:rPr sz="2000" b="1">
+                <a:solidFill>
+                  <a:srgbClr val="1A1A1A"/>
+                </a:solidFill>
+                <a:latin typeface="Calibri"/>
+              </a:rPr>
+              <a:t>What happened. </a:t>
+            </a:r>
+            <a:r>
+              <a:rPr sz="2000" b="0">
+                <a:solidFill>
+                  <a:srgbClr val="1A1A1A"/>
+                </a:solidFill>
+                <a:latin typeface="Calibri"/>
+              </a:rPr>
+              <a:t>The fit performs worse than the sample mean out of sample, and the estimate scales inversely with a coupling βJ that no measurement here fixes.</a:t>
+            </a:r>
+          </a:p>
+          <a:p>
+            <a:pPr>
+              <a:spcAft>
+                <a:spcPts val="0"/>
+              </a:spcAft>
+            </a:pPr>
+            <a:r>
+              <a:rPr sz="2000" b="1" i="0">
+                <a:solidFill>
+                  <a:srgbClr val="C0392B"/>
+                </a:solidFill>
+                <a:latin typeface="Calibri"/>
+              </a:rPr>
+              <a:t>So no value of α-hat appears anywhere — not in a table, a caption, or “for illustration”.</a:t>
+            </a:r>
+          </a:p>
+        </p:txBody>
+      </p:sp>
       <p:sp>
         <p:nvSpPr>
           <p:cNvPr id="5" name="TextBox 4"/>
@@ -8266,51 +8422,49 @@
         </p:nvSpPr>
         <p:spPr>
           <a:xfrm>
-            <a:off x="6720840" y="1737360"/>
-            <a:ext cx="4800600" cy="822960"/>
-          </a:xfrm>
-          <a:prstGeom prst="rect">
-            <a:avLst/>
-          </a:prstGeom>
-          <a:noFill/>
-        </p:spPr>
-        <p:txBody>
-          <a:bodyPr wrap="square" anchor="t">
-            <a:spAutoFit/>
-          </a:bodyPr>
-          <a:lstStyle/>
-          <a:p>
-            <a:pPr algn="ctr">
-              <a:spcAft>
-                <a:spcPts val="0"/>
-              </a:spcAft>
-            </a:pPr>
-            <a:r>
-              <a:rPr sz="3200" b="1">
-                <a:solidFill>
-                  <a:srgbClr val="1F4E79"/>
-                </a:solidFill>
-                <a:latin typeface="Calibri"/>
-              </a:rPr>
-              <a:t>α  ≥  h</a:t>
-            </a:r>
-            <a:r>
-              <a:rPr sz="3200" b="1" baseline="-25000">
-                <a:solidFill>
-                  <a:srgbClr val="1F4E79"/>
-                </a:solidFill>
-                <a:latin typeface="Calibri"/>
-              </a:rPr>
-              <a:t>c</a:t>
-            </a:r>
-            <a:r>
-              <a:rPr sz="3200" b="1">
-                <a:solidFill>
-                  <a:srgbClr val="1F4E79"/>
-                </a:solidFill>
-                <a:latin typeface="Calibri"/>
-              </a:rPr>
-              <a:t>(βJ) / ΔX</a:t>
+            <a:off x="7360920" y="1691640"/>
+            <a:ext cx="4160520" cy="2743200"/>
+          </a:xfrm>
+          <a:prstGeom prst="rect">
+            <a:avLst/>
+          </a:prstGeom>
+          <a:noFill/>
+        </p:spPr>
+        <p:txBody>
+          <a:bodyPr wrap="square" anchor="t">
+            <a:spAutoFit/>
+          </a:bodyPr>
+          <a:lstStyle/>
+          <a:p>
+            <a:pPr algn="l">
+              <a:spcAft>
+                <a:spcPts val="1400"/>
+              </a:spcAft>
+            </a:pPr>
+            <a:r>
+              <a:rPr sz="1700" b="0" i="0">
+                <a:solidFill>
+                  <a:srgbClr val="595959"/>
+                </a:solidFill>
+                <a:latin typeface="Calibri"/>
+              </a:rPr>
+              <a:t>Reporting an unidentified coupling as though it were measured would be the failure here. Declining to quote it is not.</a:t>
+            </a:r>
+          </a:p>
+          <a:p>
+            <a:pPr>
+              <a:spcAft>
+                <a:spcPts val="0"/>
+              </a:spcAft>
+            </a:pPr>
+            <a:r>
+              <a:rPr sz="1700" b="0" i="0">
+                <a:solidFill>
+                  <a:srgbClr val="595959"/>
+                </a:solidFill>
+                <a:latin typeface="Calibri"/>
+              </a:rPr>
+              <a:t>What replaces it is a statement that does not need the fit at all.</a:t>
             </a:r>
           </a:p>
         </p:txBody>
@@ -8318,93 +8472,6 @@
       <p:sp>
         <p:nvSpPr>
           <p:cNvPr id="6" name="TextBox 5"/>
-          <p:cNvSpPr txBox="1"/>
-          <p:nvPr/>
-        </p:nvSpPr>
-        <p:spPr>
-          <a:xfrm>
-            <a:off x="6720840" y="2697480"/>
-            <a:ext cx="4800600" cy="1920240"/>
-          </a:xfrm>
-          <a:prstGeom prst="rect">
-            <a:avLst/>
-          </a:prstGeom>
-          <a:noFill/>
-        </p:spPr>
-        <p:txBody>
-          <a:bodyPr wrap="square" anchor="t">
-            <a:spAutoFit/>
-          </a:bodyPr>
-          <a:lstStyle/>
-          <a:p>
-            <a:pPr algn="l">
-              <a:spcAft>
-                <a:spcPts val="0"/>
-              </a:spcAft>
-            </a:pPr>
-            <a:r>
-              <a:rPr sz="1800" b="0" i="0">
-                <a:solidFill>
-                  <a:srgbClr val="1A1A1A"/>
-                </a:solidFill>
-                <a:latin typeface="Calibri"/>
-              </a:rPr>
-              <a:t>Rather than fitting α and hoping it clears zero, this states what α would have to be for the mechanism to work at all — for any candidate observable, before a corpus exists.</a:t>
-            </a:r>
-          </a:p>
-        </p:txBody>
-      </p:sp>
-      <p:sp>
-        <p:nvSpPr>
-          <p:cNvPr id="7" name="TextBox 6"/>
-          <p:cNvSpPr txBox="1"/>
-          <p:nvPr/>
-        </p:nvSpPr>
-        <p:spPr>
-          <a:xfrm>
-            <a:off x="685800" y="4892040"/>
-            <a:ext cx="10820095" cy="640080"/>
-          </a:xfrm>
-          <a:prstGeom prst="rect">
-            <a:avLst/>
-          </a:prstGeom>
-          <a:noFill/>
-        </p:spPr>
-        <p:txBody>
-          <a:bodyPr wrap="square" anchor="t">
-            <a:spAutoFit/>
-          </a:bodyPr>
-          <a:lstStyle/>
-          <a:p>
-            <a:pPr algn="ctr">
-              <a:spcAft>
-                <a:spcPts val="0"/>
-              </a:spcAft>
-            </a:pPr>
-            <a:r>
-              <a:rPr sz="1800" b="0">
-                <a:solidFill>
-                  <a:srgbClr val="1A1A1A"/>
-                </a:solidFill>
-                <a:latin typeface="Calibri"/>
-              </a:rPr>
-              <a:t>Measured spread ΔX = 0.1241  ⇒  α ≥ 0.169 at βJ = 1.10,   1.655 at 1.50,   </a:t>
-            </a:r>
-            <a:r>
-              <a:rPr sz="1800" b="1">
-                <a:solidFill>
-                  <a:srgbClr val="1F4E79"/>
-                </a:solidFill>
-                <a:latin typeface="Calibri"/>
-              </a:rPr>
-              <a:t>4.294 at 2.00</a:t>
-            </a:r>
-          </a:p>
-        </p:txBody>
-      </p:sp>
-      <p:sp>
-        <p:nvSpPr>
-          <p:cNvPr id="8" name="TextBox 7"/>
           <p:cNvSpPr txBox="1"/>
           <p:nvPr/>
         </p:nvSpPr>
@@ -8443,7 +8510,7 @@
       </p:sp>
       <p:sp>
         <p:nvSpPr>
-          <p:cNvPr id="9" name="TextBox 8"/>
+          <p:cNvPr id="7" name="TextBox 6"/>
           <p:cNvSpPr txBox="1"/>
           <p:nvPr/>
         </p:nvSpPr>
@@ -8500,7 +8567,7 @@
       <p:grpSpPr/>
       <p:pic>
         <p:nvPicPr>
-          <p:cNvPr id="2" name="Picture 1" descr="flag-banner.png"/>
+          <p:cNvPr id="2" name="Picture 1" descr="ruler.png"/>
           <p:cNvPicPr>
             <a:picLocks noChangeAspect="1"/>
           </p:cNvPicPr>
@@ -8514,8 +8581,8 @@
         </p:blipFill>
         <p:spPr>
           <a:xfrm>
-            <a:off x="1188720" y="2148840"/>
-            <a:ext cx="658368" cy="658368"/>
+            <a:off x="685800" y="365759"/>
+            <a:ext cx="420624" cy="420624"/>
           </a:xfrm>
           <a:prstGeom prst="rect">
             <a:avLst/>
@@ -8530,8 +8597,8 @@
         </p:nvSpPr>
         <p:spPr>
           <a:xfrm>
-            <a:off x="1188720" y="2971800"/>
-            <a:ext cx="8229600" cy="1828800"/>
+            <a:off x="1289304" y="310896"/>
+            <a:ext cx="10216591" cy="822960"/>
           </a:xfrm>
           <a:prstGeom prst="rect">
             <a:avLst/>
@@ -8546,49 +8613,263 @@
           <a:p>
             <a:pPr algn="l">
               <a:spcAft>
-                <a:spcPts val="200"/>
-              </a:spcAft>
-            </a:pPr>
-            <a:r>
-              <a:rPr sz="4000" b="1" i="0">
-                <a:solidFill>
-                  <a:srgbClr val="2E75B6"/>
-                </a:solidFill>
-                <a:latin typeface="Calibri"/>
-              </a:rPr>
-              <a:t>05</a:t>
-            </a:r>
-          </a:p>
-          <a:p>
-            <a:pPr>
-              <a:spcAft>
-                <a:spcPts val="800"/>
-              </a:spcAft>
-            </a:pPr>
-            <a:r>
-              <a:rPr sz="3000" b="1" i="0">
+                <a:spcPts val="0"/>
+              </a:spcAft>
+            </a:pPr>
+            <a:r>
+              <a:rPr sz="2600" b="1" i="0">
                 <a:solidFill>
                   <a:srgbClr val="1F4E79"/>
                 </a:solidFill>
                 <a:latin typeface="Calibri"/>
               </a:rPr>
-              <a:t>Standing</a:t>
-            </a:r>
-          </a:p>
-          <a:p>
-            <a:pPr>
-              <a:spcAft>
-                <a:spcPts val="800"/>
-              </a:spcAft>
-            </a:pPr>
-            <a:r>
-              <a:rPr sz="1700" b="0" i="0">
+              <a:t>Any content observable must clear a bound to drive a transition</a:t>
+            </a:r>
+          </a:p>
+        </p:txBody>
+      </p:sp>
+      <p:pic>
+        <p:nvPicPr>
+          <p:cNvPr id="4" name="Picture 3" descr="F6_alpha_required.png"/>
+          <p:cNvPicPr>
+            <a:picLocks noChangeAspect="1"/>
+          </p:cNvPicPr>
+          <p:nvPr/>
+        </p:nvPicPr>
+        <p:blipFill>
+          <a:blip r:embed="rId3"/>
+          <a:stretch>
+            <a:fillRect/>
+          </a:stretch>
+        </p:blipFill>
+        <p:spPr>
+          <a:xfrm>
+            <a:off x="685800" y="1463040"/>
+            <a:ext cx="4618191" cy="3154680"/>
+          </a:xfrm>
+          <a:prstGeom prst="rect">
+            <a:avLst/>
+          </a:prstGeom>
+        </p:spPr>
+      </p:pic>
+      <p:sp>
+        <p:nvSpPr>
+          <p:cNvPr id="5" name="TextBox 4"/>
+          <p:cNvSpPr txBox="1"/>
+          <p:nvPr/>
+        </p:nvSpPr>
+        <p:spPr>
+          <a:xfrm>
+            <a:off x="6720840" y="1737360"/>
+            <a:ext cx="4800600" cy="822960"/>
+          </a:xfrm>
+          <a:prstGeom prst="rect">
+            <a:avLst/>
+          </a:prstGeom>
+          <a:noFill/>
+        </p:spPr>
+        <p:txBody>
+          <a:bodyPr wrap="square" anchor="t">
+            <a:spAutoFit/>
+          </a:bodyPr>
+          <a:lstStyle/>
+          <a:p>
+            <a:pPr algn="ctr">
+              <a:spcAft>
+                <a:spcPts val="0"/>
+              </a:spcAft>
+            </a:pPr>
+            <a:r>
+              <a:rPr sz="3200" b="1">
+                <a:solidFill>
+                  <a:srgbClr val="1F4E79"/>
+                </a:solidFill>
+                <a:latin typeface="Calibri"/>
+              </a:rPr>
+              <a:t>α  ≥  h</a:t>
+            </a:r>
+            <a:r>
+              <a:rPr sz="3200" b="1" baseline="-25000">
+                <a:solidFill>
+                  <a:srgbClr val="1F4E79"/>
+                </a:solidFill>
+                <a:latin typeface="Calibri"/>
+              </a:rPr>
+              <a:t>c</a:t>
+            </a:r>
+            <a:r>
+              <a:rPr sz="3200" b="1">
+                <a:solidFill>
+                  <a:srgbClr val="1F4E79"/>
+                </a:solidFill>
+                <a:latin typeface="Calibri"/>
+              </a:rPr>
+              <a:t>(βJ) / ΔX</a:t>
+            </a:r>
+          </a:p>
+        </p:txBody>
+      </p:sp>
+      <p:sp>
+        <p:nvSpPr>
+          <p:cNvPr id="6" name="TextBox 5"/>
+          <p:cNvSpPr txBox="1"/>
+          <p:nvPr/>
+        </p:nvSpPr>
+        <p:spPr>
+          <a:xfrm>
+            <a:off x="6720840" y="2697480"/>
+            <a:ext cx="4800600" cy="1920240"/>
+          </a:xfrm>
+          <a:prstGeom prst="rect">
+            <a:avLst/>
+          </a:prstGeom>
+          <a:noFill/>
+        </p:spPr>
+        <p:txBody>
+          <a:bodyPr wrap="square" anchor="t">
+            <a:spAutoFit/>
+          </a:bodyPr>
+          <a:lstStyle/>
+          <a:p>
+            <a:pPr algn="l">
+              <a:spcAft>
+                <a:spcPts val="0"/>
+              </a:spcAft>
+            </a:pPr>
+            <a:r>
+              <a:rPr sz="1800" b="0" i="0">
+                <a:solidFill>
+                  <a:srgbClr val="1A1A1A"/>
+                </a:solidFill>
+                <a:latin typeface="Calibri"/>
+              </a:rPr>
+              <a:t>Rather than fitting α and hoping it clears zero, this states what α would have to be for the mechanism to work at all — for any candidate observable, before a corpus exists.</a:t>
+            </a:r>
+          </a:p>
+        </p:txBody>
+      </p:sp>
+      <p:sp>
+        <p:nvSpPr>
+          <p:cNvPr id="7" name="TextBox 6"/>
+          <p:cNvSpPr txBox="1"/>
+          <p:nvPr/>
+        </p:nvSpPr>
+        <p:spPr>
+          <a:xfrm>
+            <a:off x="685800" y="4892040"/>
+            <a:ext cx="10820095" cy="640080"/>
+          </a:xfrm>
+          <a:prstGeom prst="rect">
+            <a:avLst/>
+          </a:prstGeom>
+          <a:noFill/>
+        </p:spPr>
+        <p:txBody>
+          <a:bodyPr wrap="square" anchor="t">
+            <a:spAutoFit/>
+          </a:bodyPr>
+          <a:lstStyle/>
+          <a:p>
+            <a:pPr algn="ctr">
+              <a:spcAft>
+                <a:spcPts val="0"/>
+              </a:spcAft>
+            </a:pPr>
+            <a:r>
+              <a:rPr sz="1800" b="0">
+                <a:solidFill>
+                  <a:srgbClr val="1A1A1A"/>
+                </a:solidFill>
+                <a:latin typeface="Calibri"/>
+              </a:rPr>
+              <a:t>Measured spread ΔX = 0.1241  ⇒  α ≥ 0.169 at βJ = 1.10,   1.655 at 1.50,   </a:t>
+            </a:r>
+            <a:r>
+              <a:rPr sz="1800" b="1">
+                <a:solidFill>
+                  <a:srgbClr val="1F4E79"/>
+                </a:solidFill>
+                <a:latin typeface="Calibri"/>
+              </a:rPr>
+              <a:t>4.294 at 2.00</a:t>
+            </a:r>
+          </a:p>
+        </p:txBody>
+      </p:sp>
+      <p:sp>
+        <p:nvSpPr>
+          <p:cNvPr id="8" name="TextBox 7"/>
+          <p:cNvSpPr txBox="1"/>
+          <p:nvPr/>
+        </p:nvSpPr>
+        <p:spPr>
+          <a:xfrm>
+            <a:off x="685800" y="6291072"/>
+            <a:ext cx="4572000" cy="320040"/>
+          </a:xfrm>
+          <a:prstGeom prst="rect">
+            <a:avLst/>
+          </a:prstGeom>
+          <a:noFill/>
+        </p:spPr>
+        <p:txBody>
+          <a:bodyPr wrap="square" anchor="t">
+            <a:spAutoFit/>
+          </a:bodyPr>
+          <a:lstStyle/>
+          <a:p>
+            <a:pPr algn="l">
+              <a:spcAft>
+                <a:spcPts val="0"/>
+              </a:spcAft>
+            </a:pPr>
+            <a:r>
+              <a:rPr sz="1100" b="0" i="0">
                 <a:solidFill>
                   <a:srgbClr val="595959"/>
                 </a:solidFill>
                 <a:latin typeface="Calibri"/>
               </a:rPr>
-              <a:t>What holds, and what is still open.</a:t>
+              <a:t>The physics</a:t>
+            </a:r>
+          </a:p>
+        </p:txBody>
+      </p:sp>
+      <p:sp>
+        <p:nvSpPr>
+          <p:cNvPr id="9" name="TextBox 8"/>
+          <p:cNvSpPr txBox="1"/>
+          <p:nvPr/>
+        </p:nvSpPr>
+        <p:spPr>
+          <a:xfrm>
+            <a:off x="10591495" y="6291072"/>
+            <a:ext cx="914400" cy="320040"/>
+          </a:xfrm>
+          <a:prstGeom prst="rect">
+            <a:avLst/>
+          </a:prstGeom>
+          <a:noFill/>
+        </p:spPr>
+        <p:txBody>
+          <a:bodyPr wrap="square" anchor="t">
+            <a:spAutoFit/>
+          </a:bodyPr>
+          <a:lstStyle/>
+          <a:p>
+            <a:pPr algn="r">
+              <a:spcAft>
+                <a:spcPts val="0"/>
+              </a:spcAft>
+            </a:pPr>
+            <a:r>
+              <a:rPr sz="1100" b="0" i="0">
+                <a:solidFill>
+                  <a:srgbClr val="595959"/>
+                </a:solidFill>
+                <a:latin typeface="Calibri"/>
+              </a:rPr>
+              <a:t>23</a:t>
             </a:r>
           </a:p>
         </p:txBody>
@@ -8613,7 +8894,7 @@
       <p:grpSpPr/>
       <p:pic>
         <p:nvPicPr>
-          <p:cNvPr id="2" name="Picture 1" descr="target.png"/>
+          <p:cNvPr id="2" name="Picture 1" descr="flag-banner.png"/>
           <p:cNvPicPr>
             <a:picLocks noChangeAspect="1"/>
           </p:cNvPicPr>
@@ -8627,8 +8908,8 @@
         </p:blipFill>
         <p:spPr>
           <a:xfrm>
-            <a:off x="685800" y="365759"/>
-            <a:ext cx="420624" cy="420624"/>
+            <a:off x="1188720" y="2148840"/>
+            <a:ext cx="658368" cy="658368"/>
           </a:xfrm>
           <a:prstGeom prst="rect">
             <a:avLst/>
@@ -8643,8 +8924,8 @@
         </p:nvSpPr>
         <p:spPr>
           <a:xfrm>
-            <a:off x="1289304" y="310896"/>
-            <a:ext cx="10216591" cy="822960"/>
+            <a:off x="1188720" y="2971800"/>
+            <a:ext cx="8229600" cy="1828800"/>
           </a:xfrm>
           <a:prstGeom prst="rect">
             <a:avLst/>
@@ -8659,398 +8940,49 @@
           <a:p>
             <a:pPr algn="l">
               <a:spcAft>
-                <a:spcPts val="0"/>
-              </a:spcAft>
-            </a:pPr>
-            <a:r>
-              <a:rPr sz="2600" b="1" i="0">
+                <a:spcPts val="200"/>
+              </a:spcAft>
+            </a:pPr>
+            <a:r>
+              <a:rPr sz="4000" b="1" i="0">
+                <a:solidFill>
+                  <a:srgbClr val="2E75B6"/>
+                </a:solidFill>
+                <a:latin typeface="Calibri"/>
+              </a:rPr>
+              <a:t>05</a:t>
+            </a:r>
+          </a:p>
+          <a:p>
+            <a:pPr>
+              <a:spcAft>
+                <a:spcPts val="800"/>
+              </a:spcAft>
+            </a:pPr>
+            <a:r>
+              <a:rPr sz="3000" b="1" i="0">
                 <a:solidFill>
                   <a:srgbClr val="1F4E79"/>
                 </a:solidFill>
                 <a:latin typeface="Calibri"/>
               </a:rPr>
-              <a:t>Whether the encoder tracks real cortex is measurable, and one pass remains</a:t>
-            </a:r>
-          </a:p>
-        </p:txBody>
-      </p:sp>
-      <p:sp>
-        <p:nvSpPr>
-          <p:cNvPr id="4" name="TextBox 3"/>
-          <p:cNvSpPr txBox="1"/>
-          <p:nvPr/>
-        </p:nvSpPr>
-        <p:spPr>
-          <a:xfrm>
-            <a:off x="685800" y="1463040"/>
-            <a:ext cx="10820095" cy="914400"/>
-          </a:xfrm>
-          <a:prstGeom prst="rect">
-            <a:avLst/>
-          </a:prstGeom>
-          <a:noFill/>
-        </p:spPr>
-        <p:txBody>
-          <a:bodyPr wrap="square" anchor="t">
-            <a:spAutoFit/>
-          </a:bodyPr>
-          <a:lstStyle/>
-          <a:p>
-            <a:pPr algn="l">
-              <a:spcAft>
-                <a:spcPts val="0"/>
-              </a:spcAft>
-            </a:pPr>
-            <a:r>
-              <a:rPr sz="1900" b="0" i="0">
-                <a:solidFill>
-                  <a:srgbClr val="1A1A1A"/>
-                </a:solidFill>
-                <a:latin typeface="Calibri"/>
-              </a:rPr>
-              <a:t>A commercial lab reports the released checkpoint, in the averaged configuration this project runs, is anti-correlated with real cortex. Four subjects, one stimulus, not independently replicated.</a:t>
-            </a:r>
-          </a:p>
-        </p:txBody>
-      </p:sp>
-      <p:sp>
-        <p:nvSpPr>
-          <p:cNvPr id="5" name="Rounded Rectangle 4"/>
-          <p:cNvSpPr/>
-          <p:nvPr/>
-        </p:nvSpPr>
-        <p:spPr>
-          <a:xfrm>
-            <a:off x="1600200" y="2514600"/>
-            <a:ext cx="4114800" cy="1417320"/>
-          </a:xfrm>
-          <a:prstGeom prst="roundRect">
-            <a:avLst>
-              <a:gd name="adj" fmla="val 6000"/>
-            </a:avLst>
-          </a:prstGeom>
-          <a:solidFill>
-            <a:srgbClr val="FFFFFF"/>
-          </a:solidFill>
-          <a:ln w="15875">
-            <a:solidFill>
-              <a:srgbClr val="D9D9D9"/>
-            </a:solidFill>
-          </a:ln>
-          <a:effectLst/>
-        </p:spPr>
-        <p:style>
-          <a:lnRef idx="1">
-            <a:schemeClr val="accent1"/>
-          </a:lnRef>
-          <a:fillRef idx="3">
-            <a:schemeClr val="accent1"/>
-          </a:fillRef>
-          <a:effectRef idx="2">
-            <a:schemeClr val="accent1"/>
-          </a:effectRef>
-          <a:fontRef idx="minor">
-            <a:schemeClr val="lt1"/>
-          </a:fontRef>
-        </p:style>
-        <p:txBody>
-          <a:bodyPr rtlCol="0" anchor="ctr" wrap="square"/>
-          <a:lstStyle/>
-          <a:p>
-            <a:pPr algn="ctr">
-              <a:spcAft>
-                <a:spcPts val="200"/>
-              </a:spcAft>
-            </a:pPr>
-            <a:r>
-              <a:rPr sz="3000" b="1" i="0">
-                <a:solidFill>
-                  <a:srgbClr val="1F4E79"/>
-                </a:solidFill>
-                <a:latin typeface="Calibri"/>
-              </a:rPr>
-              <a:t>0.1517</a:t>
-            </a:r>
-          </a:p>
-          <a:p>
-            <a:pPr algn="ctr">
-              <a:spcAft>
-                <a:spcPts val="200"/>
-              </a:spcAft>
-            </a:pPr>
-            <a:r>
-              <a:rPr sz="1600" b="0" i="0">
-                <a:solidFill>
-                  <a:srgbClr val="1A1A1A"/>
-                </a:solidFill>
-                <a:latin typeface="Calibri"/>
-              </a:rPr>
-              <a:t>measured noise ceiling</a:t>
-            </a:r>
-          </a:p>
-          <a:p>
-            <a:pPr algn="ctr">
-              <a:spcAft>
-                <a:spcPts val="0"/>
-              </a:spcAft>
-            </a:pPr>
-            <a:r>
-              <a:rPr sz="1200" b="0" i="0">
+              <a:t>Standing</a:t>
+            </a:r>
+          </a:p>
+          <a:p>
+            <a:pPr>
+              <a:spcAft>
+                <a:spcPts val="800"/>
+              </a:spcAft>
+            </a:pPr>
+            <a:r>
+              <a:rPr sz="1700" b="0" i="0">
                 <a:solidFill>
                   <a:srgbClr val="595959"/>
                 </a:solidFill>
                 <a:latin typeface="Calibri"/>
               </a:rPr>
-              <a:t>CI [0.1484, 0.1551], 4 subjects, 1000 parcels</a:t>
-            </a:r>
-          </a:p>
-        </p:txBody>
-      </p:sp>
-      <p:sp>
-        <p:nvSpPr>
-          <p:cNvPr id="6" name="Rounded Rectangle 5"/>
-          <p:cNvSpPr/>
-          <p:nvPr/>
-        </p:nvSpPr>
-        <p:spPr>
-          <a:xfrm>
-            <a:off x="6446520" y="2514600"/>
-            <a:ext cx="4114800" cy="1417320"/>
-          </a:xfrm>
-          <a:prstGeom prst="roundRect">
-            <a:avLst>
-              <a:gd name="adj" fmla="val 6000"/>
-            </a:avLst>
-          </a:prstGeom>
-          <a:solidFill>
-            <a:srgbClr val="FFFFFF"/>
-          </a:solidFill>
-          <a:ln w="15875">
-            <a:solidFill>
-              <a:srgbClr val="D9D9D9"/>
-            </a:solidFill>
-          </a:ln>
-          <a:effectLst/>
-        </p:spPr>
-        <p:style>
-          <a:lnRef idx="1">
-            <a:schemeClr val="accent1"/>
-          </a:lnRef>
-          <a:fillRef idx="3">
-            <a:schemeClr val="accent1"/>
-          </a:fillRef>
-          <a:effectRef idx="2">
-            <a:schemeClr val="accent1"/>
-          </a:effectRef>
-          <a:fontRef idx="minor">
-            <a:schemeClr val="lt1"/>
-          </a:fontRef>
-        </p:style>
-        <p:txBody>
-          <a:bodyPr rtlCol="0" anchor="ctr" wrap="square"/>
-          <a:lstStyle/>
-          <a:p>
-            <a:pPr algn="ctr">
-              <a:spcAft>
-                <a:spcPts val="200"/>
-              </a:spcAft>
-            </a:pPr>
-            <a:r>
-              <a:rPr sz="3000" b="1" i="0">
-                <a:solidFill>
-                  <a:srgbClr val="C0392B"/>
-                </a:solidFill>
-                <a:latin typeface="Calibri"/>
-              </a:rPr>
-              <a:t>0.2247</a:t>
-            </a:r>
-          </a:p>
-          <a:p>
-            <a:pPr algn="ctr">
-              <a:spcAft>
-                <a:spcPts val="200"/>
-              </a:spcAft>
-            </a:pPr>
-            <a:r>
-              <a:rPr sz="1600" b="0" i="0">
-                <a:solidFill>
-                  <a:srgbClr val="1A1A1A"/>
-                </a:solidFill>
-                <a:latin typeface="Calibri"/>
-              </a:rPr>
-              <a:t>withdrawn</a:t>
-            </a:r>
-          </a:p>
-          <a:p>
-            <a:pPr algn="ctr">
-              <a:spcAft>
-                <a:spcPts val="0"/>
-              </a:spcAft>
-            </a:pPr>
-            <a:r>
-              <a:rPr sz="1200" b="0" i="0">
-                <a:solidFill>
-                  <a:srgbClr val="595959"/>
-                </a:solidFill>
-                <a:latin typeface="Calibri"/>
-              </a:rPr>
-              <a:t>an episode picked by position, and a guard that could not fire</a:t>
-            </a:r>
-          </a:p>
-        </p:txBody>
-      </p:sp>
-      <p:sp>
-        <p:nvSpPr>
-          <p:cNvPr id="7" name="TextBox 6"/>
-          <p:cNvSpPr txBox="1"/>
-          <p:nvPr/>
-        </p:nvSpPr>
-        <p:spPr>
-          <a:xfrm>
-            <a:off x="685800" y="4160520"/>
-            <a:ext cx="10820095" cy="914400"/>
-          </a:xfrm>
-          <a:prstGeom prst="rect">
-            <a:avLst/>
-          </a:prstGeom>
-          <a:noFill/>
-        </p:spPr>
-        <p:txBody>
-          <a:bodyPr wrap="square" anchor="t">
-            <a:spAutoFit/>
-          </a:bodyPr>
-          <a:lstStyle/>
-          <a:p>
-            <a:pPr algn="l">
-              <a:spcAft>
-                <a:spcPts val="0"/>
-              </a:spcAft>
-            </a:pPr>
-            <a:r>
-              <a:rPr sz="1900" b="0" i="0">
-                <a:solidFill>
-                  <a:srgbClr val="1A1A1A"/>
-                </a:solidFill>
-                <a:latin typeface="Calibri"/>
-              </a:rPr>
-              <a:t>Replaying the old code path reproduces the wrong number exactly, which proved the cause. Both defects were silent: nothing crashed.</a:t>
-            </a:r>
-          </a:p>
-        </p:txBody>
-      </p:sp>
-      <p:sp>
-        <p:nvSpPr>
-          <p:cNvPr id="8" name="TextBox 7"/>
-          <p:cNvSpPr txBox="1"/>
-          <p:nvPr/>
-        </p:nvSpPr>
-        <p:spPr>
-          <a:xfrm>
-            <a:off x="685800" y="5897880"/>
-            <a:ext cx="10820095" cy="384048"/>
-          </a:xfrm>
-          <a:prstGeom prst="rect">
-            <a:avLst/>
-          </a:prstGeom>
-          <a:noFill/>
-        </p:spPr>
-        <p:txBody>
-          <a:bodyPr wrap="square" anchor="t">
-            <a:spAutoFit/>
-          </a:bodyPr>
-          <a:lstStyle/>
-          <a:p>
-            <a:pPr algn="l">
-              <a:spcAft>
-                <a:spcPts val="0"/>
-              </a:spcAft>
-            </a:pPr>
-            <a:r>
-              <a:rPr sz="1100" b="0" i="0">
-                <a:solidFill>
-                  <a:srgbClr val="595959"/>
-                </a:solidFill>
-                <a:latin typeface="Calibri"/>
-              </a:rPr>
-              <a:t>Schaefer et al. (2018); Algonauts 2025 (CC0); audit self-published, Sapient (2026).</a:t>
-            </a:r>
-          </a:p>
-        </p:txBody>
-      </p:sp>
-      <p:sp>
-        <p:nvSpPr>
-          <p:cNvPr id="9" name="TextBox 8"/>
-          <p:cNvSpPr txBox="1"/>
-          <p:nvPr/>
-        </p:nvSpPr>
-        <p:spPr>
-          <a:xfrm>
-            <a:off x="685800" y="6291072"/>
-            <a:ext cx="4572000" cy="320040"/>
-          </a:xfrm>
-          <a:prstGeom prst="rect">
-            <a:avLst/>
-          </a:prstGeom>
-          <a:noFill/>
-        </p:spPr>
-        <p:txBody>
-          <a:bodyPr wrap="square" anchor="t">
-            <a:spAutoFit/>
-          </a:bodyPr>
-          <a:lstStyle/>
-          <a:p>
-            <a:pPr algn="l">
-              <a:spcAft>
-                <a:spcPts val="0"/>
-              </a:spcAft>
-            </a:pPr>
-            <a:r>
-              <a:rPr sz="1100" b="0" i="0">
-                <a:solidFill>
-                  <a:srgbClr val="595959"/>
-                </a:solidFill>
-                <a:latin typeface="Calibri"/>
-              </a:rPr>
-              <a:t>Standing</a:t>
-            </a:r>
-          </a:p>
-        </p:txBody>
-      </p:sp>
-      <p:sp>
-        <p:nvSpPr>
-          <p:cNvPr id="10" name="TextBox 9"/>
-          <p:cNvSpPr txBox="1"/>
-          <p:nvPr/>
-        </p:nvSpPr>
-        <p:spPr>
-          <a:xfrm>
-            <a:off x="10591495" y="6291072"/>
-            <a:ext cx="914400" cy="320040"/>
-          </a:xfrm>
-          <a:prstGeom prst="rect">
-            <a:avLst/>
-          </a:prstGeom>
-          <a:noFill/>
-        </p:spPr>
-        <p:txBody>
-          <a:bodyPr wrap="square" anchor="t">
-            <a:spAutoFit/>
-          </a:bodyPr>
-          <a:lstStyle/>
-          <a:p>
-            <a:pPr algn="r">
-              <a:spcAft>
-                <a:spcPts val="0"/>
-              </a:spcAft>
-            </a:pPr>
-            <a:r>
-              <a:rPr sz="1100" b="0" i="0">
-                <a:solidFill>
-                  <a:srgbClr val="595959"/>
-                </a:solidFill>
-                <a:latin typeface="Calibri"/>
-              </a:rPr>
-              <a:t>24</a:t>
+              <a:t>What holds, and what is still open.</a:t>
             </a:r>
           </a:p>
         </p:txBody>
@@ -9075,7 +9007,7 @@
       <p:grpSpPr/>
       <p:pic>
         <p:nvPicPr>
-          <p:cNvPr id="2" name="Picture 1" descr="check-circle.png"/>
+          <p:cNvPr id="2" name="Picture 1" descr="target.png"/>
           <p:cNvPicPr>
             <a:picLocks noChangeAspect="1"/>
           </p:cNvPicPr>
@@ -9131,45 +9063,21 @@
                 </a:solidFill>
                 <a:latin typeface="Calibri"/>
               </a:rPr>
-              <a:t>Four claims the work supports, and four it does not</a:t>
-            </a:r>
-          </a:p>
-        </p:txBody>
-      </p:sp>
-      <p:pic>
-        <p:nvPicPr>
-          <p:cNvPr id="4" name="Picture 3" descr="check-circle.png"/>
-          <p:cNvPicPr>
-            <a:picLocks noChangeAspect="1"/>
-          </p:cNvPicPr>
-          <p:nvPr/>
-        </p:nvPicPr>
-        <p:blipFill>
-          <a:blip r:embed="rId2"/>
-          <a:stretch>
-            <a:fillRect/>
-          </a:stretch>
-        </p:blipFill>
-        <p:spPr>
-          <a:xfrm>
-            <a:off x="685800" y="1417320"/>
-            <a:ext cx="310896" cy="310896"/>
-          </a:xfrm>
-          <a:prstGeom prst="rect">
-            <a:avLst/>
-          </a:prstGeom>
-        </p:spPr>
-      </p:pic>
-      <p:sp>
-        <p:nvSpPr>
-          <p:cNvPr id="5" name="TextBox 4"/>
-          <p:cNvSpPr txBox="1"/>
-          <p:nvPr/>
-        </p:nvSpPr>
-        <p:spPr>
-          <a:xfrm>
-            <a:off x="1124712" y="1371600"/>
-            <a:ext cx="4572000" cy="411480"/>
+              <a:t>Whether the encoder tracks real cortex is measurable, and one pass remains</a:t>
+            </a:r>
+          </a:p>
+        </p:txBody>
+      </p:sp>
+      <p:sp>
+        <p:nvSpPr>
+          <p:cNvPr id="4" name="TextBox 3"/>
+          <p:cNvSpPr txBox="1"/>
+          <p:nvPr/>
+        </p:nvSpPr>
+        <p:spPr>
+          <a:xfrm>
+            <a:off x="685800" y="1463040"/>
+            <a:ext cx="10820095" cy="914400"/>
           </a:xfrm>
           <a:prstGeom prst="rect">
             <a:avLst/>
@@ -9188,27 +9096,213 @@
               </a:spcAft>
             </a:pPr>
             <a:r>
-              <a:rPr sz="1700" b="1" i="0">
+              <a:rPr sz="1900" b="0" i="0">
+                <a:solidFill>
+                  <a:srgbClr val="1A1A1A"/>
+                </a:solidFill>
+                <a:latin typeface="Calibri"/>
+              </a:rPr>
+              <a:t>A commercial lab reports the released checkpoint, in the averaged configuration this project runs, is anti-correlated with real cortex. Four subjects, one stimulus, not independently replicated.</a:t>
+            </a:r>
+          </a:p>
+        </p:txBody>
+      </p:sp>
+      <p:sp>
+        <p:nvSpPr>
+          <p:cNvPr id="5" name="Rounded Rectangle 4"/>
+          <p:cNvSpPr/>
+          <p:nvPr/>
+        </p:nvSpPr>
+        <p:spPr>
+          <a:xfrm>
+            <a:off x="1600200" y="2514600"/>
+            <a:ext cx="4114800" cy="1417320"/>
+          </a:xfrm>
+          <a:prstGeom prst="roundRect">
+            <a:avLst>
+              <a:gd name="adj" fmla="val 6000"/>
+            </a:avLst>
+          </a:prstGeom>
+          <a:solidFill>
+            <a:srgbClr val="FFFFFF"/>
+          </a:solidFill>
+          <a:ln w="15875">
+            <a:solidFill>
+              <a:srgbClr val="D9D9D9"/>
+            </a:solidFill>
+          </a:ln>
+          <a:effectLst/>
+        </p:spPr>
+        <p:style>
+          <a:lnRef idx="1">
+            <a:schemeClr val="accent1"/>
+          </a:lnRef>
+          <a:fillRef idx="3">
+            <a:schemeClr val="accent1"/>
+          </a:fillRef>
+          <a:effectRef idx="2">
+            <a:schemeClr val="accent1"/>
+          </a:effectRef>
+          <a:fontRef idx="minor">
+            <a:schemeClr val="lt1"/>
+          </a:fontRef>
+        </p:style>
+        <p:txBody>
+          <a:bodyPr rtlCol="0" anchor="ctr" wrap="square"/>
+          <a:lstStyle/>
+          <a:p>
+            <a:pPr algn="ctr">
+              <a:spcAft>
+                <a:spcPts val="200"/>
+              </a:spcAft>
+            </a:pPr>
+            <a:r>
+              <a:rPr sz="3000" b="1" i="0">
                 <a:solidFill>
                   <a:srgbClr val="1F4E79"/>
                 </a:solidFill>
                 <a:latin typeface="Calibri"/>
               </a:rPr>
-              <a:t>SUPPORTED</a:t>
-            </a:r>
-          </a:p>
-        </p:txBody>
-      </p:sp>
-      <p:sp>
-        <p:nvSpPr>
-          <p:cNvPr id="6" name="TextBox 5"/>
-          <p:cNvSpPr txBox="1"/>
-          <p:nvPr/>
-        </p:nvSpPr>
-        <p:spPr>
-          <a:xfrm>
-            <a:off x="685800" y="1920240"/>
-            <a:ext cx="5120640" cy="3291840"/>
+              <a:t>0.1517</a:t>
+            </a:r>
+          </a:p>
+          <a:p>
+            <a:pPr algn="ctr">
+              <a:spcAft>
+                <a:spcPts val="200"/>
+              </a:spcAft>
+            </a:pPr>
+            <a:r>
+              <a:rPr sz="1600" b="0" i="0">
+                <a:solidFill>
+                  <a:srgbClr val="1A1A1A"/>
+                </a:solidFill>
+                <a:latin typeface="Calibri"/>
+              </a:rPr>
+              <a:t>measured noise ceiling</a:t>
+            </a:r>
+          </a:p>
+          <a:p>
+            <a:pPr algn="ctr">
+              <a:spcAft>
+                <a:spcPts val="0"/>
+              </a:spcAft>
+            </a:pPr>
+            <a:r>
+              <a:rPr sz="1200" b="0" i="0">
+                <a:solidFill>
+                  <a:srgbClr val="595959"/>
+                </a:solidFill>
+                <a:latin typeface="Calibri"/>
+              </a:rPr>
+              <a:t>CI [0.1484, 0.1551], 4 subjects, 1000 parcels</a:t>
+            </a:r>
+          </a:p>
+        </p:txBody>
+      </p:sp>
+      <p:sp>
+        <p:nvSpPr>
+          <p:cNvPr id="6" name="Rounded Rectangle 5"/>
+          <p:cNvSpPr/>
+          <p:nvPr/>
+        </p:nvSpPr>
+        <p:spPr>
+          <a:xfrm>
+            <a:off x="6446520" y="2514600"/>
+            <a:ext cx="4114800" cy="1417320"/>
+          </a:xfrm>
+          <a:prstGeom prst="roundRect">
+            <a:avLst>
+              <a:gd name="adj" fmla="val 6000"/>
+            </a:avLst>
+          </a:prstGeom>
+          <a:solidFill>
+            <a:srgbClr val="FFFFFF"/>
+          </a:solidFill>
+          <a:ln w="15875">
+            <a:solidFill>
+              <a:srgbClr val="D9D9D9"/>
+            </a:solidFill>
+          </a:ln>
+          <a:effectLst/>
+        </p:spPr>
+        <p:style>
+          <a:lnRef idx="1">
+            <a:schemeClr val="accent1"/>
+          </a:lnRef>
+          <a:fillRef idx="3">
+            <a:schemeClr val="accent1"/>
+          </a:fillRef>
+          <a:effectRef idx="2">
+            <a:schemeClr val="accent1"/>
+          </a:effectRef>
+          <a:fontRef idx="minor">
+            <a:schemeClr val="lt1"/>
+          </a:fontRef>
+        </p:style>
+        <p:txBody>
+          <a:bodyPr rtlCol="0" anchor="ctr" wrap="square"/>
+          <a:lstStyle/>
+          <a:p>
+            <a:pPr algn="ctr">
+              <a:spcAft>
+                <a:spcPts val="200"/>
+              </a:spcAft>
+            </a:pPr>
+            <a:r>
+              <a:rPr sz="3000" b="1" i="0">
+                <a:solidFill>
+                  <a:srgbClr val="C0392B"/>
+                </a:solidFill>
+                <a:latin typeface="Calibri"/>
+              </a:rPr>
+              <a:t>0.2247</a:t>
+            </a:r>
+          </a:p>
+          <a:p>
+            <a:pPr algn="ctr">
+              <a:spcAft>
+                <a:spcPts val="200"/>
+              </a:spcAft>
+            </a:pPr>
+            <a:r>
+              <a:rPr sz="1600" b="0" i="0">
+                <a:solidFill>
+                  <a:srgbClr val="1A1A1A"/>
+                </a:solidFill>
+                <a:latin typeface="Calibri"/>
+              </a:rPr>
+              <a:t>withdrawn</a:t>
+            </a:r>
+          </a:p>
+          <a:p>
+            <a:pPr algn="ctr">
+              <a:spcAft>
+                <a:spcPts val="0"/>
+              </a:spcAft>
+            </a:pPr>
+            <a:r>
+              <a:rPr sz="1200" b="0" i="0">
+                <a:solidFill>
+                  <a:srgbClr val="595959"/>
+                </a:solidFill>
+                <a:latin typeface="Calibri"/>
+              </a:rPr>
+              <a:t>an episode picked by position, and a guard that could not fire</a:t>
+            </a:r>
+          </a:p>
+        </p:txBody>
+      </p:sp>
+      <p:sp>
+        <p:nvSpPr>
+          <p:cNvPr id="7" name="TextBox 6"/>
+          <p:cNvSpPr txBox="1"/>
+          <p:nvPr/>
+        </p:nvSpPr>
+        <p:spPr>
+          <a:xfrm>
+            <a:off x="685800" y="4160520"/>
+            <a:ext cx="10820095" cy="914400"/>
           </a:xfrm>
           <a:prstGeom prst="rect">
             <a:avLst/>
@@ -9223,93 +9317,21 @@
           <a:p>
             <a:pPr algn="l">
               <a:spcAft>
-                <a:spcPts val="1200"/>
-              </a:spcAft>
-            </a:pPr>
-            <a:r>
-              <a:rPr sz="1700" b="0" i="0">
+                <a:spcPts val="0"/>
+              </a:spcAft>
+            </a:pPr>
+            <a:r>
+              <a:rPr sz="1900" b="0" i="0">
                 <a:solidFill>
                   <a:srgbClr val="1A1A1A"/>
                 </a:solidFill>
                 <a:latin typeface="Calibri"/>
               </a:rPr>
-              <a:t>•  A content observable that can be measured, with its reliability stated.</a:t>
-            </a:r>
-          </a:p>
-          <a:p>
-            <a:pPr>
-              <a:spcAft>
-                <a:spcPts val="1200"/>
-              </a:spcAft>
-            </a:pPr>
-            <a:r>
-              <a:rPr sz="1700" b="0" i="0">
-                <a:solidFill>
-                  <a:srgbClr val="1A1A1A"/>
-                </a:solidFill>
-                <a:latin typeface="Calibri"/>
-              </a:rPr>
-              <a:t>•  That it separates these four corpora at 0.1068, power attached.</a:t>
-            </a:r>
-          </a:p>
-          <a:p>
-            <a:pPr>
-              <a:spcAft>
-                <a:spcPts val="1200"/>
-              </a:spcAft>
-            </a:pPr>
-            <a:r>
-              <a:rPr sz="1700" b="0" i="0">
-                <a:solidFill>
-                  <a:srgbClr val="1A1A1A"/>
-                </a:solidFill>
-                <a:latin typeface="Calibri"/>
-              </a:rPr>
-              <a:t>•  A bound any candidate observable must satisfy, usable before data exists.</a:t>
-            </a:r>
-          </a:p>
-          <a:p>
-            <a:pPr>
-              <a:spcAft>
-                <a:spcPts val="1200"/>
-              </a:spcAft>
-            </a:pPr>
-            <a:r>
-              <a:rPr sz="1700" b="0" i="0">
-                <a:solidFill>
-                  <a:srgbClr val="1A1A1A"/>
-                </a:solidFill>
-                <a:latin typeface="Calibri"/>
-              </a:rPr>
-              <a:t>•  A measured noise ceiling for the checkpoint on public data.</a:t>
-            </a:r>
-          </a:p>
-        </p:txBody>
-      </p:sp>
-      <p:pic>
-        <p:nvPicPr>
-          <p:cNvPr id="7" name="Picture 6" descr="x-circle.png"/>
-          <p:cNvPicPr>
-            <a:picLocks noChangeAspect="1"/>
-          </p:cNvPicPr>
-          <p:nvPr/>
-        </p:nvPicPr>
-        <p:blipFill>
-          <a:blip r:embed="rId3"/>
-          <a:stretch>
-            <a:fillRect/>
-          </a:stretch>
-        </p:blipFill>
-        <p:spPr>
-          <a:xfrm>
-            <a:off x="6492240" y="1417320"/>
-            <a:ext cx="310896" cy="310896"/>
-          </a:xfrm>
-          <a:prstGeom prst="rect">
-            <a:avLst/>
-          </a:prstGeom>
-        </p:spPr>
-      </p:pic>
+              <a:t>Replaying the old code path reproduces the wrong number exactly, which proved the cause. Both defects were silent: nothing crashed.</a:t>
+            </a:r>
+          </a:p>
+        </p:txBody>
+      </p:sp>
       <p:sp>
         <p:nvSpPr>
           <p:cNvPr id="8" name="TextBox 7"/>
@@ -9318,8 +9340,8 @@
         </p:nvSpPr>
         <p:spPr>
           <a:xfrm>
-            <a:off x="6931152" y="1371600"/>
-            <a:ext cx="4572000" cy="411480"/>
+            <a:off x="685800" y="5897880"/>
+            <a:ext cx="10820095" cy="384048"/>
           </a:xfrm>
           <a:prstGeom prst="rect">
             <a:avLst/>
@@ -9338,13 +9360,13 @@
               </a:spcAft>
             </a:pPr>
             <a:r>
-              <a:rPr sz="1700" b="1" i="0">
-                <a:solidFill>
-                  <a:srgbClr val="C0392B"/>
-                </a:solidFill>
-                <a:latin typeface="Calibri"/>
-              </a:rPr>
-              <a:t>NOT SUPPORTED</a:t>
+              <a:rPr sz="1100" b="0" i="0">
+                <a:solidFill>
+                  <a:srgbClr val="595959"/>
+                </a:solidFill>
+                <a:latin typeface="Calibri"/>
+              </a:rPr>
+              <a:t>Schaefer et al. (2018); Algonauts 2025 (CC0); audit self-published, Sapient (2026).</a:t>
             </a:r>
           </a:p>
         </p:txBody>
@@ -9352,93 +9374,6 @@
       <p:sp>
         <p:nvSpPr>
           <p:cNvPr id="9" name="TextBox 8"/>
-          <p:cNvSpPr txBox="1"/>
-          <p:nvPr/>
-        </p:nvSpPr>
-        <p:spPr>
-          <a:xfrm>
-            <a:off x="6492240" y="1920240"/>
-            <a:ext cx="5029200" cy="3291840"/>
-          </a:xfrm>
-          <a:prstGeom prst="rect">
-            <a:avLst/>
-          </a:prstGeom>
-          <a:noFill/>
-        </p:spPr>
-        <p:txBody>
-          <a:bodyPr wrap="square" anchor="t">
-            <a:spAutoFit/>
-          </a:bodyPr>
-          <a:lstStyle/>
-          <a:p>
-            <a:pPr algn="l">
-              <a:spcAft>
-                <a:spcPts val="1200"/>
-              </a:spcAft>
-            </a:pPr>
-            <a:r>
-              <a:rPr sz="1700" b="0" i="0">
-                <a:solidFill>
-                  <a:srgbClr val="1A1A1A"/>
-                </a:solidFill>
-                <a:latin typeface="Calibri"/>
-              </a:rPr>
-              <a:t>•  That the index detects manipulation. Category is confounded with source.</a:t>
-            </a:r>
-          </a:p>
-          <a:p>
-            <a:pPr>
-              <a:spcAft>
-                <a:spcPts val="1200"/>
-              </a:spcAft>
-            </a:pPr>
-            <a:r>
-              <a:rPr sz="1700" b="0" i="0">
-                <a:solidFill>
-                  <a:srgbClr val="1A1A1A"/>
-                </a:solidFill>
-                <a:latin typeface="Calibri"/>
-              </a:rPr>
-              <a:t>•  Anything about the amygdala. The checkpoint does not predict it.</a:t>
-            </a:r>
-          </a:p>
-          <a:p>
-            <a:pPr>
-              <a:spcAft>
-                <a:spcPts val="1200"/>
-              </a:spcAft>
-            </a:pPr>
-            <a:r>
-              <a:rPr sz="1700" b="0" i="0">
-                <a:solidFill>
-                  <a:srgbClr val="1A1A1A"/>
-                </a:solidFill>
-                <a:latin typeface="Calibri"/>
-              </a:rPr>
-              <a:t>•  Any value of the coupling α. The corpus does not identify it.</a:t>
-            </a:r>
-          </a:p>
-          <a:p>
-            <a:pPr>
-              <a:spcAft>
-                <a:spcPts val="1200"/>
-              </a:spcAft>
-            </a:pPr>
-            <a:r>
-              <a:rPr sz="1700" b="0" i="0">
-                <a:solidFill>
-                  <a:srgbClr val="1A1A1A"/>
-                </a:solidFill>
-                <a:latin typeface="Calibri"/>
-              </a:rPr>
-              <a:t>•  Any verdict on one article. 12.8% reverse between sessions.</a:t>
-            </a:r>
-          </a:p>
-        </p:txBody>
-      </p:sp>
-      <p:sp>
-        <p:nvSpPr>
-          <p:cNvPr id="10" name="TextBox 9"/>
           <p:cNvSpPr txBox="1"/>
           <p:nvPr/>
         </p:nvSpPr>
@@ -9477,7 +9412,7 @@
       </p:sp>
       <p:sp>
         <p:nvSpPr>
-          <p:cNvPr id="11" name="TextBox 10"/>
+          <p:cNvPr id="10" name="TextBox 9"/>
           <p:cNvSpPr txBox="1"/>
           <p:nvPr/>
         </p:nvSpPr>
@@ -9534,7 +9469,7 @@
       <p:grpSpPr/>
       <p:pic>
         <p:nvPicPr>
-          <p:cNvPr id="2" name="Picture 1" descr="books.png"/>
+          <p:cNvPr id="2" name="Picture 1" descr="check-circle.png"/>
           <p:cNvPicPr>
             <a:picLocks noChangeAspect="1"/>
           </p:cNvPicPr>
@@ -9590,21 +9525,45 @@
                 </a:solidFill>
                 <a:latin typeface="Calibri"/>
               </a:rPr>
-              <a:t>The work yields a dissertation and three papers</a:t>
-            </a:r>
-          </a:p>
-        </p:txBody>
-      </p:sp>
-      <p:sp>
-        <p:nvSpPr>
-          <p:cNvPr id="4" name="TextBox 3"/>
-          <p:cNvSpPr txBox="1"/>
-          <p:nvPr/>
-        </p:nvSpPr>
-        <p:spPr>
-          <a:xfrm>
-            <a:off x="685800" y="1554480"/>
-            <a:ext cx="2606040" cy="2743200"/>
+              <a:t>Four claims the work supports, and four it does not</a:t>
+            </a:r>
+          </a:p>
+        </p:txBody>
+      </p:sp>
+      <p:pic>
+        <p:nvPicPr>
+          <p:cNvPr id="4" name="Picture 3" descr="check-circle.png"/>
+          <p:cNvPicPr>
+            <a:picLocks noChangeAspect="1"/>
+          </p:cNvPicPr>
+          <p:nvPr/>
+        </p:nvPicPr>
+        <p:blipFill>
+          <a:blip r:embed="rId2"/>
+          <a:stretch>
+            <a:fillRect/>
+          </a:stretch>
+        </p:blipFill>
+        <p:spPr>
+          <a:xfrm>
+            <a:off x="685800" y="1417320"/>
+            <a:ext cx="310896" cy="310896"/>
+          </a:xfrm>
+          <a:prstGeom prst="rect">
+            <a:avLst/>
+          </a:prstGeom>
+        </p:spPr>
+      </p:pic>
+      <p:sp>
+        <p:nvSpPr>
+          <p:cNvPr id="5" name="TextBox 4"/>
+          <p:cNvSpPr txBox="1"/>
+          <p:nvPr/>
+        </p:nvSpPr>
+        <p:spPr>
+          <a:xfrm>
+            <a:off x="1124712" y="1371600"/>
+            <a:ext cx="4572000" cy="411480"/>
           </a:xfrm>
           <a:prstGeom prst="rect">
             <a:avLst/>
@@ -9619,63 +9578,142 @@
           <a:p>
             <a:pPr algn="l">
               <a:spcAft>
-                <a:spcPts val="400"/>
-              </a:spcAft>
-            </a:pPr>
-            <a:r>
-              <a:rPr sz="2200" b="1" i="0">
-                <a:solidFill>
-                  <a:srgbClr val="2E75B6"/>
-                </a:solidFill>
-                <a:latin typeface="Calibri"/>
-              </a:rPr>
-              <a:t>72 pp</a:t>
+                <a:spcPts val="0"/>
+              </a:spcAft>
+            </a:pPr>
+            <a:r>
+              <a:rPr sz="1700" b="1" i="0">
+                <a:solidFill>
+                  <a:srgbClr val="1F4E79"/>
+                </a:solidFill>
+                <a:latin typeface="Calibri"/>
+              </a:rPr>
+              <a:t>SUPPORTED</a:t>
+            </a:r>
+          </a:p>
+        </p:txBody>
+      </p:sp>
+      <p:sp>
+        <p:nvSpPr>
+          <p:cNvPr id="6" name="TextBox 5"/>
+          <p:cNvSpPr txBox="1"/>
+          <p:nvPr/>
+        </p:nvSpPr>
+        <p:spPr>
+          <a:xfrm>
+            <a:off x="685800" y="1920240"/>
+            <a:ext cx="5120640" cy="3291840"/>
+          </a:xfrm>
+          <a:prstGeom prst="rect">
+            <a:avLst/>
+          </a:prstGeom>
+          <a:noFill/>
+        </p:spPr>
+        <p:txBody>
+          <a:bodyPr wrap="square" anchor="t">
+            <a:spAutoFit/>
+          </a:bodyPr>
+          <a:lstStyle/>
+          <a:p>
+            <a:pPr algn="l">
+              <a:spcAft>
+                <a:spcPts val="1200"/>
+              </a:spcAft>
+            </a:pPr>
+            <a:r>
+              <a:rPr sz="1700" b="0" i="0">
+                <a:solidFill>
+                  <a:srgbClr val="1A1A1A"/>
+                </a:solidFill>
+                <a:latin typeface="Calibri"/>
+              </a:rPr>
+              <a:t>•  A content observable that can be measured, with its reliability stated.</a:t>
             </a:r>
           </a:p>
           <a:p>
             <a:pPr>
               <a:spcAft>
-                <a:spcPts val="800"/>
-              </a:spcAft>
-            </a:pPr>
-            <a:r>
-              <a:rPr sz="2000" b="1" i="0">
+                <a:spcPts val="1200"/>
+              </a:spcAft>
+            </a:pPr>
+            <a:r>
+              <a:rPr sz="1700" b="0" i="0">
                 <a:solidFill>
                   <a:srgbClr val="1A1A1A"/>
                 </a:solidFill>
                 <a:latin typeface="Calibri"/>
               </a:rPr>
-              <a:t>Dissertation</a:t>
+              <a:t>•  That it separates these four corpora at 0.1068, power attached.</a:t>
             </a:r>
           </a:p>
           <a:p>
             <a:pPr>
               <a:spcAft>
-                <a:spcPts val="0"/>
-              </a:spcAft>
-            </a:pPr>
-            <a:r>
-              <a:rPr sz="1500" b="0" i="0">
-                <a:solidFill>
-                  <a:srgbClr val="595959"/>
-                </a:solidFill>
-                <a:latin typeface="Calibri"/>
-              </a:rPr>
-              <a:t>Complete draft.</a:t>
-            </a:r>
-          </a:p>
-        </p:txBody>
-      </p:sp>
-      <p:sp>
-        <p:nvSpPr>
-          <p:cNvPr id="5" name="TextBox 4"/>
-          <p:cNvSpPr txBox="1"/>
-          <p:nvPr/>
-        </p:nvSpPr>
-        <p:spPr>
-          <a:xfrm>
-            <a:off x="3584448" y="1554480"/>
-            <a:ext cx="2606040" cy="2743200"/>
+                <a:spcPts val="1200"/>
+              </a:spcAft>
+            </a:pPr>
+            <a:r>
+              <a:rPr sz="1700" b="0" i="0">
+                <a:solidFill>
+                  <a:srgbClr val="1A1A1A"/>
+                </a:solidFill>
+                <a:latin typeface="Calibri"/>
+              </a:rPr>
+              <a:t>•  A bound any candidate observable must satisfy, usable before data exists.</a:t>
+            </a:r>
+          </a:p>
+          <a:p>
+            <a:pPr>
+              <a:spcAft>
+                <a:spcPts val="1200"/>
+              </a:spcAft>
+            </a:pPr>
+            <a:r>
+              <a:rPr sz="1700" b="0" i="0">
+                <a:solidFill>
+                  <a:srgbClr val="1A1A1A"/>
+                </a:solidFill>
+                <a:latin typeface="Calibri"/>
+              </a:rPr>
+              <a:t>•  A measured noise ceiling for the checkpoint on public data.</a:t>
+            </a:r>
+          </a:p>
+        </p:txBody>
+      </p:sp>
+      <p:pic>
+        <p:nvPicPr>
+          <p:cNvPr id="7" name="Picture 6" descr="x-circle.png"/>
+          <p:cNvPicPr>
+            <a:picLocks noChangeAspect="1"/>
+          </p:cNvPicPr>
+          <p:nvPr/>
+        </p:nvPicPr>
+        <p:blipFill>
+          <a:blip r:embed="rId3"/>
+          <a:stretch>
+            <a:fillRect/>
+          </a:stretch>
+        </p:blipFill>
+        <p:spPr>
+          <a:xfrm>
+            <a:off x="6492240" y="1417320"/>
+            <a:ext cx="310896" cy="310896"/>
+          </a:xfrm>
+          <a:prstGeom prst="rect">
+            <a:avLst/>
+          </a:prstGeom>
+        </p:spPr>
+      </p:pic>
+      <p:sp>
+        <p:nvSpPr>
+          <p:cNvPr id="8" name="TextBox 7"/>
+          <p:cNvSpPr txBox="1"/>
+          <p:nvPr/>
+        </p:nvSpPr>
+        <p:spPr>
+          <a:xfrm>
+            <a:off x="6931152" y="1371600"/>
+            <a:ext cx="4572000" cy="411480"/>
           </a:xfrm>
           <a:prstGeom prst="rect">
             <a:avLst/>
@@ -9690,274 +9728,104 @@
           <a:p>
             <a:pPr algn="l">
               <a:spcAft>
-                <a:spcPts val="400"/>
-              </a:spcAft>
-            </a:pPr>
-            <a:r>
-              <a:rPr sz="2200" b="1" i="0">
-                <a:solidFill>
-                  <a:srgbClr val="2E75B6"/>
-                </a:solidFill>
-                <a:latin typeface="Calibri"/>
-              </a:rPr>
-              <a:t>12 pp</a:t>
+                <a:spcPts val="0"/>
+              </a:spcAft>
+            </a:pPr>
+            <a:r>
+              <a:rPr sz="1700" b="1" i="0">
+                <a:solidFill>
+                  <a:srgbClr val="C0392B"/>
+                </a:solidFill>
+                <a:latin typeface="Calibri"/>
+              </a:rPr>
+              <a:t>NOT SUPPORTED</a:t>
+            </a:r>
+          </a:p>
+        </p:txBody>
+      </p:sp>
+      <p:sp>
+        <p:nvSpPr>
+          <p:cNvPr id="9" name="TextBox 8"/>
+          <p:cNvSpPr txBox="1"/>
+          <p:nvPr/>
+        </p:nvSpPr>
+        <p:spPr>
+          <a:xfrm>
+            <a:off x="6492240" y="1920240"/>
+            <a:ext cx="5029200" cy="3291840"/>
+          </a:xfrm>
+          <a:prstGeom prst="rect">
+            <a:avLst/>
+          </a:prstGeom>
+          <a:noFill/>
+        </p:spPr>
+        <p:txBody>
+          <a:bodyPr wrap="square" anchor="t">
+            <a:spAutoFit/>
+          </a:bodyPr>
+          <a:lstStyle/>
+          <a:p>
+            <a:pPr algn="l">
+              <a:spcAft>
+                <a:spcPts val="1200"/>
+              </a:spcAft>
+            </a:pPr>
+            <a:r>
+              <a:rPr sz="1700" b="0" i="0">
+                <a:solidFill>
+                  <a:srgbClr val="1A1A1A"/>
+                </a:solidFill>
+                <a:latin typeface="Calibri"/>
+              </a:rPr>
+              <a:t>•  That the index detects manipulation. Source is confounded; TF-IDF scores 0.9758.</a:t>
             </a:r>
           </a:p>
           <a:p>
             <a:pPr>
               <a:spcAft>
-                <a:spcPts val="800"/>
-              </a:spcAft>
-            </a:pPr>
-            <a:r>
-              <a:rPr sz="2000" b="1" i="0">
+                <a:spcPts val="1200"/>
+              </a:spcAft>
+            </a:pPr>
+            <a:r>
+              <a:rPr sz="1700" b="0" i="0">
                 <a:solidFill>
                   <a:srgbClr val="1A1A1A"/>
                 </a:solidFill>
                 <a:latin typeface="Calibri"/>
               </a:rPr>
-              <a:t>Paper 1</a:t>
+              <a:t>•  Anything about the amygdala. The checkpoint does not predict it.</a:t>
             </a:r>
           </a:p>
           <a:p>
             <a:pPr>
               <a:spcAft>
-                <a:spcPts val="0"/>
-              </a:spcAft>
-            </a:pPr>
-            <a:r>
-              <a:rPr sz="1500" b="0" i="0">
-                <a:solidFill>
-                  <a:srgbClr val="595959"/>
-                </a:solidFill>
-                <a:latin typeface="Calibri"/>
-              </a:rPr>
-              <a:t>The bound and the screening criterion. Physica A. Independent of the scan.</a:t>
-            </a:r>
-          </a:p>
-        </p:txBody>
-      </p:sp>
-      <p:sp>
-        <p:nvSpPr>
-          <p:cNvPr id="6" name="TextBox 5"/>
-          <p:cNvSpPr txBox="1"/>
-          <p:nvPr/>
-        </p:nvSpPr>
-        <p:spPr>
-          <a:xfrm>
-            <a:off x="6483096" y="1554480"/>
-            <a:ext cx="2606040" cy="2743200"/>
-          </a:xfrm>
-          <a:prstGeom prst="rect">
-            <a:avLst/>
-          </a:prstGeom>
-          <a:noFill/>
-        </p:spPr>
-        <p:txBody>
-          <a:bodyPr wrap="square" anchor="t">
-            <a:spAutoFit/>
-          </a:bodyPr>
-          <a:lstStyle/>
-          <a:p>
-            <a:pPr algn="l">
-              <a:spcAft>
-                <a:spcPts val="400"/>
-              </a:spcAft>
-            </a:pPr>
-            <a:r>
-              <a:rPr sz="2200" b="1" i="0">
-                <a:solidFill>
-                  <a:srgbClr val="2E75B6"/>
-                </a:solidFill>
-                <a:latin typeface="Calibri"/>
-              </a:rPr>
-              <a:t>12 pp</a:t>
+                <a:spcPts val="1200"/>
+              </a:spcAft>
+            </a:pPr>
+            <a:r>
+              <a:rPr sz="1700" b="0" i="0">
+                <a:solidFill>
+                  <a:srgbClr val="1A1A1A"/>
+                </a:solidFill>
+                <a:latin typeface="Calibri"/>
+              </a:rPr>
+              <a:t>•  Any value of the coupling α. The corpus does not identify it.</a:t>
             </a:r>
           </a:p>
           <a:p>
             <a:pPr>
               <a:spcAft>
-                <a:spcPts val="800"/>
-              </a:spcAft>
-            </a:pPr>
-            <a:r>
-              <a:rPr sz="2000" b="1" i="0">
+                <a:spcPts val="1200"/>
+              </a:spcAft>
+            </a:pPr>
+            <a:r>
+              <a:rPr sz="1700" b="0" i="0">
                 <a:solidFill>
                   <a:srgbClr val="1A1A1A"/>
                 </a:solidFill>
                 <a:latin typeface="Calibri"/>
               </a:rPr>
-              <a:t>Paper 2</a:t>
-            </a:r>
-          </a:p>
-          <a:p>
-            <a:pPr>
-              <a:spcAft>
-                <a:spcPts val="0"/>
-              </a:spcAft>
-            </a:pPr>
-            <a:r>
-              <a:rPr sz="1500" b="0" i="0">
-                <a:solidFill>
-                  <a:srgbClr val="595959"/>
-                </a:solidFill>
-                <a:latin typeface="Calibri"/>
-              </a:rPr>
-              <a:t>The instrument, the corpus, the field bound. Physica A.</a:t>
-            </a:r>
-          </a:p>
-        </p:txBody>
-      </p:sp>
-      <p:sp>
-        <p:nvSpPr>
-          <p:cNvPr id="7" name="TextBox 6"/>
-          <p:cNvSpPr txBox="1"/>
-          <p:nvPr/>
-        </p:nvSpPr>
-        <p:spPr>
-          <a:xfrm>
-            <a:off x="9381744" y="1554480"/>
-            <a:ext cx="2606040" cy="2743200"/>
-          </a:xfrm>
-          <a:prstGeom prst="rect">
-            <a:avLst/>
-          </a:prstGeom>
-          <a:noFill/>
-        </p:spPr>
-        <p:txBody>
-          <a:bodyPr wrap="square" anchor="t">
-            <a:spAutoFit/>
-          </a:bodyPr>
-          <a:lstStyle/>
-          <a:p>
-            <a:pPr algn="l">
-              <a:spcAft>
-                <a:spcPts val="400"/>
-              </a:spcAft>
-            </a:pPr>
-            <a:r>
-              <a:rPr sz="2200" b="1" i="0">
-                <a:solidFill>
-                  <a:srgbClr val="2E75B6"/>
-                </a:solidFill>
-                <a:latin typeface="Calibri"/>
-              </a:rPr>
-              <a:t>6 pp</a:t>
-            </a:r>
-          </a:p>
-          <a:p>
-            <a:pPr>
-              <a:spcAft>
-                <a:spcPts val="800"/>
-              </a:spcAft>
-            </a:pPr>
-            <a:r>
-              <a:rPr sz="2000" b="1" i="0">
-                <a:solidFill>
-                  <a:srgbClr val="1A1A1A"/>
-                </a:solidFill>
-                <a:latin typeface="Calibri"/>
-              </a:rPr>
-              <a:t>Paper 3</a:t>
-            </a:r>
-          </a:p>
-          <a:p>
-            <a:pPr>
-              <a:spcAft>
-                <a:spcPts val="0"/>
-              </a:spcAft>
-            </a:pPr>
-            <a:r>
-              <a:rPr sz="1500" b="0" i="0">
-                <a:solidFill>
-                  <a:srgbClr val="595959"/>
-                </a:solidFill>
-                <a:latin typeface="Calibri"/>
-              </a:rPr>
-              <a:t>The measured ceiling and the replication. Imaging Neuroscience. One computation on its final run.</a:t>
-            </a:r>
-          </a:p>
-        </p:txBody>
-      </p:sp>
-      <p:sp>
-        <p:nvSpPr>
-          <p:cNvPr id="8" name="Rectangle 7"/>
-          <p:cNvSpPr/>
-          <p:nvPr/>
-        </p:nvSpPr>
-        <p:spPr>
-          <a:xfrm>
-            <a:off x="685800" y="4526280"/>
-            <a:ext cx="10820095" cy="19050"/>
-          </a:xfrm>
-          <a:prstGeom prst="rect">
-            <a:avLst/>
-          </a:prstGeom>
-          <a:solidFill>
-            <a:srgbClr val="D9D9D9"/>
-          </a:solidFill>
-          <a:ln>
-            <a:noFill/>
-          </a:ln>
-          <a:effectLst/>
-        </p:spPr>
-        <p:style>
-          <a:lnRef idx="1">
-            <a:schemeClr val="accent1"/>
-          </a:lnRef>
-          <a:fillRef idx="3">
-            <a:schemeClr val="accent1"/>
-          </a:fillRef>
-          <a:effectRef idx="2">
-            <a:schemeClr val="accent1"/>
-          </a:effectRef>
-          <a:fontRef idx="minor">
-            <a:schemeClr val="lt1"/>
-          </a:fontRef>
-        </p:style>
-        <p:txBody>
-          <a:bodyPr rtlCol="0" anchor="ctr"/>
-          <a:lstStyle/>
-          <a:p>
-            <a:pPr algn="ctr"/>
-          </a:p>
-        </p:txBody>
-      </p:sp>
-      <p:sp>
-        <p:nvSpPr>
-          <p:cNvPr id="9" name="TextBox 8"/>
-          <p:cNvSpPr txBox="1"/>
-          <p:nvPr/>
-        </p:nvSpPr>
-        <p:spPr>
-          <a:xfrm>
-            <a:off x="685800" y="4754880"/>
-            <a:ext cx="10820095" cy="822960"/>
-          </a:xfrm>
-          <a:prstGeom prst="rect">
-            <a:avLst/>
-          </a:prstGeom>
-          <a:noFill/>
-        </p:spPr>
-        <p:txBody>
-          <a:bodyPr wrap="square" anchor="t">
-            <a:spAutoFit/>
-          </a:bodyPr>
-          <a:lstStyle/>
-          <a:p>
-            <a:pPr algn="l">
-              <a:spcAft>
-                <a:spcPts val="0"/>
-              </a:spcAft>
-            </a:pPr>
-            <a:r>
-              <a:rPr sz="1900" b="0" i="0">
-                <a:solidFill>
-                  <a:srgbClr val="1A1A1A"/>
-                </a:solidFill>
-                <a:latin typeface="Calibri"/>
-              </a:rPr>
-              <a:t>Every number in all four comes from a re-runnable script. Nothing is transcribed by hand.</a:t>
+              <a:t>•  Any verdict on one article. 12.8% reverse between sessions.</a:t>
             </a:r>
           </a:p>
         </p:txBody>
@@ -10060,7 +9928,7 @@
       <p:grpSpPr/>
       <p:pic>
         <p:nvPicPr>
-          <p:cNvPr id="2" name="Picture 1" descr="flag-banner.png"/>
+          <p:cNvPr id="2" name="Picture 1" descr="books.png"/>
           <p:cNvPicPr>
             <a:picLocks noChangeAspect="1"/>
           </p:cNvPicPr>
@@ -10116,7 +9984,7 @@
                 </a:solidFill>
                 <a:latin typeface="Calibri"/>
               </a:rPr>
-              <a:t>Conclusions</a:t>
+              <a:t>The work yields a dissertation and three papers</a:t>
             </a:r>
           </a:p>
         </p:txBody>
@@ -10129,8 +9997,8 @@
         </p:nvSpPr>
         <p:spPr>
           <a:xfrm>
-            <a:off x="685800" y="1371600"/>
-            <a:ext cx="10820095" cy="3840480"/>
+            <a:off x="685800" y="1554480"/>
+            <a:ext cx="2606040" cy="2743200"/>
           </a:xfrm>
           <a:prstGeom prst="rect">
             <a:avLst/>
@@ -10145,150 +10013,275 @@
           <a:p>
             <a:pPr algn="l">
               <a:spcAft>
-                <a:spcPts val="1400"/>
-              </a:spcAft>
-            </a:pPr>
-            <a:r>
-              <a:rPr sz="1800" b="1">
+                <a:spcPts val="400"/>
+              </a:spcAft>
+            </a:pPr>
+            <a:r>
+              <a:rPr sz="2200" b="1" i="0">
                 <a:solidFill>
                   <a:srgbClr val="2E75B6"/>
                 </a:solidFill>
                 <a:latin typeface="Calibri"/>
               </a:rPr>
-              <a:t>1.  </a:t>
-            </a:r>
-            <a:r>
-              <a:rPr sz="1800" b="1">
+              <a:t>78 pp</a:t>
+            </a:r>
+          </a:p>
+          <a:p>
+            <a:pPr>
+              <a:spcAft>
+                <a:spcPts val="800"/>
+              </a:spcAft>
+            </a:pPr>
+            <a:r>
+              <a:rPr sz="2000" b="1" i="0">
                 <a:solidFill>
                   <a:srgbClr val="1A1A1A"/>
                 </a:solidFill>
                 <a:latin typeface="Calibri"/>
               </a:rPr>
-              <a:t>A field observable can be measured from content. </a:t>
-            </a:r>
-            <a:r>
-              <a:rPr sz="1800" b="0">
+              <a:t>Dissertation</a:t>
+            </a:r>
+          </a:p>
+          <a:p>
+            <a:pPr>
+              <a:spcAft>
+                <a:spcPts val="0"/>
+              </a:spcAft>
+            </a:pPr>
+            <a:r>
+              <a:rPr sz="1500" b="0" i="0">
+                <a:solidFill>
+                  <a:srgbClr val="595959"/>
+                </a:solidFill>
+                <a:latin typeface="Calibri"/>
+              </a:rPr>
+              <a:t>Complete, review answered.</a:t>
+            </a:r>
+          </a:p>
+        </p:txBody>
+      </p:sp>
+      <p:sp>
+        <p:nvSpPr>
+          <p:cNvPr id="5" name="TextBox 4"/>
+          <p:cNvSpPr txBox="1"/>
+          <p:nvPr/>
+        </p:nvSpPr>
+        <p:spPr>
+          <a:xfrm>
+            <a:off x="3584448" y="1554480"/>
+            <a:ext cx="2606040" cy="2743200"/>
+          </a:xfrm>
+          <a:prstGeom prst="rect">
+            <a:avLst/>
+          </a:prstGeom>
+          <a:noFill/>
+        </p:spPr>
+        <p:txBody>
+          <a:bodyPr wrap="square" anchor="t">
+            <a:spAutoFit/>
+          </a:bodyPr>
+          <a:lstStyle/>
+          <a:p>
+            <a:pPr algn="l">
+              <a:spcAft>
+                <a:spcPts val="400"/>
+              </a:spcAft>
+            </a:pPr>
+            <a:r>
+              <a:rPr sz="2200" b="1" i="0">
+                <a:solidFill>
+                  <a:srgbClr val="2E75B6"/>
+                </a:solidFill>
+                <a:latin typeface="Calibri"/>
+              </a:rPr>
+              <a:t>12 pp</a:t>
+            </a:r>
+          </a:p>
+          <a:p>
+            <a:pPr>
+              <a:spcAft>
+                <a:spcPts val="800"/>
+              </a:spcAft>
+            </a:pPr>
+            <a:r>
+              <a:rPr sz="2000" b="1" i="0">
                 <a:solidFill>
                   <a:srgbClr val="1A1A1A"/>
                 </a:solidFill>
                 <a:latin typeface="Calibri"/>
               </a:rPr>
-              <a:t>The instrument runs, the corpus is complete, and reliability is measured rather than assumed: ICC = 0.8725.</a:t>
+              <a:t>Paper 1</a:t>
             </a:r>
           </a:p>
           <a:p>
             <a:pPr>
               <a:spcAft>
-                <a:spcPts val="1400"/>
-              </a:spcAft>
-            </a:pPr>
-            <a:r>
-              <a:rPr sz="1800" b="1">
+                <a:spcPts val="0"/>
+              </a:spcAft>
+            </a:pPr>
+            <a:r>
+              <a:rPr sz="1500" b="0" i="0">
+                <a:solidFill>
+                  <a:srgbClr val="595959"/>
+                </a:solidFill>
+                <a:latin typeface="Calibri"/>
+              </a:rPr>
+              <a:t>The bound and the screening criterion. Physica A. Independent of the scan.</a:t>
+            </a:r>
+          </a:p>
+        </p:txBody>
+      </p:sp>
+      <p:sp>
+        <p:nvSpPr>
+          <p:cNvPr id="6" name="TextBox 5"/>
+          <p:cNvSpPr txBox="1"/>
+          <p:nvPr/>
+        </p:nvSpPr>
+        <p:spPr>
+          <a:xfrm>
+            <a:off x="6483096" y="1554480"/>
+            <a:ext cx="2606040" cy="2743200"/>
+          </a:xfrm>
+          <a:prstGeom prst="rect">
+            <a:avLst/>
+          </a:prstGeom>
+          <a:noFill/>
+        </p:spPr>
+        <p:txBody>
+          <a:bodyPr wrap="square" anchor="t">
+            <a:spAutoFit/>
+          </a:bodyPr>
+          <a:lstStyle/>
+          <a:p>
+            <a:pPr algn="l">
+              <a:spcAft>
+                <a:spcPts val="400"/>
+              </a:spcAft>
+            </a:pPr>
+            <a:r>
+              <a:rPr sz="2200" b="1" i="0">
                 <a:solidFill>
                   <a:srgbClr val="2E75B6"/>
                 </a:solidFill>
                 <a:latin typeface="Calibri"/>
               </a:rPr>
-              <a:t>2.  </a:t>
-            </a:r>
-            <a:r>
-              <a:rPr sz="1800" b="1">
+              <a:t>15 pp</a:t>
+            </a:r>
+          </a:p>
+          <a:p>
+            <a:pPr>
+              <a:spcAft>
+                <a:spcPts val="800"/>
+              </a:spcAft>
+            </a:pPr>
+            <a:r>
+              <a:rPr sz="2000" b="1" i="0">
                 <a:solidFill>
                   <a:srgbClr val="1A1A1A"/>
                 </a:solidFill>
                 <a:latin typeface="Calibri"/>
               </a:rPr>
-              <a:t>It separates four corpora at 0.1068, and the separation is confounded with source. </a:t>
-            </a:r>
-            <a:r>
-              <a:rPr sz="1800" b="0">
+              <a:t>Paper 2</a:t>
+            </a:r>
+          </a:p>
+          <a:p>
+            <a:pPr>
+              <a:spcAft>
+                <a:spcPts val="0"/>
+              </a:spcAft>
+            </a:pPr>
+            <a:r>
+              <a:rPr sz="1500" b="0" i="0">
+                <a:solidFill>
+                  <a:srgbClr val="595959"/>
+                </a:solidFill>
+                <a:latin typeface="Calibri"/>
+              </a:rPr>
+              <a:t>The instrument, the corpus, the field bound. Physica A.</a:t>
+            </a:r>
+          </a:p>
+        </p:txBody>
+      </p:sp>
+      <p:sp>
+        <p:nvSpPr>
+          <p:cNvPr id="7" name="TextBox 6"/>
+          <p:cNvSpPr txBox="1"/>
+          <p:nvPr/>
+        </p:nvSpPr>
+        <p:spPr>
+          <a:xfrm>
+            <a:off x="9381744" y="1554480"/>
+            <a:ext cx="2606040" cy="2743200"/>
+          </a:xfrm>
+          <a:prstGeom prst="rect">
+            <a:avLst/>
+          </a:prstGeom>
+          <a:noFill/>
+        </p:spPr>
+        <p:txBody>
+          <a:bodyPr wrap="square" anchor="t">
+            <a:spAutoFit/>
+          </a:bodyPr>
+          <a:lstStyle/>
+          <a:p>
+            <a:pPr algn="l">
+              <a:spcAft>
+                <a:spcPts val="400"/>
+              </a:spcAft>
+            </a:pPr>
+            <a:r>
+              <a:rPr sz="2200" b="1" i="0">
+                <a:solidFill>
+                  <a:srgbClr val="2E75B6"/>
+                </a:solidFill>
+                <a:latin typeface="Calibri"/>
+              </a:rPr>
+              <a:t>6 pp</a:t>
+            </a:r>
+          </a:p>
+          <a:p>
+            <a:pPr>
+              <a:spcAft>
+                <a:spcPts val="800"/>
+              </a:spcAft>
+            </a:pPr>
+            <a:r>
+              <a:rPr sz="2000" b="1" i="0">
                 <a:solidFill>
                   <a:srgbClr val="1A1A1A"/>
                 </a:solidFill>
                 <a:latin typeface="Calibri"/>
               </a:rPr>
-              <a:t>Both halves are reported, the confound first.</a:t>
+              <a:t>Paper 3</a:t>
             </a:r>
           </a:p>
           <a:p>
             <a:pPr>
               <a:spcAft>
-                <a:spcPts val="1400"/>
-              </a:spcAft>
-            </a:pPr>
-            <a:r>
-              <a:rPr sz="1800" b="1">
-                <a:solidFill>
-                  <a:srgbClr val="2E75B6"/>
-                </a:solidFill>
-                <a:latin typeface="Calibri"/>
-              </a:rPr>
-              <a:t>3.  </a:t>
-            </a:r>
-            <a:r>
-              <a:rPr sz="1800" b="1">
-                <a:solidFill>
-                  <a:srgbClr val="1A1A1A"/>
-                </a:solidFill>
-                <a:latin typeface="Calibri"/>
-              </a:rPr>
-              <a:t>The coupling is unidentified, so the thesis reports a bound instead. </a:t>
-            </a:r>
-            <a:r>
-              <a:rPr sz="1800" b="0">
-                <a:solidFill>
-                  <a:srgbClr val="1A1A1A"/>
-                </a:solidFill>
-                <a:latin typeface="Calibri"/>
-              </a:rPr>
-              <a:t>With ΔX = 0.1241, α ≥ 4.294 at βJ = 2 — a constraint on any future proposal of this mechanism.</a:t>
-            </a:r>
-          </a:p>
-          <a:p>
-            <a:pPr>
-              <a:spcAft>
-                <a:spcPts val="1400"/>
-              </a:spcAft>
-            </a:pPr>
-            <a:r>
-              <a:rPr sz="1800" b="1">
-                <a:solidFill>
-                  <a:srgbClr val="2E75B6"/>
-                </a:solidFill>
-                <a:latin typeface="Calibri"/>
-              </a:rPr>
-              <a:t>4.  </a:t>
-            </a:r>
-            <a:r>
-              <a:rPr sz="1800" b="1">
-                <a:solidFill>
-                  <a:srgbClr val="1A1A1A"/>
-                </a:solidFill>
-                <a:latin typeface="Calibri"/>
-              </a:rPr>
-              <a:t>The instrument's own validity is now a measurable question. </a:t>
-            </a:r>
-            <a:r>
-              <a:rPr sz="1800" b="0">
-                <a:solidFill>
-                  <a:srgbClr val="1A1A1A"/>
-                </a:solidFill>
-                <a:latin typeface="Calibri"/>
-              </a:rPr>
-              <a:t>The noise ceiling is 0.1517; one prediction pass remains.</a:t>
-            </a:r>
-          </a:p>
-        </p:txBody>
-      </p:sp>
-      <p:sp>
-        <p:nvSpPr>
-          <p:cNvPr id="5" name="Rectangle 4"/>
+                <a:spcPts val="0"/>
+              </a:spcAft>
+            </a:pPr>
+            <a:r>
+              <a:rPr sz="1500" b="0" i="0">
+                <a:solidFill>
+                  <a:srgbClr val="595959"/>
+                </a:solidFill>
+                <a:latin typeface="Calibri"/>
+              </a:rPr>
+              <a:t>The measured ceiling and the replication. Imaging Neuroscience. One computation on its final run.</a:t>
+            </a:r>
+          </a:p>
+        </p:txBody>
+      </p:sp>
+      <p:sp>
+        <p:nvSpPr>
+          <p:cNvPr id="8" name="Rectangle 7"/>
           <p:cNvSpPr/>
           <p:nvPr/>
         </p:nvSpPr>
         <p:spPr>
           <a:xfrm>
-            <a:off x="685800" y="5349240"/>
+            <a:off x="685800" y="4526280"/>
             <a:ext cx="10820095" cy="19050"/>
           </a:xfrm>
           <a:prstGeom prst="rect">
@@ -10326,14 +10319,14 @@
       </p:sp>
       <p:sp>
         <p:nvSpPr>
-          <p:cNvPr id="6" name="TextBox 5"/>
-          <p:cNvSpPr txBox="1"/>
-          <p:nvPr/>
-        </p:nvSpPr>
-        <p:spPr>
-          <a:xfrm>
-            <a:off x="685800" y="5532120"/>
-            <a:ext cx="10820095" cy="457200"/>
+          <p:cNvPr id="9" name="TextBox 8"/>
+          <p:cNvSpPr txBox="1"/>
+          <p:nvPr/>
+        </p:nvSpPr>
+        <p:spPr>
+          <a:xfrm>
+            <a:off x="685800" y="4754880"/>
+            <a:ext cx="10820095" cy="822960"/>
           </a:xfrm>
           <a:prstGeom prst="rect">
             <a:avLst/>
@@ -10352,20 +10345,20 @@
               </a:spcAft>
             </a:pPr>
             <a:r>
-              <a:rPr sz="1400" b="0" i="0">
-                <a:solidFill>
-                  <a:srgbClr val="595959"/>
-                </a:solidFill>
-                <a:latin typeface="Calibri"/>
-              </a:rPr>
-              <a:t>Brian Mwai  ·  1050555  ·  monarch-4iy.pages.dev  ·  github.com/brn-mwai/monarch</a:t>
-            </a:r>
-          </a:p>
-        </p:txBody>
-      </p:sp>
-      <p:sp>
-        <p:nvSpPr>
-          <p:cNvPr id="7" name="TextBox 6"/>
+              <a:rPr sz="1900" b="0" i="0">
+                <a:solidFill>
+                  <a:srgbClr val="1A1A1A"/>
+                </a:solidFill>
+                <a:latin typeface="Calibri"/>
+              </a:rPr>
+              <a:t>Every number in all four comes from a re-runnable script. Nothing is transcribed by hand.</a:t>
+            </a:r>
+          </a:p>
+        </p:txBody>
+      </p:sp>
+      <p:sp>
+        <p:nvSpPr>
+          <p:cNvPr id="10" name="TextBox 9"/>
           <p:cNvSpPr txBox="1"/>
           <p:nvPr/>
         </p:nvSpPr>
@@ -10404,7 +10397,7 @@
       </p:sp>
       <p:sp>
         <p:nvSpPr>
-          <p:cNvPr id="8" name="TextBox 7"/>
+          <p:cNvPr id="11" name="TextBox 10"/>
           <p:cNvSpPr txBox="1"/>
           <p:nvPr/>
         </p:nvSpPr>
@@ -10459,6 +10452,407 @@
         <p:nvPr/>
       </p:nvGrpSpPr>
       <p:grpSpPr/>
+      <p:pic>
+        <p:nvPicPr>
+          <p:cNvPr id="2" name="Picture 1" descr="flag-banner.png"/>
+          <p:cNvPicPr>
+            <a:picLocks noChangeAspect="1"/>
+          </p:cNvPicPr>
+          <p:nvPr/>
+        </p:nvPicPr>
+        <p:blipFill>
+          <a:blip r:embed="rId2"/>
+          <a:stretch>
+            <a:fillRect/>
+          </a:stretch>
+        </p:blipFill>
+        <p:spPr>
+          <a:xfrm>
+            <a:off x="685800" y="365759"/>
+            <a:ext cx="420624" cy="420624"/>
+          </a:xfrm>
+          <a:prstGeom prst="rect">
+            <a:avLst/>
+          </a:prstGeom>
+        </p:spPr>
+      </p:pic>
+      <p:sp>
+        <p:nvSpPr>
+          <p:cNvPr id="3" name="TextBox 2"/>
+          <p:cNvSpPr txBox="1"/>
+          <p:nvPr/>
+        </p:nvSpPr>
+        <p:spPr>
+          <a:xfrm>
+            <a:off x="1289304" y="310896"/>
+            <a:ext cx="10216591" cy="822960"/>
+          </a:xfrm>
+          <a:prstGeom prst="rect">
+            <a:avLst/>
+          </a:prstGeom>
+          <a:noFill/>
+        </p:spPr>
+        <p:txBody>
+          <a:bodyPr wrap="square" anchor="t">
+            <a:spAutoFit/>
+          </a:bodyPr>
+          <a:lstStyle/>
+          <a:p>
+            <a:pPr algn="l">
+              <a:spcAft>
+                <a:spcPts val="0"/>
+              </a:spcAft>
+            </a:pPr>
+            <a:r>
+              <a:rPr sz="2600" b="1" i="0">
+                <a:solidFill>
+                  <a:srgbClr val="1F4E79"/>
+                </a:solidFill>
+                <a:latin typeface="Calibri"/>
+              </a:rPr>
+              <a:t>Conclusions</a:t>
+            </a:r>
+          </a:p>
+        </p:txBody>
+      </p:sp>
+      <p:sp>
+        <p:nvSpPr>
+          <p:cNvPr id="4" name="TextBox 3"/>
+          <p:cNvSpPr txBox="1"/>
+          <p:nvPr/>
+        </p:nvSpPr>
+        <p:spPr>
+          <a:xfrm>
+            <a:off x="685800" y="1371600"/>
+            <a:ext cx="10820095" cy="3840480"/>
+          </a:xfrm>
+          <a:prstGeom prst="rect">
+            <a:avLst/>
+          </a:prstGeom>
+          <a:noFill/>
+        </p:spPr>
+        <p:txBody>
+          <a:bodyPr wrap="square" anchor="t">
+            <a:spAutoFit/>
+          </a:bodyPr>
+          <a:lstStyle/>
+          <a:p>
+            <a:pPr algn="l">
+              <a:spcAft>
+                <a:spcPts val="1400"/>
+              </a:spcAft>
+            </a:pPr>
+            <a:r>
+              <a:rPr sz="1800" b="1">
+                <a:solidFill>
+                  <a:srgbClr val="2E75B6"/>
+                </a:solidFill>
+                <a:latin typeface="Calibri"/>
+              </a:rPr>
+              <a:t>1.  </a:t>
+            </a:r>
+            <a:r>
+              <a:rPr sz="1800" b="1">
+                <a:solidFill>
+                  <a:srgbClr val="1A1A1A"/>
+                </a:solidFill>
+                <a:latin typeface="Calibri"/>
+              </a:rPr>
+              <a:t>A field observable can be measured from content. </a:t>
+            </a:r>
+            <a:r>
+              <a:rPr sz="1800" b="0">
+                <a:solidFill>
+                  <a:srgbClr val="1A1A1A"/>
+                </a:solidFill>
+                <a:latin typeface="Calibri"/>
+              </a:rPr>
+              <a:t>The instrument runs, the corpus is complete, and reliability is measured rather than assumed: ICC = 0.8725.</a:t>
+            </a:r>
+          </a:p>
+          <a:p>
+            <a:pPr>
+              <a:spcAft>
+                <a:spcPts val="1400"/>
+              </a:spcAft>
+            </a:pPr>
+            <a:r>
+              <a:rPr sz="1800" b="1">
+                <a:solidFill>
+                  <a:srgbClr val="2E75B6"/>
+                </a:solidFill>
+                <a:latin typeface="Calibri"/>
+              </a:rPr>
+              <a:t>2.  </a:t>
+            </a:r>
+            <a:r>
+              <a:rPr sz="1800" b="1">
+                <a:solidFill>
+                  <a:srgbClr val="1A1A1A"/>
+                </a:solidFill>
+                <a:latin typeface="Calibri"/>
+              </a:rPr>
+              <a:t>It separates four corpora at 0.1068, and the separation is confounded with source. </a:t>
+            </a:r>
+            <a:r>
+              <a:rPr sz="1800" b="0">
+                <a:solidFill>
+                  <a:srgbClr val="1A1A1A"/>
+                </a:solidFill>
+                <a:latin typeface="Calibri"/>
+              </a:rPr>
+              <a:t>Both halves are reported, the confound first.</a:t>
+            </a:r>
+          </a:p>
+          <a:p>
+            <a:pPr>
+              <a:spcAft>
+                <a:spcPts val="1400"/>
+              </a:spcAft>
+            </a:pPr>
+            <a:r>
+              <a:rPr sz="1800" b="1">
+                <a:solidFill>
+                  <a:srgbClr val="2E75B6"/>
+                </a:solidFill>
+                <a:latin typeface="Calibri"/>
+              </a:rPr>
+              <a:t>3.  </a:t>
+            </a:r>
+            <a:r>
+              <a:rPr sz="1800" b="1">
+                <a:solidFill>
+                  <a:srgbClr val="1A1A1A"/>
+                </a:solidFill>
+                <a:latin typeface="Calibri"/>
+              </a:rPr>
+              <a:t>The coupling is unidentified, so the thesis reports a bound instead. </a:t>
+            </a:r>
+            <a:r>
+              <a:rPr sz="1800" b="0">
+                <a:solidFill>
+                  <a:srgbClr val="1A1A1A"/>
+                </a:solidFill>
+                <a:latin typeface="Calibri"/>
+              </a:rPr>
+              <a:t>With ΔX = 0.1241, α ≥ 4.294 at βJ = 2 — a constraint on any future proposal of this mechanism.</a:t>
+            </a:r>
+          </a:p>
+          <a:p>
+            <a:pPr>
+              <a:spcAft>
+                <a:spcPts val="1400"/>
+              </a:spcAft>
+            </a:pPr>
+            <a:r>
+              <a:rPr sz="1800" b="1">
+                <a:solidFill>
+                  <a:srgbClr val="2E75B6"/>
+                </a:solidFill>
+                <a:latin typeface="Calibri"/>
+              </a:rPr>
+              <a:t>4.  </a:t>
+            </a:r>
+            <a:r>
+              <a:rPr sz="1800" b="1">
+                <a:solidFill>
+                  <a:srgbClr val="1A1A1A"/>
+                </a:solidFill>
+                <a:latin typeface="Calibri"/>
+              </a:rPr>
+              <a:t>The instrument's own validity is now a measurable question. </a:t>
+            </a:r>
+            <a:r>
+              <a:rPr sz="1800" b="0">
+                <a:solidFill>
+                  <a:srgbClr val="1A1A1A"/>
+                </a:solidFill>
+                <a:latin typeface="Calibri"/>
+              </a:rPr>
+              <a:t>The noise ceiling is 0.1517; one prediction pass remains.</a:t>
+            </a:r>
+          </a:p>
+        </p:txBody>
+      </p:sp>
+      <p:sp>
+        <p:nvSpPr>
+          <p:cNvPr id="5" name="Rectangle 4"/>
+          <p:cNvSpPr/>
+          <p:nvPr/>
+        </p:nvSpPr>
+        <p:spPr>
+          <a:xfrm>
+            <a:off x="685800" y="5349240"/>
+            <a:ext cx="10820095" cy="19050"/>
+          </a:xfrm>
+          <a:prstGeom prst="rect">
+            <a:avLst/>
+          </a:prstGeom>
+          <a:solidFill>
+            <a:srgbClr val="D9D9D9"/>
+          </a:solidFill>
+          <a:ln>
+            <a:noFill/>
+          </a:ln>
+          <a:effectLst/>
+        </p:spPr>
+        <p:style>
+          <a:lnRef idx="1">
+            <a:schemeClr val="accent1"/>
+          </a:lnRef>
+          <a:fillRef idx="3">
+            <a:schemeClr val="accent1"/>
+          </a:fillRef>
+          <a:effectRef idx="2">
+            <a:schemeClr val="accent1"/>
+          </a:effectRef>
+          <a:fontRef idx="minor">
+            <a:schemeClr val="lt1"/>
+          </a:fontRef>
+        </p:style>
+        <p:txBody>
+          <a:bodyPr rtlCol="0" anchor="ctr"/>
+          <a:lstStyle/>
+          <a:p>
+            <a:pPr algn="ctr"/>
+          </a:p>
+        </p:txBody>
+      </p:sp>
+      <p:sp>
+        <p:nvSpPr>
+          <p:cNvPr id="6" name="TextBox 5"/>
+          <p:cNvSpPr txBox="1"/>
+          <p:nvPr/>
+        </p:nvSpPr>
+        <p:spPr>
+          <a:xfrm>
+            <a:off x="685800" y="5532120"/>
+            <a:ext cx="10820095" cy="457200"/>
+          </a:xfrm>
+          <a:prstGeom prst="rect">
+            <a:avLst/>
+          </a:prstGeom>
+          <a:noFill/>
+        </p:spPr>
+        <p:txBody>
+          <a:bodyPr wrap="square" anchor="t">
+            <a:spAutoFit/>
+          </a:bodyPr>
+          <a:lstStyle/>
+          <a:p>
+            <a:pPr algn="l">
+              <a:spcAft>
+                <a:spcPts val="0"/>
+              </a:spcAft>
+            </a:pPr>
+            <a:r>
+              <a:rPr sz="1400" b="0" i="0">
+                <a:solidFill>
+                  <a:srgbClr val="595959"/>
+                </a:solidFill>
+                <a:latin typeface="Calibri"/>
+              </a:rPr>
+              <a:t>Brian Mwai  ·  1050555  ·  monarch-4iy.pages.dev  ·  github.com/brn-mwai/monarch</a:t>
+            </a:r>
+          </a:p>
+        </p:txBody>
+      </p:sp>
+      <p:sp>
+        <p:nvSpPr>
+          <p:cNvPr id="7" name="TextBox 6"/>
+          <p:cNvSpPr txBox="1"/>
+          <p:nvPr/>
+        </p:nvSpPr>
+        <p:spPr>
+          <a:xfrm>
+            <a:off x="685800" y="6291072"/>
+            <a:ext cx="4572000" cy="320040"/>
+          </a:xfrm>
+          <a:prstGeom prst="rect">
+            <a:avLst/>
+          </a:prstGeom>
+          <a:noFill/>
+        </p:spPr>
+        <p:txBody>
+          <a:bodyPr wrap="square" anchor="t">
+            <a:spAutoFit/>
+          </a:bodyPr>
+          <a:lstStyle/>
+          <a:p>
+            <a:pPr algn="l">
+              <a:spcAft>
+                <a:spcPts val="0"/>
+              </a:spcAft>
+            </a:pPr>
+            <a:r>
+              <a:rPr sz="1100" b="0" i="0">
+                <a:solidFill>
+                  <a:srgbClr val="595959"/>
+                </a:solidFill>
+                <a:latin typeface="Calibri"/>
+              </a:rPr>
+              <a:t>Standing</a:t>
+            </a:r>
+          </a:p>
+        </p:txBody>
+      </p:sp>
+      <p:sp>
+        <p:nvSpPr>
+          <p:cNvPr id="8" name="TextBox 7"/>
+          <p:cNvSpPr txBox="1"/>
+          <p:nvPr/>
+        </p:nvSpPr>
+        <p:spPr>
+          <a:xfrm>
+            <a:off x="10591495" y="6291072"/>
+            <a:ext cx="914400" cy="320040"/>
+          </a:xfrm>
+          <a:prstGeom prst="rect">
+            <a:avLst/>
+          </a:prstGeom>
+          <a:noFill/>
+        </p:spPr>
+        <p:txBody>
+          <a:bodyPr wrap="square" anchor="t">
+            <a:spAutoFit/>
+          </a:bodyPr>
+          <a:lstStyle/>
+          <a:p>
+            <a:pPr algn="r">
+              <a:spcAft>
+                <a:spcPts val="0"/>
+              </a:spcAft>
+            </a:pPr>
+            <a:r>
+              <a:rPr sz="1100" b="0" i="0">
+                <a:solidFill>
+                  <a:srgbClr val="595959"/>
+                </a:solidFill>
+                <a:latin typeface="Calibri"/>
+              </a:rPr>
+              <a:t>28</a:t>
+            </a:r>
+          </a:p>
+        </p:txBody>
+      </p:sp>
+    </p:spTree>
+  </p:cSld>
+  <p:clrMapOvr>
+    <a:masterClrMapping/>
+  </p:clrMapOvr>
+</p:sld>
+</file>
+
+<file path=ppt/slides/slide29.xml><?xml version="1.0" encoding="utf-8"?>
+<p:sld xmlns:a="http://schemas.openxmlformats.org/drawingml/2006/main" xmlns:p="http://schemas.openxmlformats.org/presentationml/2006/main" xmlns:r="http://schemas.openxmlformats.org/officeDocument/2006/relationships">
+  <p:cSld>
+    <p:spTree>
+      <p:nvGrpSpPr>
+        <p:cNvPr id="1" name=""/>
+        <p:cNvGrpSpPr/>
+        <p:nvPr/>
+      </p:nvGrpSpPr>
+      <p:grpSpPr/>
       <p:sp>
         <p:nvSpPr>
           <p:cNvPr id="2" name="TextBox 1"/>
@@ -10722,7 +11116,7 @@
                 </a:solidFill>
                 <a:latin typeface="Calibri"/>
               </a:rPr>
-              <a:t>28</a:t>
+              <a:t>29</a:t>
             </a:r>
           </a:p>
         </p:txBody>

</xml_diff>

<commit_message>
Prepare the dissertation for library deposit
Cites every dataset, model and atlas where it is used: ISOT, SemEval-2019
Task 4, Webis-Clickbait-17, PubMed, VADER, Algonauts 2025, Schaefer, Yeo and
the checkpoint audit. The Declaration says the work of others is cited, and
chapters 3 to 7 cited nothing. All 21 references are now cited.

Qualifies the field bound as a statement about the all-to-all mean-field
model, since network structure lowers h_c, and drops the claim that the
bound is conservative, which had the direction backwards. Corrects the VADER
sentence (the ISOT-only interval lies below 0.5), replaces 'human labels'
with the dataset-derived label, reports precision and recall as chapter 4
promises, and attributes the second session's smaller effect to sampling
variation, since both sessions carry the same error.

Fixes the title-page date to September 2026, adds PDF title and author
metadata, and brings the deck's page count and Korbel title into line.
</commit_message>
<xml_diff>
--- a/docs/defence/Monarch_Defence.pptx
+++ b/docs/defence/Monarch_Defence.pptx
@@ -10023,7 +10023,7 @@
                 </a:solidFill>
                 <a:latin typeface="Calibri"/>
               </a:rPr>
-              <a:t>78 pp</a:t>
+              <a:t>81 pp</a:t>
             </a:r>
           </a:p>
           <a:p>
@@ -10990,7 +10990,7 @@
                 </a:solidFill>
                 <a:latin typeface="Calibri"/>
               </a:rPr>
-              <a:t>Korbel, J., Dahdoul, R., Thurner, S. (2026). Critical campaign spending in a double-random field Ising model of elections. Phys. Rev. Lett. 136, 127402.</a:t>
+              <a:t>Korbel, J., Dahdoul, R., Thurner, S. (2026). Empirical validation of the polarization transition in a double-random field model of elections. Phys. Rev. Lett. 136, 127402.</a:t>
             </a:r>
           </a:p>
           <a:p>

</xml_diff>

<commit_message>
Tighten the deck and bring it up to date
Cuts the six densest slides to about half their words, keeping one claim
each, and enlarges the bound figure. Slide 25 now reports the aligned
encoder result instead of saying a pass remains, and the conclusions
follow it. Adds the VADER citation, Hutto and Gilbert and the audit to the
references in order, and corrects the Potthast entry, which named the
ECIR clickbait challenge instead of the COLING corpus paper used. Page
counts and the date are current, and the editable deck matches.
</commit_message>
<xml_diff>
--- a/docs/defence/Monarch_Defence.pptx
+++ b/docs/defence/Monarch_Defence.pptx
@@ -3336,7 +3336,7 @@
                 </a:solidFill>
                 <a:latin typeface="Calibri"/>
               </a:rPr>
-              <a:t>3 September 2026</a:t>
+              <a:t>September 2026</a:t>
             </a:r>
           </a:p>
         </p:txBody>
@@ -3527,7 +3527,7 @@
                 </a:solidFill>
                 <a:latin typeface="Calibri"/>
               </a:rPr>
-              <a:t>Output is (T, 20484). There is no subcortical head.</a:t>
+              <a:t>No subcortical output.</a:t>
             </a:r>
           </a:p>
           <a:p>
@@ -3543,7 +3543,7 @@
                 </a:solidFill>
                 <a:latin typeface="Calibri"/>
               </a:rPr>
-              <a:t>The amygdala is not predicted, so the proposal's central equation cannot be computed.</a:t>
+              <a:t>No amygdala, so the proposal's equation cannot be computed.</a:t>
             </a:r>
           </a:p>
         </p:txBody>
@@ -3614,7 +3614,7 @@
                 </a:solidFill>
                 <a:latin typeface="Calibri"/>
               </a:rPr>
-              <a:t>The loader forces average_subjects.</a:t>
+              <a:t>The loader forces it.</a:t>
             </a:r>
           </a:p>
           <a:p>
@@ -3630,7 +3630,7 @@
                 </a:solidFill>
                 <a:latin typeface="Calibri"/>
               </a:rPr>
-              <a:t>It predicts a typical viewer. Whether that carries signal is the third paper's question.</a:t>
+              <a:t>It predicts a typical viewer, which Paper 3 tests.</a:t>
             </a:r>
           </a:p>
         </p:txBody>
@@ -3701,7 +3701,7 @@
                 </a:solidFill>
                 <a:latin typeface="Calibri"/>
               </a:rPr>
-              <a:t>Region means sit near zero, so a ratio sign-flips or explodes.</a:t>
+              <a:t>Means sit near zero, so a ratio breaks.</a:t>
             </a:r>
           </a:p>
           <a:p>
@@ -3717,7 +3717,7 @@
                 </a:solidFill>
                 <a:latin typeface="Calibri"/>
               </a:rPr>
-              <a:t>Undefined for 69 of 400 items. Replaced by the difference.</a:t>
+              <a:t>Undefined for 69 of 400 items; the difference replaces it.</a:t>
             </a:r>
           </a:p>
         </p:txBody>
@@ -3756,7 +3756,7 @@
                 </a:solidFill>
                 <a:latin typeface="Calibri"/>
               </a:rPr>
-              <a:t>Each was found by testing the artifact, and each is stated in the abstract rather than the limitations.</a:t>
+              <a:t>All three were found by testing the checkpoint, before any result.</a:t>
             </a:r>
           </a:p>
         </p:txBody>
@@ -5185,7 +5185,7 @@
         <p:spPr>
           <a:xfrm>
             <a:off x="9402775" y="1728216"/>
-            <a:ext cx="2926080" cy="411480"/>
+            <a:ext cx="2651760" cy="411480"/>
           </a:xfrm>
           <a:prstGeom prst="rect">
             <a:avLst/>
@@ -5307,7 +5307,7 @@
         <p:spPr>
           <a:xfrm>
             <a:off x="5434279" y="2505456"/>
-            <a:ext cx="2926080" cy="411480"/>
+            <a:ext cx="2651760" cy="411480"/>
           </a:xfrm>
           <a:prstGeom prst="rect">
             <a:avLst/>
@@ -5429,7 +5429,7 @@
         <p:spPr>
           <a:xfrm>
             <a:off x="3584448" y="3282696"/>
-            <a:ext cx="2926080" cy="411480"/>
+            <a:ext cx="2651760" cy="411480"/>
           </a:xfrm>
           <a:prstGeom prst="rect">
             <a:avLst/>
@@ -6806,13 +6806,13 @@
               </a:spcAft>
             </a:pPr>
             <a:r>
-              <a:rPr sz="1700" b="0" i="0">
+              <a:rPr sz="1800" b="0" i="0">
                 <a:solidFill>
                   <a:srgbClr val="1A1A1A"/>
                 </a:solidFill>
                 <a:latin typeface="Calibri"/>
               </a:rPr>
-              <a:t>Same 400 rows, same pre-scan label. Sentiment (VADER) does not clear chance, 0.5392. On the 150 ISOT items, the one source carrying both classes, TF-IDF still reaches 0.9724. A probe on the same words recovers the source dataset at 66.25% against 25% chance, so much of the lexical win is provenance.</a:t>
+              <a:t>Same 400 rows, same label. Sentiment (VADER) sits at chance, 0.5392. The same words guess the source 66% of the time against 25% chance, so much of the lexical win is provenance.</a:t>
             </a:r>
           </a:p>
         </p:txBody>
@@ -6825,7 +6825,7 @@
         </p:nvSpPr>
         <p:spPr>
           <a:xfrm>
-            <a:off x="685800" y="4846320"/>
+            <a:off x="685800" y="4663440"/>
             <a:ext cx="10820095" cy="731520"/>
           </a:xfrm>
           <a:prstGeom prst="rect">
@@ -6851,7 +6851,7 @@
                 </a:solidFill>
                 <a:latin typeface="Calibri"/>
               </a:rPr>
-              <a:t>The index is carried forward as the field observable the physics needs, not as a detector.</a:t>
+              <a:t>The index is a field observable for the physics, not a detector.</a:t>
             </a:r>
           </a:p>
         </p:txBody>
@@ -6864,8 +6864,8 @@
         </p:nvSpPr>
         <p:spPr>
           <a:xfrm>
-            <a:off x="685800" y="6291072"/>
-            <a:ext cx="4572000" cy="320040"/>
+            <a:off x="685800" y="5897880"/>
+            <a:ext cx="10820095" cy="384048"/>
           </a:xfrm>
           <a:prstGeom prst="rect">
             <a:avLst/>
@@ -6890,6 +6890,45 @@
                 </a:solidFill>
                 <a:latin typeface="Calibri"/>
               </a:rPr>
+              <a:t>Hutto &amp; Gilbert (2014), VADER.</a:t>
+            </a:r>
+          </a:p>
+        </p:txBody>
+      </p:sp>
+      <p:sp>
+        <p:nvSpPr>
+          <p:cNvPr id="11" name="TextBox 10"/>
+          <p:cNvSpPr txBox="1"/>
+          <p:nvPr/>
+        </p:nvSpPr>
+        <p:spPr>
+          <a:xfrm>
+            <a:off x="685800" y="6291072"/>
+            <a:ext cx="4572000" cy="320040"/>
+          </a:xfrm>
+          <a:prstGeom prst="rect">
+            <a:avLst/>
+          </a:prstGeom>
+          <a:noFill/>
+        </p:spPr>
+        <p:txBody>
+          <a:bodyPr wrap="square" anchor="t">
+            <a:spAutoFit/>
+          </a:bodyPr>
+          <a:lstStyle/>
+          <a:p>
+            <a:pPr algn="l">
+              <a:spcAft>
+                <a:spcPts val="0"/>
+              </a:spcAft>
+            </a:pPr>
+            <a:r>
+              <a:rPr sz="1100" b="0" i="0">
+                <a:solidFill>
+                  <a:srgbClr val="595959"/>
+                </a:solidFill>
+                <a:latin typeface="Calibri"/>
+              </a:rPr>
               <a:t>The measurement</a:t>
             </a:r>
           </a:p>
@@ -6897,7 +6936,7 @@
       </p:sp>
       <p:sp>
         <p:nvSpPr>
-          <p:cNvPr id="11" name="TextBox 10"/>
+          <p:cNvPr id="12" name="TextBox 11"/>
           <p:cNvSpPr txBox="1"/>
           <p:nvPr/>
         </p:nvSpPr>
@@ -7121,13 +7160,13 @@
               </a:spcAft>
             </a:pPr>
             <a:r>
-              <a:rPr sz="1700" b="0" i="0">
+              <a:rPr sz="1800" b="0" i="0">
                 <a:solidFill>
                   <a:srgbClr val="1A1A1A"/>
                 </a:solidFill>
                 <a:latin typeface="Calibri"/>
               </a:rPr>
-              <a:t>The separation replicates: 0.0888 on the second session against 0.1068 on the first. Both clear the detectable floor.</a:t>
+              <a:t>The separation replicates: η² = 0.0888 against 0.1068.</a:t>
             </a:r>
           </a:p>
         </p:txBody>
@@ -7238,13 +7277,13 @@
               </a:spcAft>
             </a:pPr>
             <a:r>
-              <a:rPr sz="1700" b="0" i="0">
+              <a:rPr sz="1800" b="0" i="0">
                 <a:solidFill>
                   <a:srgbClr val="1A1A1A"/>
                 </a:solidFill>
                 <a:latin typeface="Calibri"/>
               </a:rPr>
-              <a:t>51 of 400 items flip sign between sessions, so no verdict on one article appears anywhere in the analysis, the figures or the public site.</a:t>
+              <a:t>51 of 400. Noise alone predicts 55, so no verdict on one article is ever made.</a:t>
             </a:r>
           </a:p>
         </p:txBody>
@@ -7257,8 +7296,8 @@
         </p:nvSpPr>
         <p:spPr>
           <a:xfrm>
-            <a:off x="685800" y="4892040"/>
-            <a:ext cx="10820095" cy="822960"/>
+            <a:off x="685800" y="6291072"/>
+            <a:ext cx="4572000" cy="320040"/>
           </a:xfrm>
           <a:prstGeom prst="rect">
             <a:avLst/>
@@ -7277,13 +7316,13 @@
               </a:spcAft>
             </a:pPr>
             <a:r>
-              <a:rPr sz="1700" b="0" i="0">
+              <a:rPr sz="1100" b="0" i="0">
                 <a:solidFill>
                   <a:srgbClr val="595959"/>
                 </a:solidFill>
                 <a:latin typeface="Calibri"/>
               </a:rPr>
-              <a:t>Additive noise at the measured session error predicts 55.3 reversals, 95% [44, 67]; 51 are observed. Reversing items sit near zero and spread evenly across categories.</a:t>
+              <a:t>The measurement</a:t>
             </a:r>
           </a:p>
         </p:txBody>
@@ -7291,45 +7330,6 @@
       <p:sp>
         <p:nvSpPr>
           <p:cNvPr id="11" name="TextBox 10"/>
-          <p:cNvSpPr txBox="1"/>
-          <p:nvPr/>
-        </p:nvSpPr>
-        <p:spPr>
-          <a:xfrm>
-            <a:off x="685800" y="6291072"/>
-            <a:ext cx="4572000" cy="320040"/>
-          </a:xfrm>
-          <a:prstGeom prst="rect">
-            <a:avLst/>
-          </a:prstGeom>
-          <a:noFill/>
-        </p:spPr>
-        <p:txBody>
-          <a:bodyPr wrap="square" anchor="t">
-            <a:spAutoFit/>
-          </a:bodyPr>
-          <a:lstStyle/>
-          <a:p>
-            <a:pPr algn="l">
-              <a:spcAft>
-                <a:spcPts val="0"/>
-              </a:spcAft>
-            </a:pPr>
-            <a:r>
-              <a:rPr sz="1100" b="0" i="0">
-                <a:solidFill>
-                  <a:srgbClr val="595959"/>
-                </a:solidFill>
-                <a:latin typeface="Calibri"/>
-              </a:rPr>
-              <a:t>The measurement</a:t>
-            </a:r>
-          </a:p>
-        </p:txBody>
-      </p:sp>
-      <p:sp>
-        <p:nvSpPr>
-          <p:cNvPr id="12" name="TextBox 11"/>
           <p:cNvSpPr txBox="1"/>
           <p:nvPr/>
         </p:nvSpPr>
@@ -7996,7 +7996,7 @@
                 </a:solidFill>
                 <a:latin typeface="Calibri"/>
               </a:rPr>
-              <a:t>Each person holds an opinion ±1, is pulled toward their neighbours with strength J, and is pushed by media with field h:</a:t>
+              <a:t>Each person holds an opinion ±1, is pulled toward neighbours by J, and pushed by media with field h = αX, where X is the measured observable:</a:t>
             </a:r>
           </a:p>
         </p:txBody>
@@ -8009,7 +8009,7 @@
         </p:nvSpPr>
         <p:spPr>
           <a:xfrm>
-            <a:off x="685800" y="2240280"/>
+            <a:off x="685800" y="2377440"/>
             <a:ext cx="10820095" cy="640080"/>
           </a:xfrm>
           <a:prstGeom prst="rect">
@@ -8035,7 +8035,7 @@
                 </a:solidFill>
                 <a:latin typeface="Calibri"/>
               </a:rPr>
-              <a:t>m  =  tanh( βJ m + h ),        h  =  α X</a:t>
+              <a:t>m  =  tanh( βJ m + h )</a:t>
             </a:r>
           </a:p>
         </p:txBody>
@@ -8048,8 +8048,8 @@
         </p:nvSpPr>
         <p:spPr>
           <a:xfrm>
-            <a:off x="685800" y="2971800"/>
-            <a:ext cx="10820095" cy="731520"/>
+            <a:off x="685800" y="3200400"/>
+            <a:ext cx="10820095" cy="640080"/>
           </a:xfrm>
           <a:prstGeom prst="rect">
             <a:avLst/>
@@ -8062,19 +8062,19 @@
           </a:bodyPr>
           <a:lstStyle/>
           <a:p>
-            <a:pPr algn="l">
-              <a:spcAft>
-                <a:spcPts val="0"/>
-              </a:spcAft>
-            </a:pPr>
-            <a:r>
-              <a:rPr sz="1900" b="0" i="0">
-                <a:solidFill>
-                  <a:srgbClr val="1A1A1A"/>
-                </a:solidFill>
-                <a:latin typeface="Calibri"/>
-              </a:rPr>
-              <a:t>where X is the measured observable and α the unknown coupling. Expanding artanh(m) ≈ m + m³/3:</a:t>
+            <a:pPr algn="ctr">
+              <a:spcAft>
+                <a:spcPts val="0"/>
+              </a:spcAft>
+            </a:pPr>
+            <a:r>
+              <a:rPr sz="2400" b="1" i="0">
+                <a:solidFill>
+                  <a:srgbClr val="1F4E79"/>
+                </a:solidFill>
+                <a:latin typeface="Calibri"/>
+              </a:rPr>
+              <a:t>F(m) = a m² + b m⁴ − h m,        a = (1 − βJ)/2,        b = 1/12</a:t>
             </a:r>
           </a:p>
         </p:txBody>
@@ -8087,8 +8087,8 @@
         </p:nvSpPr>
         <p:spPr>
           <a:xfrm>
-            <a:off x="685800" y="3657600"/>
-            <a:ext cx="10820095" cy="640080"/>
+            <a:off x="685800" y="4251960"/>
+            <a:ext cx="10820095" cy="1097280"/>
           </a:xfrm>
           <a:prstGeom prst="rect">
             <a:avLst/>
@@ -8101,19 +8101,19 @@
           </a:bodyPr>
           <a:lstStyle/>
           <a:p>
-            <a:pPr algn="ctr">
-              <a:spcAft>
-                <a:spcPts val="0"/>
-              </a:spcAft>
-            </a:pPr>
-            <a:r>
-              <a:rPr sz="2400" b="1" i="0">
-                <a:solidFill>
-                  <a:srgbClr val="1F4E79"/>
-                </a:solidFill>
-                <a:latin typeface="Calibri"/>
-              </a:rPr>
-              <a:t>F(m) = a m² + b m⁴ − h m,        a = (1 − βJ)/2,        b = 1/12</a:t>
+            <a:pPr algn="l">
+              <a:spcAft>
+                <a:spcPts val="0"/>
+              </a:spcAft>
+            </a:pPr>
+            <a:r>
+              <a:rPr sz="1800" b="0" i="0">
+                <a:solidFill>
+                  <a:srgbClr val="595959"/>
+                </a:solidFill>
+                <a:latin typeface="Calibri"/>
+              </a:rPr>
+              <a:t>Coefficients derived, not assumed; this corrects the proposal's a and b. The solver recovers the mean-field exponents.</a:t>
             </a:r>
           </a:p>
         </p:txBody>
@@ -8126,8 +8126,8 @@
         </p:nvSpPr>
         <p:spPr>
           <a:xfrm>
-            <a:off x="685800" y="4434840"/>
-            <a:ext cx="10820095" cy="1097280"/>
+            <a:off x="685800" y="6291072"/>
+            <a:ext cx="4572000" cy="320040"/>
           </a:xfrm>
           <a:prstGeom prst="rect">
             <a:avLst/>
@@ -8146,22 +8146,13 @@
               </a:spcAft>
             </a:pPr>
             <a:r>
-              <a:rPr sz="1700" b="1">
+              <a:rPr sz="1100" b="0" i="0">
                 <a:solidFill>
                   <a:srgbClr val="595959"/>
                 </a:solidFill>
                 <a:latin typeface="Calibri"/>
               </a:rPr>
-              <a:t>Coefficients derived from the self-consistency condition. </a:t>
-            </a:r>
-            <a:r>
-              <a:rPr sz="1700" b="0">
-                <a:solidFill>
-                  <a:srgbClr val="595959"/>
-                </a:solidFill>
-                <a:latin typeface="Calibri"/>
-              </a:rPr>
-              <a:t>The proposal carried a = 1 − βJ, b = (βJ)³/3, which do not follow from it. The solver reproduces the exact exponents 1/2, 1 and 3.</a:t>
+              <a:t>The physics</a:t>
             </a:r>
           </a:p>
         </p:txBody>
@@ -8169,45 +8160,6 @@
       <p:sp>
         <p:nvSpPr>
           <p:cNvPr id="9" name="TextBox 8"/>
-          <p:cNvSpPr txBox="1"/>
-          <p:nvPr/>
-        </p:nvSpPr>
-        <p:spPr>
-          <a:xfrm>
-            <a:off x="685800" y="6291072"/>
-            <a:ext cx="4572000" cy="320040"/>
-          </a:xfrm>
-          <a:prstGeom prst="rect">
-            <a:avLst/>
-          </a:prstGeom>
-          <a:noFill/>
-        </p:spPr>
-        <p:txBody>
-          <a:bodyPr wrap="square" anchor="t">
-            <a:spAutoFit/>
-          </a:bodyPr>
-          <a:lstStyle/>
-          <a:p>
-            <a:pPr algn="l">
-              <a:spcAft>
-                <a:spcPts val="0"/>
-              </a:spcAft>
-            </a:pPr>
-            <a:r>
-              <a:rPr sz="1100" b="0" i="0">
-                <a:solidFill>
-                  <a:srgbClr val="595959"/>
-                </a:solidFill>
-                <a:latin typeface="Calibri"/>
-              </a:rPr>
-              <a:t>The physics</a:t>
-            </a:r>
-          </a:p>
-        </p:txBody>
-      </p:sp>
-      <p:sp>
-        <p:nvSpPr>
-          <p:cNvPr id="10" name="TextBox 9"/>
           <p:cNvSpPr txBox="1"/>
           <p:nvPr/>
         </p:nvSpPr>
@@ -8334,7 +8286,7 @@
         <p:spPr>
           <a:xfrm>
             <a:off x="685800" y="1600200"/>
-            <a:ext cx="6035040" cy="3291840"/>
+            <a:ext cx="10820095" cy="3474720"/>
           </a:xfrm>
           <a:prstGeom prst="rect">
             <a:avLst/>
@@ -8349,7 +8301,7 @@
           <a:p>
             <a:pPr algn="l">
               <a:spcAft>
-                <a:spcPts val="1400"/>
+                <a:spcPts val="1600"/>
               </a:spcAft>
             </a:pPr>
             <a:r>
@@ -8359,7 +8311,7 @@
                 </a:solidFill>
                 <a:latin typeface="Calibri"/>
               </a:rPr>
-              <a:t>What was tried. </a:t>
+              <a:t>Tried. </a:t>
             </a:r>
             <a:r>
               <a:rPr sz="2000" b="0">
@@ -8368,13 +8320,13 @@
                 </a:solidFill>
                 <a:latin typeface="Calibri"/>
               </a:rPr>
-              <a:t>Regress the outcome on the measured index and read off α.</a:t>
+              <a:t>Fit the outcome to the measured index and read off α.</a:t>
             </a:r>
           </a:p>
           <a:p>
             <a:pPr>
               <a:spcAft>
-                <a:spcPts val="1400"/>
+                <a:spcPts val="1600"/>
               </a:spcAft>
             </a:pPr>
             <a:r>
@@ -8384,7 +8336,7 @@
                 </a:solidFill>
                 <a:latin typeface="Calibri"/>
               </a:rPr>
-              <a:t>What happened. </a:t>
+              <a:t>Result. </a:t>
             </a:r>
             <a:r>
               <a:rPr sz="2000" b="0">
@@ -8393,13 +8345,13 @@
                 </a:solidFill>
                 <a:latin typeface="Calibri"/>
               </a:rPr>
-              <a:t>The fit performs worse than the sample mean out of sample, and the estimate scales inversely with a coupling βJ that no measurement here fixes.</a:t>
+              <a:t>Out of sample the fit does worse than the average, and the estimate depends on βJ, which nothing here measures.</a:t>
             </a:r>
           </a:p>
           <a:p>
             <a:pPr>
               <a:spcAft>
-                <a:spcPts val="0"/>
+                <a:spcPts val="2000"/>
               </a:spcAft>
             </a:pPr>
             <a:r>
@@ -8409,7 +8361,23 @@
                 </a:solidFill>
                 <a:latin typeface="Calibri"/>
               </a:rPr>
-              <a:t>So no value of α-hat appears anywhere — not in a table, a caption, or “for illustration”.</a:t>
+              <a:t>So no value of α is quoted anywhere.</a:t>
+            </a:r>
+          </a:p>
+          <a:p>
+            <a:pPr>
+              <a:spcAft>
+                <a:spcPts val="0"/>
+              </a:spcAft>
+            </a:pPr>
+            <a:r>
+              <a:rPr sz="1800" b="0" i="0">
+                <a:solidFill>
+                  <a:srgbClr val="595959"/>
+                </a:solidFill>
+                <a:latin typeface="Calibri"/>
+              </a:rPr>
+              <a:t>What replaces it needs no fit at all: the bound on the next slide.</a:t>
             </a:r>
           </a:p>
         </p:txBody>
@@ -8422,8 +8390,8 @@
         </p:nvSpPr>
         <p:spPr>
           <a:xfrm>
-            <a:off x="7360920" y="1691640"/>
-            <a:ext cx="4160520" cy="2743200"/>
+            <a:off x="685800" y="6291072"/>
+            <a:ext cx="4572000" cy="320040"/>
           </a:xfrm>
           <a:prstGeom prst="rect">
             <a:avLst/>
@@ -8438,33 +8406,17 @@
           <a:p>
             <a:pPr algn="l">
               <a:spcAft>
-                <a:spcPts val="1400"/>
-              </a:spcAft>
-            </a:pPr>
-            <a:r>
-              <a:rPr sz="1700" b="0" i="0">
+                <a:spcPts val="0"/>
+              </a:spcAft>
+            </a:pPr>
+            <a:r>
+              <a:rPr sz="1100" b="0" i="0">
                 <a:solidFill>
                   <a:srgbClr val="595959"/>
                 </a:solidFill>
                 <a:latin typeface="Calibri"/>
               </a:rPr>
-              <a:t>Reporting an unidentified coupling as though it were measured would be the failure here. Declining to quote it is not.</a:t>
-            </a:r>
-          </a:p>
-          <a:p>
-            <a:pPr>
-              <a:spcAft>
-                <a:spcPts val="0"/>
-              </a:spcAft>
-            </a:pPr>
-            <a:r>
-              <a:rPr sz="1700" b="0" i="0">
-                <a:solidFill>
-                  <a:srgbClr val="595959"/>
-                </a:solidFill>
-                <a:latin typeface="Calibri"/>
-              </a:rPr>
-              <a:t>What replaces it is a statement that does not need the fit at all.</a:t>
+              <a:t>The physics</a:t>
             </a:r>
           </a:p>
         </p:txBody>
@@ -8472,45 +8424,6 @@
       <p:sp>
         <p:nvSpPr>
           <p:cNvPr id="6" name="TextBox 5"/>
-          <p:cNvSpPr txBox="1"/>
-          <p:nvPr/>
-        </p:nvSpPr>
-        <p:spPr>
-          <a:xfrm>
-            <a:off x="685800" y="6291072"/>
-            <a:ext cx="4572000" cy="320040"/>
-          </a:xfrm>
-          <a:prstGeom prst="rect">
-            <a:avLst/>
-          </a:prstGeom>
-          <a:noFill/>
-        </p:spPr>
-        <p:txBody>
-          <a:bodyPr wrap="square" anchor="t">
-            <a:spAutoFit/>
-          </a:bodyPr>
-          <a:lstStyle/>
-          <a:p>
-            <a:pPr algn="l">
-              <a:spcAft>
-                <a:spcPts val="0"/>
-              </a:spcAft>
-            </a:pPr>
-            <a:r>
-              <a:rPr sz="1100" b="0" i="0">
-                <a:solidFill>
-                  <a:srgbClr val="595959"/>
-                </a:solidFill>
-                <a:latin typeface="Calibri"/>
-              </a:rPr>
-              <a:t>The physics</a:t>
-            </a:r>
-          </a:p>
-        </p:txBody>
-      </p:sp>
-      <p:sp>
-        <p:nvSpPr>
-          <p:cNvPr id="7" name="TextBox 6"/>
           <p:cNvSpPr txBox="1"/>
           <p:nvPr/>
         </p:nvSpPr>
@@ -8644,8 +8557,8 @@
         </p:blipFill>
         <p:spPr>
           <a:xfrm>
-            <a:off x="685800" y="1463040"/>
-            <a:ext cx="4618191" cy="3154680"/>
+            <a:off x="685800" y="1325880"/>
+            <a:ext cx="5889867" cy="4023360"/>
           </a:xfrm>
           <a:prstGeom prst="rect">
             <a:avLst/>
@@ -8660,8 +8573,8 @@
         </p:nvSpPr>
         <p:spPr>
           <a:xfrm>
-            <a:off x="6720840" y="1737360"/>
-            <a:ext cx="4800600" cy="822960"/>
+            <a:off x="6949440" y="1737360"/>
+            <a:ext cx="4572000" cy="822960"/>
           </a:xfrm>
           <a:prstGeom prst="rect">
             <a:avLst/>
@@ -8717,8 +8630,8 @@
         </p:nvSpPr>
         <p:spPr>
           <a:xfrm>
-            <a:off x="6720840" y="2697480"/>
-            <a:ext cx="4800600" cy="1920240"/>
+            <a:off x="6949440" y="2743200"/>
+            <a:ext cx="4572000" cy="2377440"/>
           </a:xfrm>
           <a:prstGeom prst="rect">
             <a:avLst/>
@@ -8733,7 +8646,7 @@
           <a:p>
             <a:pPr algn="l">
               <a:spcAft>
-                <a:spcPts val="0"/>
+                <a:spcPts val="1400"/>
               </a:spcAft>
             </a:pPr>
             <a:r>
@@ -8743,7 +8656,32 @@
                 </a:solidFill>
                 <a:latin typeface="Calibri"/>
               </a:rPr>
-              <a:t>Rather than fitting α and hoping it clears zero, this states what α would have to be for the mechanism to work at all — for any candidate observable, before a corpus exists.</a:t>
+              <a:t>What α would have to be for media to tip opinion, for any observable, before any data. Within the mean-field model.</a:t>
+            </a:r>
+          </a:p>
+          <a:p>
+            <a:pPr>
+              <a:spcAft>
+                <a:spcPts val="0"/>
+              </a:spcAft>
+            </a:pPr>
+            <a:r>
+              <a:rPr sz="1800" b="0">
+                <a:solidFill>
+                  <a:srgbClr val="1A1A1A"/>
+                </a:solidFill>
+                <a:latin typeface="Calibri"/>
+              </a:rPr>
+              <a:t>Measured ΔX = 0.1241 gives </a:t>
+            </a:r>
+            <a:r>
+              <a:rPr sz="1800" b="1">
+                <a:solidFill>
+                  <a:srgbClr val="C0392B"/>
+                </a:solidFill>
+                <a:latin typeface="Calibri"/>
+              </a:rPr>
+              <a:t>α ≥ 4.29 at βJ = 2.</a:t>
             </a:r>
           </a:p>
         </p:txBody>
@@ -8756,8 +8694,8 @@
         </p:nvSpPr>
         <p:spPr>
           <a:xfrm>
-            <a:off x="685800" y="4892040"/>
-            <a:ext cx="10820095" cy="640080"/>
+            <a:off x="685800" y="6291072"/>
+            <a:ext cx="4572000" cy="320040"/>
           </a:xfrm>
           <a:prstGeom prst="rect">
             <a:avLst/>
@@ -8770,28 +8708,19 @@
           </a:bodyPr>
           <a:lstStyle/>
           <a:p>
-            <a:pPr algn="ctr">
-              <a:spcAft>
-                <a:spcPts val="0"/>
-              </a:spcAft>
-            </a:pPr>
-            <a:r>
-              <a:rPr sz="1800" b="0">
-                <a:solidFill>
-                  <a:srgbClr val="1A1A1A"/>
-                </a:solidFill>
-                <a:latin typeface="Calibri"/>
-              </a:rPr>
-              <a:t>Measured spread ΔX = 0.1241  ⇒  α ≥ 0.169 at βJ = 1.10,   1.655 at 1.50,   </a:t>
-            </a:r>
-            <a:r>
-              <a:rPr sz="1800" b="1">
-                <a:solidFill>
-                  <a:srgbClr val="1F4E79"/>
-                </a:solidFill>
-                <a:latin typeface="Calibri"/>
-              </a:rPr>
-              <a:t>4.294 at 2.00</a:t>
+            <a:pPr algn="l">
+              <a:spcAft>
+                <a:spcPts val="0"/>
+              </a:spcAft>
+            </a:pPr>
+            <a:r>
+              <a:rPr sz="1100" b="0" i="0">
+                <a:solidFill>
+                  <a:srgbClr val="595959"/>
+                </a:solidFill>
+                <a:latin typeface="Calibri"/>
+              </a:rPr>
+              <a:t>The physics</a:t>
             </a:r>
           </a:p>
         </p:txBody>
@@ -8799,45 +8728,6 @@
       <p:sp>
         <p:nvSpPr>
           <p:cNvPr id="8" name="TextBox 7"/>
-          <p:cNvSpPr txBox="1"/>
-          <p:nvPr/>
-        </p:nvSpPr>
-        <p:spPr>
-          <a:xfrm>
-            <a:off x="685800" y="6291072"/>
-            <a:ext cx="4572000" cy="320040"/>
-          </a:xfrm>
-          <a:prstGeom prst="rect">
-            <a:avLst/>
-          </a:prstGeom>
-          <a:noFill/>
-        </p:spPr>
-        <p:txBody>
-          <a:bodyPr wrap="square" anchor="t">
-            <a:spAutoFit/>
-          </a:bodyPr>
-          <a:lstStyle/>
-          <a:p>
-            <a:pPr algn="l">
-              <a:spcAft>
-                <a:spcPts val="0"/>
-              </a:spcAft>
-            </a:pPr>
-            <a:r>
-              <a:rPr sz="1100" b="0" i="0">
-                <a:solidFill>
-                  <a:srgbClr val="595959"/>
-                </a:solidFill>
-                <a:latin typeface="Calibri"/>
-              </a:rPr>
-              <a:t>The physics</a:t>
-            </a:r>
-          </a:p>
-        </p:txBody>
-      </p:sp>
-      <p:sp>
-        <p:nvSpPr>
-          <p:cNvPr id="9" name="TextBox 8"/>
           <p:cNvSpPr txBox="1"/>
           <p:nvPr/>
         </p:nvSpPr>
@@ -9063,7 +8953,7 @@
                 </a:solidFill>
                 <a:latin typeface="Calibri"/>
               </a:rPr>
-              <a:t>Whether the encoder tracks real cortex is measurable, and one pass remains</a:t>
+              <a:t>Against real brains the encoder is weakly positive, not anti-correlated</a:t>
             </a:r>
           </a:p>
         </p:txBody>
@@ -9102,7 +8992,7 @@
                 </a:solidFill>
                 <a:latin typeface="Calibri"/>
               </a:rPr>
-              <a:t>A commercial lab reports the released checkpoint, in the averaged configuration this project runs, is anti-correlated with real cortex. Four subjects, one stimulus, not independently replicated.</a:t>
+              <a:t>A company audit says the checkpoint this project runs is anti-correlated with real cortex. Tested here on public fMRI:</a:t>
             </a:r>
           </a:p>
         </p:txBody>
@@ -9115,8 +9005,8 @@
         </p:nvSpPr>
         <p:spPr>
           <a:xfrm>
-            <a:off x="1600200" y="2514600"/>
-            <a:ext cx="4114800" cy="1417320"/>
+            <a:off x="822960" y="2514600"/>
+            <a:ext cx="3246120" cy="1508760"/>
           </a:xfrm>
           <a:prstGeom prst="roundRect">
             <a:avLst>
@@ -9179,7 +9069,7 @@
                 </a:solidFill>
                 <a:latin typeface="Calibri"/>
               </a:rPr>
-              <a:t>measured noise ceiling</a:t>
+              <a:t>noise ceiling</a:t>
             </a:r>
           </a:p>
           <a:p>
@@ -9195,7 +9085,7 @@
                 </a:solidFill>
                 <a:latin typeface="Calibri"/>
               </a:rPr>
-              <a:t>CI [0.1484, 0.1551], 4 subjects, 1000 parcels</a:t>
+              <a:t>full episode, 4 subjects</a:t>
             </a:r>
           </a:p>
         </p:txBody>
@@ -9208,8 +9098,101 @@
         </p:nvSpPr>
         <p:spPr>
           <a:xfrm>
-            <a:off x="6446520" y="2514600"/>
-            <a:ext cx="4114800" cy="1417320"/>
+            <a:off x="4480560" y="2514600"/>
+            <a:ext cx="3246120" cy="1508760"/>
+          </a:xfrm>
+          <a:prstGeom prst="roundRect">
+            <a:avLst>
+              <a:gd name="adj" fmla="val 6000"/>
+            </a:avLst>
+          </a:prstGeom>
+          <a:solidFill>
+            <a:srgbClr val="FFFFFF"/>
+          </a:solidFill>
+          <a:ln w="15875">
+            <a:solidFill>
+              <a:srgbClr val="1F4E79"/>
+            </a:solidFill>
+          </a:ln>
+          <a:effectLst/>
+        </p:spPr>
+        <p:style>
+          <a:lnRef idx="1">
+            <a:schemeClr val="accent1"/>
+          </a:lnRef>
+          <a:fillRef idx="3">
+            <a:schemeClr val="accent1"/>
+          </a:fillRef>
+          <a:effectRef idx="2">
+            <a:schemeClr val="accent1"/>
+          </a:effectRef>
+          <a:fontRef idx="minor">
+            <a:schemeClr val="lt1"/>
+          </a:fontRef>
+        </p:style>
+        <p:txBody>
+          <a:bodyPr rtlCol="0" anchor="ctr" wrap="square"/>
+          <a:lstStyle/>
+          <a:p>
+            <a:pPr algn="ctr">
+              <a:spcAft>
+                <a:spcPts val="200"/>
+              </a:spcAft>
+            </a:pPr>
+            <a:r>
+              <a:rPr sz="3000" b="1" i="0">
+                <a:solidFill>
+                  <a:srgbClr val="1F4E79"/>
+                </a:solidFill>
+                <a:latin typeface="Calibri"/>
+              </a:rPr>
+              <a:t>+0.028</a:t>
+            </a:r>
+          </a:p>
+          <a:p>
+            <a:pPr algn="ctr">
+              <a:spcAft>
+                <a:spcPts val="200"/>
+              </a:spcAft>
+            </a:pPr>
+            <a:r>
+              <a:rPr sz="1600" b="0" i="0">
+                <a:solidFill>
+                  <a:srgbClr val="1A1A1A"/>
+                </a:solidFill>
+                <a:latin typeface="Calibri"/>
+              </a:rPr>
+              <a:t>encoder vs brains</a:t>
+            </a:r>
+          </a:p>
+          <a:p>
+            <a:pPr algn="ctr">
+              <a:spcAft>
+                <a:spcPts val="0"/>
+              </a:spcAft>
+            </a:pPr>
+            <a:r>
+              <a:rPr sz="1200" b="0" i="0">
+                <a:solidFill>
+                  <a:srgbClr val="595959"/>
+                </a:solidFill>
+                <a:latin typeface="Calibri"/>
+              </a:rPr>
+              <a:t>ceiling 0.096 on the same 80 scans, p = 0.048</a:t>
+            </a:r>
+          </a:p>
+        </p:txBody>
+      </p:sp>
+      <p:sp>
+        <p:nvSpPr>
+          <p:cNvPr id="7" name="Rounded Rectangle 6"/>
+          <p:cNvSpPr/>
+          <p:nvPr/>
+        </p:nvSpPr>
+        <p:spPr>
+          <a:xfrm>
+            <a:off x="8138160" y="2514600"/>
+            <a:ext cx="3246120" cy="1508760"/>
           </a:xfrm>
           <a:prstGeom prst="roundRect">
             <a:avLst>
@@ -9256,7 +9239,7 @@
                 </a:solidFill>
                 <a:latin typeface="Calibri"/>
               </a:rPr>
-              <a:t>0.2247</a:t>
+              <a:t>3 bugs</a:t>
             </a:r>
           </a:p>
           <a:p>
@@ -9272,7 +9255,7 @@
                 </a:solidFill>
                 <a:latin typeface="Calibri"/>
               </a:rPr>
-              <a:t>withdrawn</a:t>
+              <a:t>silent, found, fixed</a:t>
             </a:r>
           </a:p>
           <a:p>
@@ -9288,20 +9271,20 @@
                 </a:solidFill>
                 <a:latin typeface="Calibri"/>
               </a:rPr>
-              <a:t>an episode picked by position, and a guard that could not fire</a:t>
-            </a:r>
-          </a:p>
-        </p:txBody>
-      </p:sp>
-      <p:sp>
-        <p:nvSpPr>
-          <p:cNvPr id="7" name="TextBox 6"/>
+              <a:t>wrong episode, flipped array, two clocks</a:t>
+            </a:r>
+          </a:p>
+        </p:txBody>
+      </p:sp>
+      <p:sp>
+        <p:nvSpPr>
+          <p:cNvPr id="8" name="TextBox 7"/>
           <p:cNvSpPr txBox="1"/>
           <p:nvPr/>
         </p:nvSpPr>
         <p:spPr>
           <a:xfrm>
-            <a:off x="685800" y="4160520"/>
+            <a:off x="685800" y="4343400"/>
             <a:ext cx="10820095" cy="914400"/>
           </a:xfrm>
           <a:prstGeom prst="rect">
@@ -9327,14 +9310,14 @@
                 </a:solidFill>
                 <a:latin typeface="Calibri"/>
               </a:rPr>
-              <a:t>Replaying the old code path reproduces the wrong number exactly, which proved the cause. Both defects were silent: nothing crashed.</a:t>
-            </a:r>
-          </a:p>
-        </p:txBody>
-      </p:sp>
-      <p:sp>
-        <p:nvSpPr>
-          <p:cNvPr id="8" name="TextBox 7"/>
+              <a:t>Positive, weak, and not yet decisive on two minutes of film.</a:t>
+            </a:r>
+          </a:p>
+        </p:txBody>
+      </p:sp>
+      <p:sp>
+        <p:nvSpPr>
+          <p:cNvPr id="9" name="TextBox 8"/>
           <p:cNvSpPr txBox="1"/>
           <p:nvPr/>
         </p:nvSpPr>
@@ -9366,14 +9349,14 @@
                 </a:solidFill>
                 <a:latin typeface="Calibri"/>
               </a:rPr>
-              <a:t>Schaefer et al. (2018); Algonauts 2025 (CC0); audit self-published, Sapient (2026).</a:t>
-            </a:r>
-          </a:p>
-        </p:txBody>
-      </p:sp>
-      <p:sp>
-        <p:nvSpPr>
-          <p:cNvPr id="9" name="TextBox 8"/>
+              <a:t>Algonauts 2025; Schaefer et al. (2018); audit: The Sapient Company (2026).</a:t>
+            </a:r>
+          </a:p>
+        </p:txBody>
+      </p:sp>
+      <p:sp>
+        <p:nvSpPr>
+          <p:cNvPr id="10" name="TextBox 9"/>
           <p:cNvSpPr txBox="1"/>
           <p:nvPr/>
         </p:nvSpPr>
@@ -9412,7 +9395,7 @@
       </p:sp>
       <p:sp>
         <p:nvSpPr>
-          <p:cNvPr id="10" name="TextBox 9"/>
+          <p:cNvPr id="11" name="TextBox 10"/>
           <p:cNvSpPr txBox="1"/>
           <p:nvPr/>
         </p:nvSpPr>
@@ -9675,7 +9658,7 @@
                 </a:solidFill>
                 <a:latin typeface="Calibri"/>
               </a:rPr>
-              <a:t>•  A measured noise ceiling for the checkpoint on public data.</a:t>
+              <a:t>•  A noise ceiling on public fMRI, and a first check of the encoder against it.</a:t>
             </a:r>
           </a:p>
         </p:txBody>
@@ -10165,7 +10148,7 @@
                 </a:solidFill>
                 <a:latin typeface="Calibri"/>
               </a:rPr>
-              <a:t>15 pp</a:t>
+              <a:t>16 pp</a:t>
             </a:r>
           </a:p>
           <a:p>
@@ -10236,7 +10219,7 @@
                 </a:solidFill>
                 <a:latin typeface="Calibri"/>
               </a:rPr>
-              <a:t>6 pp</a:t>
+              <a:t>8 pp</a:t>
             </a:r>
           </a:p>
           <a:p>
@@ -10268,7 +10251,7 @@
                 </a:solidFill>
                 <a:latin typeface="Calibri"/>
               </a:rPr>
-              <a:t>The measured ceiling and the replication. Imaging Neuroscience. One computation on its final run.</a:t>
+              <a:t>The noise ceiling and a check of the encoder against real brains. Imaging Neuroscience.</a:t>
             </a:r>
           </a:p>
         </p:txBody>
@@ -10660,7 +10643,7 @@
                 </a:solidFill>
                 <a:latin typeface="Calibri"/>
               </a:rPr>
-              <a:t>The instrument's own validity is now a measurable question. </a:t>
+              <a:t>The encoder is weakly positive against real brains, not anti-correlated. </a:t>
             </a:r>
             <a:r>
               <a:rPr sz="1800" b="0">
@@ -10669,7 +10652,7 @@
                 </a:solidFill>
                 <a:latin typeface="Calibri"/>
               </a:rPr>
-              <a:t>The noise ceiling is 0.1517; one prediction pass remains.</a:t>
+              <a:t>r = +0.028 against a ceiling of 0.096 on the same scans; not yet decisive.</a:t>
             </a:r>
           </a:p>
         </p:txBody>
@@ -10900,8 +10883,8 @@
         </p:nvSpPr>
         <p:spPr>
           <a:xfrm>
-            <a:off x="685800" y="1417320"/>
-            <a:ext cx="10820095" cy="4572000"/>
+            <a:off x="685800" y="1325880"/>
+            <a:ext cx="10820095" cy="4754880"/>
           </a:xfrm>
           <a:prstGeom prst="rect">
             <a:avLst/>
@@ -10916,11 +10899,11 @@
           <a:p>
             <a:pPr algn="l">
               <a:spcAft>
-                <a:spcPts val="1000"/>
-              </a:spcAft>
-            </a:pPr>
-            <a:r>
-              <a:rPr sz="1400" b="0" i="0">
+                <a:spcPts val="600"/>
+              </a:spcAft>
+            </a:pPr>
+            <a:r>
+              <a:rPr sz="1300" b="0" i="0">
                 <a:solidFill>
                   <a:srgbClr val="1A1A1A"/>
                 </a:solidFill>
@@ -10932,11 +10915,11 @@
           <a:p>
             <a:pPr>
               <a:spcAft>
-                <a:spcPts val="1000"/>
-              </a:spcAft>
-            </a:pPr>
-            <a:r>
-              <a:rPr sz="1400" b="0" i="0">
+                <a:spcPts val="600"/>
+              </a:spcAft>
+            </a:pPr>
+            <a:r>
+              <a:rPr sz="1300" b="0" i="0">
                 <a:solidFill>
                   <a:srgbClr val="1A1A1A"/>
                 </a:solidFill>
@@ -10948,43 +10931,75 @@
           <a:p>
             <a:pPr>
               <a:spcAft>
-                <a:spcPts val="1000"/>
-              </a:spcAft>
-            </a:pPr>
-            <a:r>
-              <a:rPr sz="1400" b="0" i="0">
+                <a:spcPts val="600"/>
+              </a:spcAft>
+            </a:pPr>
+            <a:r>
+              <a:rPr sz="1300" b="0" i="0">
                 <a:solidFill>
                   <a:srgbClr val="1A1A1A"/>
                 </a:solidFill>
                 <a:latin typeface="Calibri"/>
               </a:rPr>
+              <a:t>Gifford, A. T. et al. (2025). The Algonauts Project 2025 Challenge. arXiv:2501.00504.</a:t>
+            </a:r>
+          </a:p>
+          <a:p>
+            <a:pPr>
+              <a:spcAft>
+                <a:spcPts val="600"/>
+              </a:spcAft>
+            </a:pPr>
+            <a:r>
+              <a:rPr sz="1300" b="0" i="0">
+                <a:solidFill>
+                  <a:srgbClr val="1A1A1A"/>
+                </a:solidFill>
+                <a:latin typeface="Calibri"/>
+              </a:rPr>
               <a:t>Glasser, M. F. et al. (2016). A multi-modal parcellation of human cerebral cortex. Nature 536, 171–178.</a:t>
             </a:r>
           </a:p>
           <a:p>
             <a:pPr>
               <a:spcAft>
-                <a:spcPts val="1000"/>
-              </a:spcAft>
-            </a:pPr>
-            <a:r>
-              <a:rPr sz="1400" b="0" i="0">
+                <a:spcPts val="600"/>
+              </a:spcAft>
+            </a:pPr>
+            <a:r>
+              <a:rPr sz="1300" b="0" i="0">
                 <a:solidFill>
                   <a:srgbClr val="1A1A1A"/>
                 </a:solidFill>
                 <a:latin typeface="Calibri"/>
               </a:rPr>
+              <a:t>Hutto, C. J., Gilbert, E. (2014). VADER: a parsimonious rule-based model for sentiment analysis of social media text. ICWSM.</a:t>
+            </a:r>
+          </a:p>
+          <a:p>
+            <a:pPr>
+              <a:spcAft>
+                <a:spcPts val="600"/>
+              </a:spcAft>
+            </a:pPr>
+            <a:r>
+              <a:rPr sz="1300" b="0" i="0">
+                <a:solidFill>
+                  <a:srgbClr val="1A1A1A"/>
+                </a:solidFill>
+                <a:latin typeface="Calibri"/>
+              </a:rPr>
               <a:t>Kiesel, J. et al. (2019). SemEval-2019 Task 4: hyperpartisan news detection. SemEval.</a:t>
             </a:r>
           </a:p>
           <a:p>
             <a:pPr>
               <a:spcAft>
-                <a:spcPts val="1000"/>
-              </a:spcAft>
-            </a:pPr>
-            <a:r>
-              <a:rPr sz="1400" b="0" i="0">
+                <a:spcPts val="600"/>
+              </a:spcAft>
+            </a:pPr>
+            <a:r>
+              <a:rPr sz="1300" b="0" i="0">
                 <a:solidFill>
                   <a:srgbClr val="1A1A1A"/>
                 </a:solidFill>
@@ -10996,49 +11011,49 @@
           <a:p>
             <a:pPr>
               <a:spcAft>
-                <a:spcPts val="1000"/>
-              </a:spcAft>
-            </a:pPr>
-            <a:r>
-              <a:rPr sz="1400" b="0" i="0">
+                <a:spcPts val="600"/>
+              </a:spcAft>
+            </a:pPr>
+            <a:r>
+              <a:rPr sz="1300" b="0" i="0">
                 <a:solidFill>
                   <a:srgbClr val="1A1A1A"/>
                 </a:solidFill>
                 <a:latin typeface="Calibri"/>
               </a:rPr>
-              <a:t>Potthast, M. et al. (2018). The Webis clickbait challenge 2017. ECIR.</a:t>
+              <a:t>Potthast, M. et al. (2018). Crowdsourcing a large corpus of clickbait on Twitter. COLING, 1498–1507.</a:t>
             </a:r>
           </a:p>
           <a:p>
             <a:pPr>
               <a:spcAft>
-                <a:spcPts val="1000"/>
-              </a:spcAft>
-            </a:pPr>
-            <a:r>
-              <a:rPr sz="1400" b="0" i="0">
+                <a:spcPts val="600"/>
+              </a:spcAft>
+            </a:pPr>
+            <a:r>
+              <a:rPr sz="1300" b="0" i="0">
                 <a:solidFill>
                   <a:srgbClr val="1A1A1A"/>
                 </a:solidFill>
                 <a:latin typeface="Calibri"/>
               </a:rPr>
+              <a:t>The Sapient Company (2026). The Faceless Brain. Self-published technical report.</a:t>
+            </a:r>
+          </a:p>
+          <a:p>
+            <a:pPr>
+              <a:spcAft>
+                <a:spcPts val="600"/>
+              </a:spcAft>
+            </a:pPr>
+            <a:r>
+              <a:rPr sz="1300" b="0" i="0">
+                <a:solidFill>
+                  <a:srgbClr val="1A1A1A"/>
+                </a:solidFill>
+                <a:latin typeface="Calibri"/>
+              </a:rPr>
               <a:t>Schaefer, A. et al. (2018). Local-global parcellation of the human cerebral cortex. Cereb. Cortex 28, 3095–3114.</a:t>
-            </a:r>
-          </a:p>
-          <a:p>
-            <a:pPr>
-              <a:spcAft>
-                <a:spcPts val="1000"/>
-              </a:spcAft>
-            </a:pPr>
-            <a:r>
-              <a:rPr sz="1400" b="0" i="0">
-                <a:solidFill>
-                  <a:srgbClr val="1A1A1A"/>
-                </a:solidFill>
-                <a:latin typeface="Calibri"/>
-              </a:rPr>
-              <a:t>The Algonauts Project 2025 Challenge. arXiv:2501.00504.</a:t>
             </a:r>
           </a:p>
         </p:txBody>

</xml_diff>